<commit_message>
Add a "Your week" slide to the deck for the shift picker, rest days and the full-week Forecast
The deck had no Schedule or Forecast screenshots, so nothing in it showed
how a week is set up or read day by day.

New slide 5, after Set up: the Schedule (Monday to Saturday set, Sunday a
rest day) beside the Weekly Forecast (Monday to Sunday strip), with the
picker's Confirm, copying a shift to chosen days, and what a rest day is:
not leave, so the week keeps its 40 hours. Speaker notes included.

Also brought up to date:
- Set up and Try it use the reshot first-open screenshot. On a fresh phone
  with no shifts, Saturday is now a rest day, so it shows 0.00h still needed.
- Trial: 384 automated tests passing (was 330).
- Try it: "questions on email or Teams", matching the email.

Co-Authored-By: Claude Opus 5 <noreply@anthropic.com>
</commit_message>
<xml_diff>
--- a/docs/presentation/CTAP-Tracker.pptx
+++ b/docs/presentation/CTAP-Tracker.pptx
@@ -9,6 +9,7 @@
     <p:sldId id="257" r:id="rId3"/>
     <p:sldId id="258" r:id="rId4"/>
     <p:sldId id="259" r:id="rId5"/>
+    <p:sldId id="266" r:id="rId17"/>
     <p:sldId id="260" r:id="rId6"/>
     <p:sldId id="261" r:id="rId7"/>
     <p:sldId id="262" r:id="rId8"/>
@@ -632,6 +633,94 @@
     <p:extLst>
       <p:ext uri="{BB962C8B-B14F-4D97-AF65-F5344CB8AC3E}">
         <p14:creationId xmlns:p14="http://schemas.microsoft.com/office/powerpoint/2010/main" val="1024086991"/>
+      </p:ext>
+    </p:extLst>
+  </p:cSld>
+  <p:clrMapOvr>
+    <a:masterClrMapping/>
+  </p:clrMapOvr>
+</p:notes>
+</file>
+
+<file path=ppt/notesSlides/notesSlide11.xml><?xml version="1.0" encoding="utf-8"?>
+<p:notes xmlns:a="http://schemas.openxmlformats.org/drawingml/2006/main" xmlns:r="http://schemas.openxmlformats.org/officeDocument/2006/relationships" xmlns:p="http://schemas.openxmlformats.org/presentationml/2006/main">
+  <p:cSld>
+    <p:spTree>
+      <p:nvGrpSpPr>
+        <p:cNvPr id="1" name=""/>
+        <p:cNvGrpSpPr/>
+        <p:nvPr/>
+      </p:nvGrpSpPr>
+      <p:grpSpPr>
+        <a:xfrm>
+          <a:off x="0" y="0"/>
+          <a:ext cx="0" cy="0"/>
+          <a:chOff x="0" y="0"/>
+          <a:chExt cx="0" cy="0"/>
+        </a:xfrm>
+      </p:grpSpPr>
+      <p:sp>
+        <p:nvSpPr>
+          <p:cNvPr id="2" name="Slide Image Placeholder 1"/>
+          <p:cNvSpPr>
+            <a:spLocks noGrp="1" noRot="1" noChangeAspect="1"/>
+          </p:cNvSpPr>
+          <p:nvPr>
+            <p:ph type="sldImg"/>
+          </p:nvPr>
+        </p:nvSpPr>
+        <p:spPr/>
+      </p:sp>
+      <p:sp>
+        <p:nvSpPr>
+          <p:cNvPr id="3" name="Notes Placeholder 2"/>
+          <p:cNvSpPr>
+            <a:spLocks noGrp="1"/>
+          </p:cNvSpPr>
+          <p:nvPr>
+            <p:ph type="body" idx="1"/>
+          </p:nvPr>
+        </p:nvSpPr>
+        <p:spPr/>
+        <p:txBody>
+          <a:bodyPr/>
+          <a:lstStyle/>
+          <a:p>
+            <a:r>
+              <a:rPr lang="en-GB" dirty="0"/>
+              <a:t>New since the first version of this deck. Shift times are set in a picker with a Confirm, because the iPhone time wheel used to close after the first scroll. An engineer on a rota can copy a shift to exactly the days they work. A day with no times is a rest day: it isn't leave, so the week keeps its 40 hours, and nobody has to mark it, because it's read from the Schedule.</a:t>
+            </a:r>
+            <a:endParaRPr lang="en-GB" dirty="0"/>
+          </a:p>
+        </p:txBody>
+      </p:sp>
+      <p:sp>
+        <p:nvSpPr>
+          <p:cNvPr id="4" name="Slide Number Placeholder 3"/>
+          <p:cNvSpPr>
+            <a:spLocks noGrp="1"/>
+          </p:cNvSpPr>
+          <p:nvPr>
+            <p:ph type="sldNum" sz="quarter" idx="10"/>
+          </p:nvPr>
+        </p:nvSpPr>
+        <p:spPr/>
+        <p:txBody>
+          <a:bodyPr/>
+          <a:lstStyle/>
+          <a:p>
+            <a:fld id="{F7021451-1387-4CA6-816F-3879F97B5CBC}" type="slidenum">
+              <a:rPr lang="en-GB"/>
+              <a:t>5</a:t>
+            </a:fld>
+            <a:endParaRPr lang="en-GB"/>
+          </a:p>
+        </p:txBody>
+      </p:sp>
+    </p:spTree>
+    <p:extLst>
+      <p:ext uri="{BB962C8B-B14F-4D97-AF65-F5344CB8AC3E}">
+        <p14:creationId xmlns:p14="http://schemas.microsoft.com/office/powerpoint/2010/main" val="2091734615"/>
       </p:ext>
     </p:extLst>
   </p:cSld>
@@ -2111,7 +2200,7 @@
                 <a:ea typeface="Calibri" pitchFamily="34" charset="-122"/>
                 <a:cs typeface="Calibri" pitchFamily="34" charset="-120"/>
               </a:rPr>
-              <a:t>Jake Rainford  ·  Service &amp; Repair Engineer  ·  questions on Teams</a:t>
+              <a:t>Jake Rainford  ·  Service &amp; Repair Engineer  ·  questions on email or Teams</a:t>
             </a:r>
             <a:endParaRPr lang="en-US" sz="1300" dirty="0"/>
           </a:p>
@@ -2211,6 +2300,543 @@
           <a:xfrm>
             <a:off x="9052560" y="822960"/>
             <a:ext cx="2408426" cy="5212080"/>
+          </a:xfrm>
+          <a:prstGeom prst="rect">
+            <a:avLst/>
+          </a:prstGeom>
+        </p:spPr>
+      </p:pic>
+    </p:spTree>
+  </p:cSld>
+  <p:clrMapOvr>
+    <a:masterClrMapping/>
+  </p:clrMapOvr>
+</p:sld>
+</file>
+
+<file path=ppt/slides/slide11.xml><?xml version="1.0" encoding="utf-8"?>
+<p:sld xmlns:a="http://schemas.openxmlformats.org/drawingml/2006/main" xmlns:r="http://schemas.openxmlformats.org/officeDocument/2006/relationships" xmlns:p="http://schemas.openxmlformats.org/presentationml/2006/main">
+  <p:cSld name="Slide 5">
+    <p:bg>
+      <p:bgPr>
+        <a:solidFill>
+          <a:srgbClr val="0B0D12"/>
+        </a:solidFill>
+        <a:effectLst/>
+      </p:bgPr>
+    </p:bg>
+    <p:spTree>
+      <p:nvGrpSpPr>
+        <p:cNvPr id="1" name=""/>
+        <p:cNvGrpSpPr/>
+        <p:nvPr/>
+      </p:nvGrpSpPr>
+      <p:grpSpPr>
+        <a:xfrm>
+          <a:off x="0" y="0"/>
+          <a:ext cx="0" cy="0"/>
+          <a:chOff x="0" y="0"/>
+          <a:chExt cx="0" cy="0"/>
+        </a:xfrm>
+      </p:grpSpPr>
+      <p:sp>
+        <p:nvSpPr>
+          <p:cNvPr id="2" name="Text 0"/>
+          <p:cNvSpPr txBox="1"/>
+          <p:nvPr/>
+        </p:nvSpPr>
+        <p:spPr>
+          <a:xfrm>
+            <a:off x="6583680" y="566928"/>
+            <a:ext cx="5151120" cy="237744"/>
+          </a:xfrm>
+          <a:prstGeom prst="rect">
+            <a:avLst/>
+          </a:prstGeom>
+          <a:noFill/>
+          <a:ln/>
+        </p:spPr>
+        <p:txBody>
+          <a:bodyPr wrap="square" lIns="0" tIns="0" rIns="0" bIns="0" rtlCol="0" anchor="ctr"/>
+          <a:lstStyle/>
+          <a:p>
+            <a:pPr indent="0" marL="0">
+              <a:buNone/>
+            </a:pPr>
+            <a:r>
+              <a:rPr lang="en-GB" sz="1100" b="1" spc="240" kern="0" dirty="0">
+                <a:solidFill>
+                  <a:srgbClr val="4A86D8"/>
+                </a:solidFill>
+                <a:latin typeface="Arial" pitchFamily="34" charset="0"/>
+                <a:ea typeface="Arial" pitchFamily="34" charset="-122"/>
+                <a:cs typeface="Arial" pitchFamily="34" charset="-120"/>
+              </a:rPr>
+              <a:t>YOUR WEEK</a:t>
+            </a:r>
+            <a:endParaRPr lang="en-GB" sz="1100" dirty="0"/>
+          </a:p>
+        </p:txBody>
+      </p:sp>
+      <p:sp>
+        <p:nvSpPr>
+          <p:cNvPr id="3" name="Text 1"/>
+          <p:cNvSpPr txBox="1"/>
+          <p:nvPr/>
+        </p:nvSpPr>
+        <p:spPr>
+          <a:xfrm>
+            <a:off x="6583680" y="877824"/>
+            <a:ext cx="5151120" cy="1280160"/>
+          </a:xfrm>
+          <a:prstGeom prst="rect">
+            <a:avLst/>
+          </a:prstGeom>
+          <a:noFill/>
+          <a:ln/>
+        </p:spPr>
+        <p:txBody>
+          <a:bodyPr wrap="square" lIns="0" tIns="0" rIns="0" bIns="0" rtlCol="0" anchor="ctr"/>
+          <a:lstStyle/>
+          <a:p>
+            <a:pPr indent="0" marL="0">
+              <a:lnSpc>
+                <a:spcPts val="3800"/>
+              </a:lnSpc>
+              <a:buNone/>
+            </a:pPr>
+            <a:r>
+              <a:rPr lang="en-GB" sz="3000" b="1" dirty="0">
+                <a:solidFill>
+                  <a:srgbClr val="F2F5FA"/>
+                </a:solidFill>
+                <a:latin typeface="Arial" pitchFamily="34" charset="0"/>
+                <a:ea typeface="Arial" pitchFamily="34" charset="-122"/>
+                <a:cs typeface="Arial" pitchFamily="34" charset="-120"/>
+              </a:rPr>
+              <a:t>Set the week you work,</a:t>
+            </a:r>
+            <a:endParaRPr lang="en-GB" sz="3000" dirty="0"/>
+          </a:p>
+          <a:p>
+            <a:pPr indent="0" marL="0">
+              <a:lnSpc>
+                <a:spcPts val="3800"/>
+              </a:lnSpc>
+              <a:buNone/>
+            </a:pPr>
+            <a:r>
+              <a:rPr lang="en-GB" sz="3000" b="1" dirty="0">
+                <a:solidFill>
+                  <a:srgbClr val="F2F5FA"/>
+                </a:solidFill>
+                <a:latin typeface="Arial" pitchFamily="34" charset="0"/>
+                <a:ea typeface="Arial" pitchFamily="34" charset="-122"/>
+                <a:cs typeface="Arial" pitchFamily="34" charset="-120"/>
+              </a:rPr>
+              <a:t>then see all of it.</a:t>
+            </a:r>
+            <a:endParaRPr lang="en-GB" sz="3000" dirty="0"/>
+          </a:p>
+        </p:txBody>
+      </p:sp>
+      <p:sp>
+        <p:nvSpPr>
+          <p:cNvPr id="4" name="Shape 2"/>
+          <p:cNvSpPr/>
+          <p:nvPr/>
+        </p:nvSpPr>
+        <p:spPr>
+          <a:xfrm>
+            <a:off x="6583680" y="2459736"/>
+            <a:ext cx="173736" cy="173736"/>
+          </a:xfrm>
+          <a:prstGeom prst="ellipse">
+            <a:avLst/>
+          </a:prstGeom>
+          <a:solidFill>
+            <a:srgbClr val="4A86D8"/>
+          </a:solidFill>
+          <a:ln w="12700">
+            <a:solidFill>
+              <a:srgbClr val="4A86D8"/>
+            </a:solidFill>
+            <a:prstDash val="solid"/>
+          </a:ln>
+        </p:spPr>
+      </p:sp>
+      <p:sp>
+        <p:nvSpPr>
+          <p:cNvPr id="5" name="Text 3"/>
+          <p:cNvSpPr txBox="1"/>
+          <p:nvPr/>
+        </p:nvSpPr>
+        <p:spPr>
+          <a:xfrm>
+            <a:off x="6949440" y="2395728"/>
+            <a:ext cx="4785360" cy="310896"/>
+          </a:xfrm>
+          <a:prstGeom prst="rect">
+            <a:avLst/>
+          </a:prstGeom>
+          <a:noFill/>
+          <a:ln/>
+        </p:spPr>
+        <p:txBody>
+          <a:bodyPr wrap="square" lIns="0" tIns="0" rIns="0" bIns="0" rtlCol="0" anchor="ctr"/>
+          <a:lstStyle/>
+          <a:p>
+            <a:pPr indent="0" marL="0">
+              <a:buNone/>
+            </a:pPr>
+            <a:r>
+              <a:rPr lang="en-GB" sz="1500" dirty="0">
+                <a:solidFill>
+                  <a:srgbClr val="A8B2C4"/>
+                </a:solidFill>
+                <a:latin typeface="Calibri" pitchFamily="34" charset="0"/>
+                <a:ea typeface="Calibri" pitchFamily="34" charset="-122"/>
+                <a:cs typeface="Calibri" pitchFamily="34" charset="-120"/>
+              </a:rPr>
+              <a:t>Tap a day's times, set them, Confirm</a:t>
+            </a:r>
+            <a:endParaRPr lang="en-GB" sz="1500" dirty="0"/>
+          </a:p>
+        </p:txBody>
+      </p:sp>
+      <p:sp>
+        <p:nvSpPr>
+          <p:cNvPr id="6" name="Shape 4"/>
+          <p:cNvSpPr/>
+          <p:nvPr/>
+        </p:nvSpPr>
+        <p:spPr>
+          <a:xfrm>
+            <a:off x="6583680" y="2916936"/>
+            <a:ext cx="173736" cy="173736"/>
+          </a:xfrm>
+          <a:prstGeom prst="ellipse">
+            <a:avLst/>
+          </a:prstGeom>
+          <a:solidFill>
+            <a:srgbClr val="4A86D8"/>
+          </a:solidFill>
+          <a:ln w="12700">
+            <a:solidFill>
+              <a:srgbClr val="4A86D8"/>
+            </a:solidFill>
+            <a:prstDash val="solid"/>
+          </a:ln>
+        </p:spPr>
+      </p:sp>
+      <p:sp>
+        <p:nvSpPr>
+          <p:cNvPr id="7" name="Text 5"/>
+          <p:cNvSpPr txBox="1"/>
+          <p:nvPr/>
+        </p:nvSpPr>
+        <p:spPr>
+          <a:xfrm>
+            <a:off x="6949440" y="2852928"/>
+            <a:ext cx="4785360" cy="310896"/>
+          </a:xfrm>
+          <a:prstGeom prst="rect">
+            <a:avLst/>
+          </a:prstGeom>
+          <a:noFill/>
+          <a:ln/>
+        </p:spPr>
+        <p:txBody>
+          <a:bodyPr wrap="square" lIns="0" tIns="0" rIns="0" bIns="0" rtlCol="0" anchor="ctr"/>
+          <a:lstStyle/>
+          <a:p>
+            <a:pPr indent="0" marL="0">
+              <a:buNone/>
+            </a:pPr>
+            <a:r>
+              <a:rPr lang="en-GB" sz="1500" dirty="0">
+                <a:solidFill>
+                  <a:srgbClr val="A8B2C4"/>
+                </a:solidFill>
+                <a:latin typeface="Calibri" pitchFamily="34" charset="0"/>
+                <a:ea typeface="Calibri" pitchFamily="34" charset="-122"/>
+                <a:cs typeface="Calibri" pitchFamily="34" charset="-120"/>
+              </a:rPr>
+              <a:t>Copy a shift to any days you choose</a:t>
+            </a:r>
+            <a:endParaRPr lang="en-GB" sz="1500" dirty="0"/>
+          </a:p>
+        </p:txBody>
+      </p:sp>
+      <p:sp>
+        <p:nvSpPr>
+          <p:cNvPr id="8" name="Shape 6"/>
+          <p:cNvSpPr/>
+          <p:nvPr/>
+        </p:nvSpPr>
+        <p:spPr>
+          <a:xfrm>
+            <a:off x="6583680" y="3374136"/>
+            <a:ext cx="173736" cy="173736"/>
+          </a:xfrm>
+          <a:prstGeom prst="ellipse">
+            <a:avLst/>
+          </a:prstGeom>
+          <a:solidFill>
+            <a:srgbClr val="4A86D8"/>
+          </a:solidFill>
+          <a:ln w="12700">
+            <a:solidFill>
+              <a:srgbClr val="4A86D8"/>
+            </a:solidFill>
+            <a:prstDash val="solid"/>
+          </a:ln>
+        </p:spPr>
+      </p:sp>
+      <p:sp>
+        <p:nvSpPr>
+          <p:cNvPr id="9" name="Text 7"/>
+          <p:cNvSpPr txBox="1"/>
+          <p:nvPr/>
+        </p:nvSpPr>
+        <p:spPr>
+          <a:xfrm>
+            <a:off x="6949440" y="3310128"/>
+            <a:ext cx="4785360" cy="310896"/>
+          </a:xfrm>
+          <a:prstGeom prst="rect">
+            <a:avLst/>
+          </a:prstGeom>
+          <a:noFill/>
+          <a:ln/>
+        </p:spPr>
+        <p:txBody>
+          <a:bodyPr wrap="square" lIns="0" tIns="0" rIns="0" bIns="0" rtlCol="0" anchor="ctr"/>
+          <a:lstStyle/>
+          <a:p>
+            <a:pPr indent="0" marL="0">
+              <a:buNone/>
+            </a:pPr>
+            <a:r>
+              <a:rPr lang="en-GB" sz="1500" dirty="0">
+                <a:solidFill>
+                  <a:srgbClr val="A8B2C4"/>
+                </a:solidFill>
+                <a:latin typeface="Calibri" pitchFamily="34" charset="0"/>
+                <a:ea typeface="Calibri" pitchFamily="34" charset="-122"/>
+                <a:cs typeface="Calibri" pitchFamily="34" charset="-120"/>
+              </a:rPr>
+              <a:t>No times means a rest day, not leave</a:t>
+            </a:r>
+            <a:endParaRPr lang="en-GB" sz="1500" dirty="0"/>
+          </a:p>
+        </p:txBody>
+      </p:sp>
+      <p:sp>
+        <p:nvSpPr>
+          <p:cNvPr id="10" name="Text 8"/>
+          <p:cNvSpPr txBox="1"/>
+          <p:nvPr/>
+        </p:nvSpPr>
+        <p:spPr>
+          <a:xfrm>
+            <a:off x="6583680" y="3977640"/>
+            <a:ext cx="5151120" cy="1005840"/>
+          </a:xfrm>
+          <a:prstGeom prst="rect">
+            <a:avLst/>
+          </a:prstGeom>
+          <a:noFill/>
+          <a:ln/>
+        </p:spPr>
+        <p:txBody>
+          <a:bodyPr wrap="square" lIns="0" tIns="0" rIns="0" bIns="0" rtlCol="0" anchor="t"/>
+          <a:lstStyle/>
+          <a:p>
+            <a:pPr indent="0" marL="0">
+              <a:lnSpc>
+                <a:spcPts val="2100"/>
+              </a:lnSpc>
+              <a:buNone/>
+            </a:pPr>
+            <a:r>
+              <a:rPr lang="en-GB" sz="1400" dirty="0">
+                <a:solidFill>
+                  <a:srgbClr val="A8B2C4"/>
+                </a:solidFill>
+                <a:latin typeface="Calibri" pitchFamily="34" charset="0"/>
+                <a:ea typeface="Calibri" pitchFamily="34" charset="-122"/>
+                <a:cs typeface="Calibri" pitchFamily="34" charset="-120"/>
+              </a:rPr>
+              <a:t>The Weekly Forecast runs Monday to Sunday and opens on today. Days left counts only the days you're working, so a Friday off doesn't spread the target over an extra day.</a:t>
+            </a:r>
+            <a:endParaRPr lang="en-GB" sz="1400" dirty="0"/>
+          </a:p>
+        </p:txBody>
+      </p:sp>
+      <p:sp>
+        <p:nvSpPr>
+          <p:cNvPr id="11" name="Text 9"/>
+          <p:cNvSpPr txBox="1"/>
+          <p:nvPr/>
+        </p:nvSpPr>
+        <p:spPr>
+          <a:xfrm>
+            <a:off x="6583680" y="5029200"/>
+            <a:ext cx="5151120" cy="822960"/>
+          </a:xfrm>
+          <a:prstGeom prst="rect">
+            <a:avLst/>
+          </a:prstGeom>
+          <a:noFill/>
+          <a:ln/>
+        </p:spPr>
+        <p:txBody>
+          <a:bodyPr wrap="square" lIns="0" tIns="0" rIns="0" bIns="0" rtlCol="0" anchor="ctr"/>
+          <a:lstStyle/>
+          <a:p>
+            <a:pPr indent="0" marL="0">
+              <a:lnSpc>
+                <a:spcPts val="2100"/>
+              </a:lnSpc>
+              <a:buNone/>
+            </a:pPr>
+            <a:r>
+              <a:rPr lang="en-GB" sz="1400" b="1" dirty="0">
+                <a:solidFill>
+                  <a:srgbClr val="F2F5FA"/>
+                </a:solidFill>
+                <a:latin typeface="Calibri" pitchFamily="34" charset="0"/>
+                <a:ea typeface="Calibri" pitchFamily="34" charset="-122"/>
+                <a:cs typeface="Calibri" pitchFamily="34" charset="-120"/>
+              </a:rPr>
+              <a:t xml:space="preserve">A rest day keeps your 40 hours. </a:t>
+            </a:r>
+            <a:r>
+              <a:rPr lang="en-GB" sz="1400" dirty="0">
+                <a:solidFill>
+                  <a:srgbClr val="A8B2C4"/>
+                </a:solidFill>
+                <a:latin typeface="Calibri" pitchFamily="34" charset="0"/>
+                <a:ea typeface="Calibri" pitchFamily="34" charset="-122"/>
+                <a:cs typeface="Calibri" pitchFamily="34" charset="-120"/>
+              </a:rPr>
+              <a:t>It just isn't a day you're expected to earn on, unlike leave, which takes that day's hours off the week.</a:t>
+            </a:r>
+            <a:endParaRPr lang="en-GB" sz="1400" dirty="0"/>
+          </a:p>
+        </p:txBody>
+      </p:sp>
+      <p:sp>
+        <p:nvSpPr>
+          <p:cNvPr id="12" name="Shape 10"/>
+          <p:cNvSpPr/>
+          <p:nvPr/>
+        </p:nvSpPr>
+        <p:spPr>
+          <a:xfrm>
+            <a:off x="457200" y="589788"/>
+            <a:ext cx="2714598" cy="5715000"/>
+          </a:xfrm>
+          <a:prstGeom prst="roundRect">
+            <a:avLst>
+              <a:gd name="adj" fmla="val 7411"/>
+            </a:avLst>
+          </a:prstGeom>
+          <a:solidFill>
+            <a:srgbClr val="1E2533"/>
+          </a:solidFill>
+          <a:ln w="12700">
+            <a:solidFill>
+              <a:srgbClr val="1E2533"/>
+            </a:solidFill>
+            <a:prstDash val="solid"/>
+          </a:ln>
+          <a:effectLst>
+            <a:outerShdw sx="100000" sy="100000" kx="0" ky="0" algn="bl" rotWithShape="0" blurRad="228600" dist="50800" dir="5400000">
+              <a:srgbClr val="000000">
+                <a:alpha val="45000"/>
+              </a:srgbClr>
+            </a:outerShdw>
+          </a:effectLst>
+        </p:spPr>
+      </p:sp>
+      <p:pic>
+        <p:nvPicPr>
+          <p:cNvPr id="13" name="Image 0" descr="Schedule: Monday to Saturday 08:00 to 16:30, Sunday shown as a rest day"/>
+          <p:cNvPicPr>
+            <a:picLocks noChangeAspect="1"/>
+          </p:cNvPicPr>
+          <p:nvPr/>
+        </p:nvPicPr>
+        <p:blipFill>
+          <a:blip r:embed="rId1"/>
+          <a:stretch>
+            <a:fillRect/>
+          </a:stretch>
+        </p:blipFill>
+        <p:spPr>
+          <a:xfrm>
+            <a:off x="525780" y="658368"/>
+            <a:ext cx="2577438" cy="5577840"/>
+          </a:xfrm>
+          <a:prstGeom prst="rect">
+            <a:avLst/>
+          </a:prstGeom>
+        </p:spPr>
+      </p:pic>
+      <p:sp>
+        <p:nvSpPr>
+          <p:cNvPr id="14" name="Shape 11"/>
+          <p:cNvSpPr/>
+          <p:nvPr/>
+        </p:nvSpPr>
+        <p:spPr>
+          <a:xfrm>
+            <a:off x="3446118" y="589788"/>
+            <a:ext cx="2714598" cy="5715000"/>
+          </a:xfrm>
+          <a:prstGeom prst="roundRect">
+            <a:avLst>
+              <a:gd name="adj" fmla="val 7411"/>
+            </a:avLst>
+          </a:prstGeom>
+          <a:solidFill>
+            <a:srgbClr val="1E2533"/>
+          </a:solidFill>
+          <a:ln w="12700">
+            <a:solidFill>
+              <a:srgbClr val="1E2533"/>
+            </a:solidFill>
+            <a:prstDash val="solid"/>
+          </a:ln>
+          <a:effectLst>
+            <a:outerShdw sx="100000" sy="100000" kx="0" ky="0" algn="bl" rotWithShape="0" blurRad="228600" dist="50800" dir="5400000">
+              <a:srgbClr val="000000">
+                <a:alpha val="45000"/>
+              </a:srgbClr>
+            </a:outerShdw>
+          </a:effectLst>
+        </p:spPr>
+      </p:sp>
+      <p:pic>
+        <p:nvPicPr>
+          <p:cNvPr id="15" name="Image 1" descr="Weekly Forecast: a Monday to Sunday day strip open on Saturday, with the week's totals"/>
+          <p:cNvPicPr>
+            <a:picLocks noChangeAspect="1"/>
+          </p:cNvPicPr>
+          <p:nvPr/>
+        </p:nvPicPr>
+        <p:blipFill>
+          <a:blip r:embed="rId4"/>
+          <a:stretch>
+            <a:fillRect/>
+          </a:stretch>
+        </p:blipFill>
+        <p:spPr>
+          <a:xfrm>
+            <a:off x="3514698" y="658368"/>
+            <a:ext cx="2577438" cy="5577840"/>
           </a:xfrm>
           <a:prstGeom prst="rect">
             <a:avLst/>
@@ -7150,7 +7776,7 @@
                 <a:ea typeface="Arial" pitchFamily="34" charset="-122"/>
                 <a:cs typeface="Arial" pitchFamily="34" charset="-120"/>
               </a:rPr>
-              <a:t>330</a:t>
+              <a:t>384</a:t>
             </a:r>
             <a:endParaRPr lang="en-US" sz="3800" dirty="0"/>
           </a:p>

</xml_diff>

<commit_message>
Put the deck in light mode, without the drop shadows that showed as grey boxes
The dark deck had dark grey squares all over it. Its cards, tiles and phone
frames were slate fills on a near-black ground, and 19 blurred drop shadows
sat under them, which some viewers flatten into solid grey boxes.

The deck is now white with dark text, pale grey cards (the app's own light
ground, so the Coach and check-in crops blend into them), light phone
frames, and darker green, amber and red that still read on white. Every
shadow is gone. All screenshots are the app's light theme, from the same
pinned demo state, so every figure is unchanged.

Co-Authored-By: Claude Opus 5 <noreply@anthropic.com>
</commit_message>
<xml_diff>
--- a/docs/presentation/CTAP-Tracker.pptx
+++ b/docs/presentation/CTAP-Tracker.pptx
@@ -1747,7 +1747,7 @@
     <p:bg>
       <p:bgPr>
         <a:solidFill>
-          <a:srgbClr val="0B0D12"/>
+          <a:srgbClr val="FFFFFF"/>
         </a:solidFill>
       </p:bgPr>
     </p:bg>
@@ -1792,7 +1792,7 @@
             <a:r>
               <a:rPr lang="en-US" sz="7200" b="1" spc="-150" kern="0" dirty="0">
                 <a:solidFill>
-                  <a:srgbClr val="F2F5FA"/>
+                  <a:srgbClr val="0F1522"/>
                 </a:solidFill>
                 <a:latin typeface="Arial" pitchFamily="34" charset="0"/>
                 <a:ea typeface="Arial" pitchFamily="34" charset="-122"/>
@@ -1831,7 +1831,7 @@
             <a:r>
               <a:rPr lang="en-US" sz="7200" b="1" spc="-150" kern="0" dirty="0">
                 <a:solidFill>
-                  <a:srgbClr val="4A86D8"/>
+                  <a:srgbClr val="2F6BC4"/>
                 </a:solidFill>
                 <a:latin typeface="Arial" pitchFamily="34" charset="0"/>
                 <a:ea typeface="Arial" pitchFamily="34" charset="-122"/>
@@ -1870,7 +1870,7 @@
             <a:r>
               <a:rPr lang="en-US" sz="1800" dirty="0">
                 <a:solidFill>
-                  <a:srgbClr val="A8B2C4"/>
+                  <a:srgbClr val="4B5565"/>
                 </a:solidFill>
                 <a:latin typeface="Calibri" pitchFamily="34" charset="0"/>
                 <a:ea typeface="Calibri" pitchFamily="34" charset="-122"/>
@@ -1909,7 +1909,7 @@
             <a:r>
               <a:rPr lang="en-US" sz="1100" spc="180" kern="0" dirty="0">
                 <a:solidFill>
-                  <a:srgbClr val="758091"/>
+                  <a:srgbClr val="6B7485"/>
                 </a:solidFill>
                 <a:latin typeface="Arial" pitchFamily="34" charset="0"/>
                 <a:ea typeface="Arial" pitchFamily="34" charset="-122"/>
@@ -1938,21 +1938,14 @@
             </a:avLst>
           </a:prstGeom>
           <a:solidFill>
-            <a:srgbClr val="1E2533"/>
+            <a:srgbClr val="DDE3EC"/>
           </a:solidFill>
           <a:ln w="12700">
             <a:solidFill>
-              <a:srgbClr val="1E2533"/>
+              <a:srgbClr val="DDE3EC"/>
             </a:solidFill>
             <a:prstDash val="solid"/>
           </a:ln>
-          <a:effectLst>
-            <a:outerShdw sx="100000" sy="100000" kx="0" ky="0" algn="bl" rotWithShape="0" blurRad="228600" dist="50800" dir="5400000">
-              <a:srgbClr val="000000">
-                <a:alpha val="45000"/>
-              </a:srgbClr>
-            </a:outerShdw>
-          </a:effectLst>
         </p:spPr>
       </p:sp>
       <p:pic>
@@ -1993,7 +1986,7 @@
     <p:bg>
       <p:bgPr>
         <a:solidFill>
-          <a:srgbClr val="0B0D12"/>
+          <a:srgbClr val="FFFFFF"/>
         </a:solidFill>
       </p:bgPr>
     </p:bg>
@@ -2038,7 +2031,7 @@
             <a:r>
               <a:rPr lang="en-US" sz="5400" b="1" dirty="0">
                 <a:solidFill>
-                  <a:srgbClr val="F2F5FA"/>
+                  <a:srgbClr val="0F1522"/>
                 </a:solidFill>
                 <a:latin typeface="Arial" pitchFamily="34" charset="0"/>
                 <a:ea typeface="Arial" pitchFamily="34" charset="-122"/>
@@ -2077,7 +2070,7 @@
             <a:r>
               <a:rPr lang="en-US" sz="2100" dirty="0">
                 <a:solidFill>
-                  <a:srgbClr val="4A86D8"/>
+                  <a:srgbClr val="2F6BC4"/>
                 </a:solidFill>
                 <a:latin typeface="Arial" pitchFamily="34" charset="0"/>
                 <a:ea typeface="Arial" pitchFamily="34" charset="-122"/>
@@ -2116,7 +2109,7 @@
             <a:r>
               <a:rPr lang="en-US" sz="1600" dirty="0">
                 <a:solidFill>
-                  <a:srgbClr val="A8B2C4"/>
+                  <a:srgbClr val="4B5565"/>
                 </a:solidFill>
                 <a:latin typeface="Calibri" pitchFamily="34" charset="0"/>
                 <a:ea typeface="Calibri" pitchFamily="34" charset="-122"/>
@@ -2155,7 +2148,7 @@
             <a:r>
               <a:rPr lang="en-US" sz="1400" i="1" dirty="0">
                 <a:solidFill>
-                  <a:srgbClr val="758091"/>
+                  <a:srgbClr val="6B7485"/>
                 </a:solidFill>
                 <a:latin typeface="Calibri" pitchFamily="34" charset="0"/>
                 <a:ea typeface="Calibri" pitchFamily="34" charset="-122"/>
@@ -2194,7 +2187,7 @@
             <a:r>
               <a:rPr lang="en-US" sz="1300" dirty="0">
                 <a:solidFill>
-                  <a:srgbClr val="758091"/>
+                  <a:srgbClr val="6B7485"/>
                 </a:solidFill>
                 <a:latin typeface="Calibri" pitchFamily="34" charset="0"/>
                 <a:ea typeface="Calibri" pitchFamily="34" charset="-122"/>
@@ -2236,7 +2229,7 @@
             <a:r>
               <a:rPr lang="en-US" sz="1050" dirty="0">
                 <a:solidFill>
-                  <a:srgbClr val="758091"/>
+                  <a:srgbClr val="6B7485"/>
                 </a:solidFill>
                 <a:latin typeface="Calibri" pitchFamily="34" charset="0"/>
                 <a:ea typeface="Calibri" pitchFamily="34" charset="-122"/>
@@ -2265,21 +2258,14 @@
             </a:avLst>
           </a:prstGeom>
           <a:solidFill>
-            <a:srgbClr val="1E2533"/>
+            <a:srgbClr val="DDE3EC"/>
           </a:solidFill>
           <a:ln w="12700">
             <a:solidFill>
-              <a:srgbClr val="1E2533"/>
+              <a:srgbClr val="DDE3EC"/>
             </a:solidFill>
             <a:prstDash val="solid"/>
           </a:ln>
-          <a:effectLst>
-            <a:outerShdw sx="100000" sy="100000" kx="0" ky="0" algn="bl" rotWithShape="0" blurRad="228600" dist="50800" dir="5400000">
-              <a:srgbClr val="000000">
-                <a:alpha val="45000"/>
-              </a:srgbClr>
-            </a:outerShdw>
-          </a:effectLst>
         </p:spPr>
       </p:sp>
       <p:pic>
@@ -2320,7 +2306,7 @@
     <p:bg>
       <p:bgPr>
         <a:solidFill>
-          <a:srgbClr val="0B0D12"/>
+          <a:srgbClr val="FFFFFF"/>
         </a:solidFill>
         <a:effectLst/>
       </p:bgPr>
@@ -2366,7 +2352,7 @@
             <a:r>
               <a:rPr lang="en-GB" sz="1100" b="1" spc="240" kern="0" dirty="0">
                 <a:solidFill>
-                  <a:srgbClr val="4A86D8"/>
+                  <a:srgbClr val="2F6BC4"/>
                 </a:solidFill>
                 <a:latin typeface="Arial" pitchFamily="34" charset="0"/>
                 <a:ea typeface="Arial" pitchFamily="34" charset="-122"/>
@@ -2408,7 +2394,7 @@
             <a:r>
               <a:rPr lang="en-GB" sz="3000" b="1" dirty="0">
                 <a:solidFill>
-                  <a:srgbClr val="F2F5FA"/>
+                  <a:srgbClr val="0F1522"/>
                 </a:solidFill>
                 <a:latin typeface="Arial" pitchFamily="34" charset="0"/>
                 <a:ea typeface="Arial" pitchFamily="34" charset="-122"/>
@@ -2428,7 +2414,7 @@
             <a:r>
               <a:rPr lang="en-GB" sz="3000" b="1" dirty="0">
                 <a:solidFill>
-                  <a:srgbClr val="F2F5FA"/>
+                  <a:srgbClr val="0F1522"/>
                 </a:solidFill>
                 <a:latin typeface="Arial" pitchFamily="34" charset="0"/>
                 <a:ea typeface="Arial" pitchFamily="34" charset="-122"/>
@@ -2455,11 +2441,11 @@
             <a:avLst/>
           </a:prstGeom>
           <a:solidFill>
-            <a:srgbClr val="4A86D8"/>
+            <a:srgbClr val="2F6BC4"/>
           </a:solidFill>
           <a:ln w="12700">
             <a:solidFill>
-              <a:srgbClr val="4A86D8"/>
+              <a:srgbClr val="2F6BC4"/>
             </a:solidFill>
             <a:prstDash val="solid"/>
           </a:ln>
@@ -2492,7 +2478,7 @@
             <a:r>
               <a:rPr lang="en-GB" sz="1500" dirty="0">
                 <a:solidFill>
-                  <a:srgbClr val="A8B2C4"/>
+                  <a:srgbClr val="4B5565"/>
                 </a:solidFill>
                 <a:latin typeface="Calibri" pitchFamily="34" charset="0"/>
                 <a:ea typeface="Calibri" pitchFamily="34" charset="-122"/>
@@ -2519,11 +2505,11 @@
             <a:avLst/>
           </a:prstGeom>
           <a:solidFill>
-            <a:srgbClr val="4A86D8"/>
+            <a:srgbClr val="2F6BC4"/>
           </a:solidFill>
           <a:ln w="12700">
             <a:solidFill>
-              <a:srgbClr val="4A86D8"/>
+              <a:srgbClr val="2F6BC4"/>
             </a:solidFill>
             <a:prstDash val="solid"/>
           </a:ln>
@@ -2556,7 +2542,7 @@
             <a:r>
               <a:rPr lang="en-GB" sz="1500" dirty="0">
                 <a:solidFill>
-                  <a:srgbClr val="A8B2C4"/>
+                  <a:srgbClr val="4B5565"/>
                 </a:solidFill>
                 <a:latin typeface="Calibri" pitchFamily="34" charset="0"/>
                 <a:ea typeface="Calibri" pitchFamily="34" charset="-122"/>
@@ -2583,11 +2569,11 @@
             <a:avLst/>
           </a:prstGeom>
           <a:solidFill>
-            <a:srgbClr val="4A86D8"/>
+            <a:srgbClr val="2F6BC4"/>
           </a:solidFill>
           <a:ln w="12700">
             <a:solidFill>
-              <a:srgbClr val="4A86D8"/>
+              <a:srgbClr val="2F6BC4"/>
             </a:solidFill>
             <a:prstDash val="solid"/>
           </a:ln>
@@ -2620,7 +2606,7 @@
             <a:r>
               <a:rPr lang="en-GB" sz="1500" dirty="0">
                 <a:solidFill>
-                  <a:srgbClr val="A8B2C4"/>
+                  <a:srgbClr val="4B5565"/>
                 </a:solidFill>
                 <a:latin typeface="Calibri" pitchFamily="34" charset="0"/>
                 <a:ea typeface="Calibri" pitchFamily="34" charset="-122"/>
@@ -2662,7 +2648,7 @@
             <a:r>
               <a:rPr lang="en-GB" sz="1400" dirty="0">
                 <a:solidFill>
-                  <a:srgbClr val="A8B2C4"/>
+                  <a:srgbClr val="4B5565"/>
                 </a:solidFill>
                 <a:latin typeface="Calibri" pitchFamily="34" charset="0"/>
                 <a:ea typeface="Calibri" pitchFamily="34" charset="-122"/>
@@ -2704,7 +2690,7 @@
             <a:r>
               <a:rPr lang="en-GB" sz="1400" b="1" dirty="0">
                 <a:solidFill>
-                  <a:srgbClr val="F2F5FA"/>
+                  <a:srgbClr val="0F1522"/>
                 </a:solidFill>
                 <a:latin typeface="Calibri" pitchFamily="34" charset="0"/>
                 <a:ea typeface="Calibri" pitchFamily="34" charset="-122"/>
@@ -2715,7 +2701,7 @@
             <a:r>
               <a:rPr lang="en-GB" sz="1400" dirty="0">
                 <a:solidFill>
-                  <a:srgbClr val="A8B2C4"/>
+                  <a:srgbClr val="4B5565"/>
                 </a:solidFill>
                 <a:latin typeface="Calibri" pitchFamily="34" charset="0"/>
                 <a:ea typeface="Calibri" pitchFamily="34" charset="-122"/>
@@ -2744,21 +2730,14 @@
             </a:avLst>
           </a:prstGeom>
           <a:solidFill>
-            <a:srgbClr val="1E2533"/>
+            <a:srgbClr val="DDE3EC"/>
           </a:solidFill>
           <a:ln w="12700">
             <a:solidFill>
-              <a:srgbClr val="1E2533"/>
+              <a:srgbClr val="DDE3EC"/>
             </a:solidFill>
             <a:prstDash val="solid"/>
           </a:ln>
-          <a:effectLst>
-            <a:outerShdw sx="100000" sy="100000" kx="0" ky="0" algn="bl" rotWithShape="0" blurRad="228600" dist="50800" dir="5400000">
-              <a:srgbClr val="000000">
-                <a:alpha val="45000"/>
-              </a:srgbClr>
-            </a:outerShdw>
-          </a:effectLst>
         </p:spPr>
       </p:sp>
       <p:pic>
@@ -2802,21 +2781,14 @@
             </a:avLst>
           </a:prstGeom>
           <a:solidFill>
-            <a:srgbClr val="1E2533"/>
+            <a:srgbClr val="DDE3EC"/>
           </a:solidFill>
           <a:ln w="12700">
             <a:solidFill>
-              <a:srgbClr val="1E2533"/>
+              <a:srgbClr val="DDE3EC"/>
             </a:solidFill>
             <a:prstDash val="solid"/>
           </a:ln>
-          <a:effectLst>
-            <a:outerShdw sx="100000" sy="100000" kx="0" ky="0" algn="bl" rotWithShape="0" blurRad="228600" dist="50800" dir="5400000">
-              <a:srgbClr val="000000">
-                <a:alpha val="45000"/>
-              </a:srgbClr>
-            </a:outerShdw>
-          </a:effectLst>
         </p:spPr>
       </p:sp>
       <p:pic>
@@ -2857,7 +2829,7 @@
     <p:bg>
       <p:bgPr>
         <a:solidFill>
-          <a:srgbClr val="0B0D12"/>
+          <a:srgbClr val="FFFFFF"/>
         </a:solidFill>
       </p:bgPr>
     </p:bg>
@@ -2902,7 +2874,7 @@
             <a:r>
               <a:rPr lang="en-US" sz="1100" b="1" spc="240" kern="0" dirty="0">
                 <a:solidFill>
-                  <a:srgbClr val="4A86D8"/>
+                  <a:srgbClr val="2F6BC4"/>
                 </a:solidFill>
                 <a:latin typeface="Arial" pitchFamily="34" charset="0"/>
                 <a:ea typeface="Arial" pitchFamily="34" charset="-122"/>
@@ -2944,7 +2916,7 @@
             <a:r>
               <a:rPr lang="en-US" sz="3800" b="1" dirty="0">
                 <a:solidFill>
-                  <a:srgbClr val="F2F5FA"/>
+                  <a:srgbClr val="0F1522"/>
                 </a:solidFill>
                 <a:latin typeface="Arial" pitchFamily="34" charset="0"/>
                 <a:ea typeface="Arial" pitchFamily="34" charset="-122"/>
@@ -2964,7 +2936,7 @@
             <a:r>
               <a:rPr lang="en-US" sz="3800" b="1" dirty="0">
                 <a:solidFill>
-                  <a:srgbClr val="F2F5FA"/>
+                  <a:srgbClr val="0F1522"/>
                 </a:solidFill>
                 <a:latin typeface="Arial" pitchFamily="34" charset="0"/>
                 <a:ea typeface="Arial" pitchFamily="34" charset="-122"/>
@@ -2993,21 +2965,14 @@
             </a:avLst>
           </a:prstGeom>
           <a:solidFill>
-            <a:srgbClr val="161B26"/>
+            <a:srgbClr val="F2F2F7"/>
           </a:solidFill>
           <a:ln w="12700">
             <a:solidFill>
-              <a:srgbClr val="1E2533"/>
+              <a:srgbClr val="DDE3EC"/>
             </a:solidFill>
             <a:prstDash val="solid"/>
           </a:ln>
-          <a:effectLst>
-            <a:outerShdw sx="100000" sy="100000" kx="0" ky="0" algn="bl" rotWithShape="0" blurRad="228600" dist="50800" dir="5400000">
-              <a:srgbClr val="000000">
-                <a:alpha val="45000"/>
-              </a:srgbClr>
-            </a:outerShdw>
-          </a:effectLst>
         </p:spPr>
       </p:sp>
       <p:sp>
@@ -3037,7 +3002,7 @@
             <a:r>
               <a:rPr lang="en-US" sz="5000" b="1" dirty="0">
                 <a:solidFill>
-                  <a:srgbClr val="4A86D8"/>
+                  <a:srgbClr val="2F6BC4"/>
                 </a:solidFill>
                 <a:latin typeface="Arial" pitchFamily="34" charset="0"/>
                 <a:ea typeface="Arial" pitchFamily="34" charset="-122"/>
@@ -3076,7 +3041,7 @@
             <a:r>
               <a:rPr lang="en-US" sz="1000" spc="160" kern="0" dirty="0">
                 <a:solidFill>
-                  <a:srgbClr val="758091"/>
+                  <a:srgbClr val="6B7485"/>
                 </a:solidFill>
                 <a:latin typeface="Arial" pitchFamily="34" charset="0"/>
                 <a:ea typeface="Arial" pitchFamily="34" charset="-122"/>
@@ -3115,7 +3080,7 @@
             <a:r>
               <a:rPr lang="en-US" sz="1600" b="1" dirty="0">
                 <a:solidFill>
-                  <a:srgbClr val="F2F5FA"/>
+                  <a:srgbClr val="0F1522"/>
                 </a:solidFill>
                 <a:latin typeface="Arial" pitchFamily="34" charset="0"/>
                 <a:ea typeface="Arial" pitchFamily="34" charset="-122"/>
@@ -3157,7 +3122,7 @@
             <a:r>
               <a:rPr lang="en-US" sz="1300" dirty="0">
                 <a:solidFill>
-                  <a:srgbClr val="A8B2C4"/>
+                  <a:srgbClr val="4B5565"/>
                 </a:solidFill>
                 <a:latin typeface="Calibri" pitchFamily="34" charset="0"/>
                 <a:ea typeface="Calibri" pitchFamily="34" charset="-122"/>
@@ -3186,21 +3151,14 @@
             </a:avLst>
           </a:prstGeom>
           <a:solidFill>
-            <a:srgbClr val="161B26"/>
+            <a:srgbClr val="F2F2F7"/>
           </a:solidFill>
           <a:ln w="12700">
             <a:solidFill>
-              <a:srgbClr val="1E2533"/>
+              <a:srgbClr val="DDE3EC"/>
             </a:solidFill>
             <a:prstDash val="solid"/>
           </a:ln>
-          <a:effectLst>
-            <a:outerShdw sx="100000" sy="100000" kx="0" ky="0" algn="bl" rotWithShape="0" blurRad="228600" dist="50800" dir="5400000">
-              <a:srgbClr val="000000">
-                <a:alpha val="45000"/>
-              </a:srgbClr>
-            </a:outerShdw>
-          </a:effectLst>
         </p:spPr>
       </p:sp>
       <p:sp>
@@ -3230,7 +3188,7 @@
             <a:r>
               <a:rPr lang="en-US" sz="5000" b="1" dirty="0">
                 <a:solidFill>
-                  <a:srgbClr val="4A86D8"/>
+                  <a:srgbClr val="2F6BC4"/>
                 </a:solidFill>
                 <a:latin typeface="Arial" pitchFamily="34" charset="0"/>
                 <a:ea typeface="Arial" pitchFamily="34" charset="-122"/>
@@ -3269,7 +3227,7 @@
             <a:r>
               <a:rPr lang="en-US" sz="1000" spc="160" kern="0" dirty="0">
                 <a:solidFill>
-                  <a:srgbClr val="758091"/>
+                  <a:srgbClr val="6B7485"/>
                 </a:solidFill>
                 <a:latin typeface="Arial" pitchFamily="34" charset="0"/>
                 <a:ea typeface="Arial" pitchFamily="34" charset="-122"/>
@@ -3308,7 +3266,7 @@
             <a:r>
               <a:rPr lang="en-US" sz="1600" b="1" dirty="0">
                 <a:solidFill>
-                  <a:srgbClr val="F2F5FA"/>
+                  <a:srgbClr val="0F1522"/>
                 </a:solidFill>
                 <a:latin typeface="Arial" pitchFamily="34" charset="0"/>
                 <a:ea typeface="Arial" pitchFamily="34" charset="-122"/>
@@ -3350,7 +3308,7 @@
             <a:r>
               <a:rPr lang="en-US" sz="1300" dirty="0">
                 <a:solidFill>
-                  <a:srgbClr val="A8B2C4"/>
+                  <a:srgbClr val="4B5565"/>
                 </a:solidFill>
                 <a:latin typeface="Calibri" pitchFamily="34" charset="0"/>
                 <a:ea typeface="Calibri" pitchFamily="34" charset="-122"/>
@@ -3379,21 +3337,14 @@
             </a:avLst>
           </a:prstGeom>
           <a:solidFill>
-            <a:srgbClr val="161B26"/>
+            <a:srgbClr val="F2F2F7"/>
           </a:solidFill>
           <a:ln w="12700">
             <a:solidFill>
-              <a:srgbClr val="1E2533"/>
+              <a:srgbClr val="DDE3EC"/>
             </a:solidFill>
             <a:prstDash val="solid"/>
           </a:ln>
-          <a:effectLst>
-            <a:outerShdw sx="100000" sy="100000" kx="0" ky="0" algn="bl" rotWithShape="0" blurRad="228600" dist="50800" dir="5400000">
-              <a:srgbClr val="000000">
-                <a:alpha val="45000"/>
-              </a:srgbClr>
-            </a:outerShdw>
-          </a:effectLst>
         </p:spPr>
       </p:sp>
       <p:sp>
@@ -3423,7 +3374,7 @@
             <a:r>
               <a:rPr lang="en-US" sz="5000" b="1" dirty="0">
                 <a:solidFill>
-                  <a:srgbClr val="4A86D8"/>
+                  <a:srgbClr val="2F6BC4"/>
                 </a:solidFill>
                 <a:latin typeface="Arial" pitchFamily="34" charset="0"/>
                 <a:ea typeface="Arial" pitchFamily="34" charset="-122"/>
@@ -3462,7 +3413,7 @@
             <a:r>
               <a:rPr lang="en-US" sz="1000" spc="160" kern="0" dirty="0">
                 <a:solidFill>
-                  <a:srgbClr val="758091"/>
+                  <a:srgbClr val="6B7485"/>
                 </a:solidFill>
                 <a:latin typeface="Arial" pitchFamily="34" charset="0"/>
                 <a:ea typeface="Arial" pitchFamily="34" charset="-122"/>
@@ -3501,7 +3452,7 @@
             <a:r>
               <a:rPr lang="en-US" sz="1600" b="1" dirty="0">
                 <a:solidFill>
-                  <a:srgbClr val="F2F5FA"/>
+                  <a:srgbClr val="0F1522"/>
                 </a:solidFill>
                 <a:latin typeface="Arial" pitchFamily="34" charset="0"/>
                 <a:ea typeface="Arial" pitchFamily="34" charset="-122"/>
@@ -3543,7 +3494,7 @@
             <a:r>
               <a:rPr lang="en-US" sz="1300" dirty="0">
                 <a:solidFill>
-                  <a:srgbClr val="A8B2C4"/>
+                  <a:srgbClr val="4B5565"/>
                 </a:solidFill>
                 <a:latin typeface="Calibri" pitchFamily="34" charset="0"/>
                 <a:ea typeface="Calibri" pitchFamily="34" charset="-122"/>
@@ -3569,7 +3520,7 @@
     <p:bg>
       <p:bgPr>
         <a:solidFill>
-          <a:srgbClr val="0B0D12"/>
+          <a:srgbClr val="FFFFFF"/>
         </a:solidFill>
       </p:bgPr>
     </p:bg>
@@ -3614,7 +3565,7 @@
             <a:r>
               <a:rPr lang="en-US" sz="1100" b="1" spc="240" kern="0" dirty="0">
                 <a:solidFill>
-                  <a:srgbClr val="4A86D8"/>
+                  <a:srgbClr val="2F6BC4"/>
                 </a:solidFill>
                 <a:latin typeface="Arial" pitchFamily="34" charset="0"/>
                 <a:ea typeface="Arial" pitchFamily="34" charset="-122"/>
@@ -3656,7 +3607,7 @@
             <a:r>
               <a:rPr lang="en-US" sz="3200" b="1" dirty="0">
                 <a:solidFill>
-                  <a:srgbClr val="F2F5FA"/>
+                  <a:srgbClr val="0F1522"/>
                 </a:solidFill>
                 <a:latin typeface="Arial" pitchFamily="34" charset="0"/>
                 <a:ea typeface="Arial" pitchFamily="34" charset="-122"/>
@@ -3676,7 +3627,7 @@
             <a:r>
               <a:rPr lang="en-US" sz="3200" b="1" dirty="0">
                 <a:solidFill>
-                  <a:srgbClr val="F2F5FA"/>
+                  <a:srgbClr val="0F1522"/>
                 </a:solidFill>
                 <a:latin typeface="Arial" pitchFamily="34" charset="0"/>
                 <a:ea typeface="Arial" pitchFamily="34" charset="-122"/>
@@ -3703,11 +3654,11 @@
             <a:avLst/>
           </a:prstGeom>
           <a:solidFill>
-            <a:srgbClr val="4A86D8"/>
+            <a:srgbClr val="2F6BC4"/>
           </a:solidFill>
           <a:ln w="12700">
             <a:solidFill>
-              <a:srgbClr val="4A86D8"/>
+              <a:srgbClr val="2F6BC4"/>
             </a:solidFill>
             <a:prstDash val="solid"/>
           </a:ln>
@@ -3743,7 +3694,7 @@
             <a:r>
               <a:rPr lang="en-US" sz="1800" i="1" dirty="0">
                 <a:solidFill>
-                  <a:srgbClr val="F2F5FA"/>
+                  <a:srgbClr val="0F1522"/>
                 </a:solidFill>
                 <a:latin typeface="Calibri" pitchFamily="34" charset="0"/>
                 <a:ea typeface="Calibri" pitchFamily="34" charset="-122"/>
@@ -3785,7 +3736,7 @@
             <a:r>
               <a:rPr lang="en-US" sz="1250" dirty="0">
                 <a:solidFill>
-                  <a:srgbClr val="758091"/>
+                  <a:srgbClr val="6B7485"/>
                 </a:solidFill>
                 <a:latin typeface="Calibri" pitchFamily="34" charset="0"/>
                 <a:ea typeface="Calibri" pitchFamily="34" charset="-122"/>
@@ -3812,11 +3763,11 @@
             <a:avLst/>
           </a:prstGeom>
           <a:solidFill>
-            <a:srgbClr val="4A86D8"/>
+            <a:srgbClr val="2F6BC4"/>
           </a:solidFill>
           <a:ln w="12700">
             <a:solidFill>
-              <a:srgbClr val="4A86D8"/>
+              <a:srgbClr val="2F6BC4"/>
             </a:solidFill>
             <a:prstDash val="solid"/>
           </a:ln>
@@ -3852,7 +3803,7 @@
             <a:r>
               <a:rPr lang="en-US" sz="1800" i="1" dirty="0">
                 <a:solidFill>
-                  <a:srgbClr val="F2F5FA"/>
+                  <a:srgbClr val="0F1522"/>
                 </a:solidFill>
                 <a:latin typeface="Calibri" pitchFamily="34" charset="0"/>
                 <a:ea typeface="Calibri" pitchFamily="34" charset="-122"/>
@@ -3872,7 +3823,7 @@
             <a:r>
               <a:rPr lang="en-US" sz="1800" i="1" dirty="0">
                 <a:solidFill>
-                  <a:srgbClr val="F2F5FA"/>
+                  <a:srgbClr val="0F1522"/>
                 </a:solidFill>
                 <a:latin typeface="Calibri" pitchFamily="34" charset="0"/>
                 <a:ea typeface="Calibri" pitchFamily="34" charset="-122"/>
@@ -3914,7 +3865,7 @@
             <a:r>
               <a:rPr lang="en-US" sz="1250" dirty="0">
                 <a:solidFill>
-                  <a:srgbClr val="758091"/>
+                  <a:srgbClr val="6B7485"/>
                 </a:solidFill>
                 <a:latin typeface="Calibri" pitchFamily="34" charset="0"/>
                 <a:ea typeface="Calibri" pitchFamily="34" charset="-122"/>
@@ -3943,11 +3894,11 @@
             </a:avLst>
           </a:prstGeom>
           <a:solidFill>
-            <a:srgbClr val="161B26"/>
+            <a:srgbClr val="F2F2F7"/>
           </a:solidFill>
           <a:ln w="12700">
             <a:solidFill>
-              <a:srgbClr val="1E2533"/>
+              <a:srgbClr val="DDE3EC"/>
             </a:solidFill>
             <a:prstDash val="solid"/>
           </a:ln>
@@ -3983,7 +3934,7 @@
             <a:r>
               <a:rPr lang="en-US" sz="1400" b="1" dirty="0">
                 <a:solidFill>
-                  <a:srgbClr val="F2F5FA"/>
+                  <a:srgbClr val="0F1522"/>
                 </a:solidFill>
                 <a:latin typeface="Calibri" pitchFamily="34" charset="0"/>
                 <a:ea typeface="Calibri" pitchFamily="34" charset="-122"/>
@@ -4000,7 +3951,7 @@
             <a:r>
               <a:rPr lang="en-US" sz="1400" dirty="0">
                 <a:solidFill>
-                  <a:srgbClr val="A8B2C4"/>
+                  <a:srgbClr val="4B5565"/>
                 </a:solidFill>
                 <a:latin typeface="Calibri" pitchFamily="34" charset="0"/>
                 <a:ea typeface="Calibri" pitchFamily="34" charset="-122"/>
@@ -4029,21 +3980,14 @@
             </a:avLst>
           </a:prstGeom>
           <a:solidFill>
-            <a:srgbClr val="1E2533"/>
+            <a:srgbClr val="DDE3EC"/>
           </a:solidFill>
           <a:ln w="12700">
             <a:solidFill>
-              <a:srgbClr val="1E2533"/>
+              <a:srgbClr val="DDE3EC"/>
             </a:solidFill>
             <a:prstDash val="solid"/>
           </a:ln>
-          <a:effectLst>
-            <a:outerShdw sx="100000" sy="100000" kx="0" ky="0" algn="bl" rotWithShape="0" blurRad="228600" dist="50800" dir="5400000">
-              <a:srgbClr val="000000">
-                <a:alpha val="45000"/>
-              </a:srgbClr>
-            </a:outerShdw>
-          </a:effectLst>
         </p:spPr>
       </p:sp>
       <p:pic>
@@ -4084,7 +4028,7 @@
     <p:bg>
       <p:bgPr>
         <a:solidFill>
-          <a:srgbClr val="0B0D12"/>
+          <a:srgbClr val="FFFFFF"/>
         </a:solidFill>
       </p:bgPr>
     </p:bg>
@@ -4129,7 +4073,7 @@
             <a:r>
               <a:rPr lang="en-US" sz="1100" b="1" spc="240" kern="0" dirty="0">
                 <a:solidFill>
-                  <a:srgbClr val="4A86D8"/>
+                  <a:srgbClr val="2F6BC4"/>
                 </a:solidFill>
                 <a:latin typeface="Arial" pitchFamily="34" charset="0"/>
                 <a:ea typeface="Arial" pitchFamily="34" charset="-122"/>
@@ -4171,7 +4115,7 @@
             <a:r>
               <a:rPr lang="en-US" sz="3000" b="1" dirty="0">
                 <a:solidFill>
-                  <a:srgbClr val="F2F5FA"/>
+                  <a:srgbClr val="0F1522"/>
                 </a:solidFill>
                 <a:latin typeface="Arial" pitchFamily="34" charset="0"/>
                 <a:ea typeface="Arial" pitchFamily="34" charset="-122"/>
@@ -4191,7 +4135,7 @@
             <a:r>
               <a:rPr lang="en-US" sz="3000" b="1" dirty="0">
                 <a:solidFill>
-                  <a:srgbClr val="F2F5FA"/>
+                  <a:srgbClr val="0F1522"/>
                 </a:solidFill>
                 <a:latin typeface="Arial" pitchFamily="34" charset="0"/>
                 <a:ea typeface="Arial" pitchFamily="34" charset="-122"/>
@@ -4218,11 +4162,11 @@
             <a:avLst/>
           </a:prstGeom>
           <a:solidFill>
-            <a:srgbClr val="2F63A8"/>
+            <a:srgbClr val="2F6BC4"/>
           </a:solidFill>
           <a:ln w="12700">
             <a:solidFill>
-              <a:srgbClr val="2F63A8"/>
+              <a:srgbClr val="2F6BC4"/>
             </a:solidFill>
             <a:prstDash val="solid"/>
           </a:ln>
@@ -4255,7 +4199,7 @@
             <a:r>
               <a:rPr lang="en-US" sz="1300" b="1" dirty="0">
                 <a:solidFill>
-                  <a:srgbClr val="F2F5FA"/>
+                  <a:srgbClr val="0F1522"/>
                 </a:solidFill>
                 <a:latin typeface="Arial" pitchFamily="34" charset="0"/>
                 <a:ea typeface="Arial" pitchFamily="34" charset="-122"/>
@@ -4294,7 +4238,7 @@
             <a:r>
               <a:rPr lang="en-US" sz="1700" b="1" dirty="0">
                 <a:solidFill>
-                  <a:srgbClr val="F2F5FA"/>
+                  <a:srgbClr val="0F1522"/>
                 </a:solidFill>
                 <a:latin typeface="Arial" pitchFamily="34" charset="0"/>
                 <a:ea typeface="Arial" pitchFamily="34" charset="-122"/>
@@ -4336,7 +4280,7 @@
             <a:r>
               <a:rPr lang="en-US" sz="1350" dirty="0">
                 <a:solidFill>
-                  <a:srgbClr val="A8B2C4"/>
+                  <a:srgbClr val="4B5565"/>
                 </a:solidFill>
                 <a:latin typeface="Calibri" pitchFamily="34" charset="0"/>
                 <a:ea typeface="Calibri" pitchFamily="34" charset="-122"/>
@@ -4363,11 +4307,11 @@
             <a:avLst/>
           </a:prstGeom>
           <a:solidFill>
-            <a:srgbClr val="2F63A8"/>
+            <a:srgbClr val="2F6BC4"/>
           </a:solidFill>
           <a:ln w="12700">
             <a:solidFill>
-              <a:srgbClr val="2F63A8"/>
+              <a:srgbClr val="2F6BC4"/>
             </a:solidFill>
             <a:prstDash val="solid"/>
           </a:ln>
@@ -4400,7 +4344,7 @@
             <a:r>
               <a:rPr lang="en-US" sz="1300" b="1" dirty="0">
                 <a:solidFill>
-                  <a:srgbClr val="F2F5FA"/>
+                  <a:srgbClr val="0F1522"/>
                 </a:solidFill>
                 <a:latin typeface="Arial" pitchFamily="34" charset="0"/>
                 <a:ea typeface="Arial" pitchFamily="34" charset="-122"/>
@@ -4439,7 +4383,7 @@
             <a:r>
               <a:rPr lang="en-US" sz="1700" b="1" dirty="0">
                 <a:solidFill>
-                  <a:srgbClr val="F2F5FA"/>
+                  <a:srgbClr val="0F1522"/>
                 </a:solidFill>
                 <a:latin typeface="Arial" pitchFamily="34" charset="0"/>
                 <a:ea typeface="Arial" pitchFamily="34" charset="-122"/>
@@ -4481,7 +4425,7 @@
             <a:r>
               <a:rPr lang="en-US" sz="1350" dirty="0">
                 <a:solidFill>
-                  <a:srgbClr val="A8B2C4"/>
+                  <a:srgbClr val="4B5565"/>
                 </a:solidFill>
                 <a:latin typeface="Calibri" pitchFamily="34" charset="0"/>
                 <a:ea typeface="Calibri" pitchFamily="34" charset="-122"/>
@@ -4508,11 +4452,11 @@
             <a:avLst/>
           </a:prstGeom>
           <a:solidFill>
-            <a:srgbClr val="2F63A8"/>
+            <a:srgbClr val="2F6BC4"/>
           </a:solidFill>
           <a:ln w="12700">
             <a:solidFill>
-              <a:srgbClr val="2F63A8"/>
+              <a:srgbClr val="2F6BC4"/>
             </a:solidFill>
             <a:prstDash val="solid"/>
           </a:ln>
@@ -4545,7 +4489,7 @@
             <a:r>
               <a:rPr lang="en-US" sz="1300" b="1" dirty="0">
                 <a:solidFill>
-                  <a:srgbClr val="F2F5FA"/>
+                  <a:srgbClr val="0F1522"/>
                 </a:solidFill>
                 <a:latin typeface="Arial" pitchFamily="34" charset="0"/>
                 <a:ea typeface="Arial" pitchFamily="34" charset="-122"/>
@@ -4584,7 +4528,7 @@
             <a:r>
               <a:rPr lang="en-US" sz="1700" b="1" dirty="0">
                 <a:solidFill>
-                  <a:srgbClr val="F2F5FA"/>
+                  <a:srgbClr val="0F1522"/>
                 </a:solidFill>
                 <a:latin typeface="Arial" pitchFamily="34" charset="0"/>
                 <a:ea typeface="Arial" pitchFamily="34" charset="-122"/>
@@ -4626,7 +4570,7 @@
             <a:r>
               <a:rPr lang="en-US" sz="1350" dirty="0">
                 <a:solidFill>
-                  <a:srgbClr val="A8B2C4"/>
+                  <a:srgbClr val="4B5565"/>
                 </a:solidFill>
                 <a:latin typeface="Calibri" pitchFamily="34" charset="0"/>
                 <a:ea typeface="Calibri" pitchFamily="34" charset="-122"/>
@@ -4665,7 +4609,7 @@
             <a:r>
               <a:rPr lang="en-US" sz="1300" i="1" dirty="0">
                 <a:solidFill>
-                  <a:srgbClr val="758091"/>
+                  <a:srgbClr val="6B7485"/>
                 </a:solidFill>
                 <a:latin typeface="Calibri" pitchFamily="34" charset="0"/>
                 <a:ea typeface="Calibri" pitchFamily="34" charset="-122"/>
@@ -4694,21 +4638,14 @@
             </a:avLst>
           </a:prstGeom>
           <a:solidFill>
-            <a:srgbClr val="1E2533"/>
+            <a:srgbClr val="DDE3EC"/>
           </a:solidFill>
           <a:ln w="12700">
             <a:solidFill>
-              <a:srgbClr val="1E2533"/>
+              <a:srgbClr val="DDE3EC"/>
             </a:solidFill>
             <a:prstDash val="solid"/>
           </a:ln>
-          <a:effectLst>
-            <a:outerShdw sx="100000" sy="100000" kx="0" ky="0" algn="bl" rotWithShape="0" blurRad="228600" dist="50800" dir="5400000">
-              <a:srgbClr val="000000">
-                <a:alpha val="45000"/>
-              </a:srgbClr>
-            </a:outerShdw>
-          </a:effectLst>
         </p:spPr>
       </p:sp>
       <p:pic>
@@ -4749,7 +4686,7 @@
     <p:bg>
       <p:bgPr>
         <a:solidFill>
-          <a:srgbClr val="0B0D12"/>
+          <a:srgbClr val="FFFFFF"/>
         </a:solidFill>
       </p:bgPr>
     </p:bg>
@@ -4794,7 +4731,7 @@
             <a:r>
               <a:rPr lang="en-US" sz="1100" b="1" spc="240" kern="0" dirty="0">
                 <a:solidFill>
-                  <a:srgbClr val="4A86D8"/>
+                  <a:srgbClr val="2F6BC4"/>
                 </a:solidFill>
                 <a:latin typeface="Arial" pitchFamily="34" charset="0"/>
                 <a:ea typeface="Arial" pitchFamily="34" charset="-122"/>
@@ -4836,7 +4773,7 @@
             <a:r>
               <a:rPr lang="en-US" sz="3200" b="1" dirty="0">
                 <a:solidFill>
-                  <a:srgbClr val="F2F5FA"/>
+                  <a:srgbClr val="0F1522"/>
                 </a:solidFill>
                 <a:latin typeface="Arial" pitchFamily="34" charset="0"/>
                 <a:ea typeface="Arial" pitchFamily="34" charset="-122"/>
@@ -4856,7 +4793,7 @@
             <a:r>
               <a:rPr lang="en-US" sz="3200" b="1" dirty="0">
                 <a:solidFill>
-                  <a:srgbClr val="F2F5FA"/>
+                  <a:srgbClr val="0F1522"/>
                 </a:solidFill>
                 <a:latin typeface="Arial" pitchFamily="34" charset="0"/>
                 <a:ea typeface="Arial" pitchFamily="34" charset="-122"/>
@@ -4885,21 +4822,14 @@
             </a:avLst>
           </a:prstGeom>
           <a:solidFill>
-            <a:srgbClr val="161B26"/>
+            <a:srgbClr val="F2F2F7"/>
           </a:solidFill>
           <a:ln w="12700">
             <a:solidFill>
-              <a:srgbClr val="1E2533"/>
+              <a:srgbClr val="DDE3EC"/>
             </a:solidFill>
             <a:prstDash val="solid"/>
           </a:ln>
-          <a:effectLst>
-            <a:outerShdw sx="100000" sy="100000" kx="0" ky="0" algn="bl" rotWithShape="0" blurRad="228600" dist="50800" dir="5400000">
-              <a:srgbClr val="000000">
-                <a:alpha val="45000"/>
-              </a:srgbClr>
-            </a:outerShdw>
-          </a:effectLst>
         </p:spPr>
       </p:sp>
       <p:sp>
@@ -4929,7 +4859,7 @@
             <a:r>
               <a:rPr lang="en-US" sz="1000" spc="160" kern="0" dirty="0">
                 <a:solidFill>
-                  <a:srgbClr val="758091"/>
+                  <a:srgbClr val="6B7485"/>
                 </a:solidFill>
                 <a:latin typeface="Arial" pitchFamily="34" charset="0"/>
                 <a:ea typeface="Arial" pitchFamily="34" charset="-122"/>
@@ -4968,7 +4898,7 @@
             <a:r>
               <a:rPr lang="en-US" sz="1900" dirty="0">
                 <a:solidFill>
-                  <a:srgbClr val="F2F5FA"/>
+                  <a:srgbClr val="0F1522"/>
                 </a:solidFill>
                 <a:latin typeface="Arial" pitchFamily="34" charset="0"/>
                 <a:ea typeface="Arial" pitchFamily="34" charset="-122"/>
@@ -4982,7 +4912,7 @@
             <a:r>
               <a:rPr lang="en-US" sz="1900" dirty="0">
                 <a:solidFill>
-                  <a:srgbClr val="758091"/>
+                  <a:srgbClr val="6B7485"/>
                 </a:solidFill>
                 <a:latin typeface="Arial" pitchFamily="34" charset="0"/>
                 <a:ea typeface="Arial" pitchFamily="34" charset="-122"/>
@@ -4996,7 +4926,7 @@
             <a:r>
               <a:rPr lang="en-US" sz="1900" dirty="0">
                 <a:solidFill>
-                  <a:srgbClr val="F2F5FA"/>
+                  <a:srgbClr val="0F1522"/>
                 </a:solidFill>
                 <a:latin typeface="Arial" pitchFamily="34" charset="0"/>
                 <a:ea typeface="Arial" pitchFamily="34" charset="-122"/>
@@ -5010,7 +4940,7 @@
             <a:r>
               <a:rPr lang="en-US" sz="1900" dirty="0">
                 <a:solidFill>
-                  <a:srgbClr val="758091"/>
+                  <a:srgbClr val="6B7485"/>
                 </a:solidFill>
                 <a:latin typeface="Arial" pitchFamily="34" charset="0"/>
                 <a:ea typeface="Arial" pitchFamily="34" charset="-122"/>
@@ -5024,7 +4954,7 @@
             <a:r>
               <a:rPr lang="en-US" sz="1900" b="1" dirty="0">
                 <a:solidFill>
-                  <a:srgbClr val="4A86D8"/>
+                  <a:srgbClr val="2F6BC4"/>
                 </a:solidFill>
                 <a:latin typeface="Arial" pitchFamily="34" charset="0"/>
                 <a:ea typeface="Arial" pitchFamily="34" charset="-122"/>
@@ -5063,7 +4993,7 @@
             <a:r>
               <a:rPr lang="en-US" sz="1200" dirty="0">
                 <a:solidFill>
-                  <a:srgbClr val="758091"/>
+                  <a:srgbClr val="6B7485"/>
                 </a:solidFill>
                 <a:latin typeface="Calibri" pitchFamily="34" charset="0"/>
                 <a:ea typeface="Calibri" pitchFamily="34" charset="-122"/>
@@ -5092,21 +5022,14 @@
             </a:avLst>
           </a:prstGeom>
           <a:solidFill>
-            <a:srgbClr val="161B26"/>
+            <a:srgbClr val="F2F2F7"/>
           </a:solidFill>
           <a:ln w="12700">
             <a:solidFill>
-              <a:srgbClr val="2F63A8"/>
+              <a:srgbClr val="2F6BC4"/>
             </a:solidFill>
             <a:prstDash val="solid"/>
           </a:ln>
-          <a:effectLst>
-            <a:outerShdw sx="100000" sy="100000" kx="0" ky="0" algn="bl" rotWithShape="0" blurRad="228600" dist="50800" dir="5400000">
-              <a:srgbClr val="000000">
-                <a:alpha val="45000"/>
-              </a:srgbClr>
-            </a:outerShdw>
-          </a:effectLst>
         </p:spPr>
       </p:sp>
       <p:sp>
@@ -5136,7 +5059,7 @@
             <a:r>
               <a:rPr lang="en-US" sz="1000" spc="160" kern="0" dirty="0">
                 <a:solidFill>
-                  <a:srgbClr val="758091"/>
+                  <a:srgbClr val="6B7485"/>
                 </a:solidFill>
                 <a:latin typeface="Arial" pitchFamily="34" charset="0"/>
                 <a:ea typeface="Arial" pitchFamily="34" charset="-122"/>
@@ -5175,7 +5098,7 @@
             <a:r>
               <a:rPr lang="en-US" sz="1700" dirty="0">
                 <a:solidFill>
-                  <a:srgbClr val="F2F5FA"/>
+                  <a:srgbClr val="0F1522"/>
                 </a:solidFill>
                 <a:latin typeface="Arial" pitchFamily="34" charset="0"/>
                 <a:ea typeface="Arial" pitchFamily="34" charset="-122"/>
@@ -5189,7 +5112,7 @@
             <a:r>
               <a:rPr lang="en-US" sz="1700" dirty="0">
                 <a:solidFill>
-                  <a:srgbClr val="758091"/>
+                  <a:srgbClr val="6B7485"/>
                 </a:solidFill>
                 <a:latin typeface="Arial" pitchFamily="34" charset="0"/>
                 <a:ea typeface="Arial" pitchFamily="34" charset="-122"/>
@@ -5203,7 +5126,7 @@
             <a:r>
               <a:rPr lang="en-US" sz="1700" dirty="0">
                 <a:solidFill>
-                  <a:srgbClr val="F2F5FA"/>
+                  <a:srgbClr val="0F1522"/>
                 </a:solidFill>
                 <a:latin typeface="Arial" pitchFamily="34" charset="0"/>
                 <a:ea typeface="Arial" pitchFamily="34" charset="-122"/>
@@ -5217,7 +5140,7 @@
             <a:r>
               <a:rPr lang="en-US" sz="1700" dirty="0">
                 <a:solidFill>
-                  <a:srgbClr val="758091"/>
+                  <a:srgbClr val="6B7485"/>
                 </a:solidFill>
                 <a:latin typeface="Arial" pitchFamily="34" charset="0"/>
                 <a:ea typeface="Arial" pitchFamily="34" charset="-122"/>
@@ -5231,7 +5154,7 @@
             <a:r>
               <a:rPr lang="en-US" sz="1700" dirty="0">
                 <a:solidFill>
-                  <a:srgbClr val="F2F5FA"/>
+                  <a:srgbClr val="0F1522"/>
                 </a:solidFill>
                 <a:latin typeface="Arial" pitchFamily="34" charset="0"/>
                 <a:ea typeface="Arial" pitchFamily="34" charset="-122"/>
@@ -5245,7 +5168,7 @@
             <a:r>
               <a:rPr lang="en-US" sz="1700" dirty="0">
                 <a:solidFill>
-                  <a:srgbClr val="758091"/>
+                  <a:srgbClr val="6B7485"/>
                 </a:solidFill>
                 <a:latin typeface="Arial" pitchFamily="34" charset="0"/>
                 <a:ea typeface="Arial" pitchFamily="34" charset="-122"/>
@@ -5284,7 +5207,7 @@
             <a:r>
               <a:rPr lang="en-US" sz="3400" b="1" dirty="0">
                 <a:solidFill>
-                  <a:srgbClr val="5FD28A"/>
+                  <a:srgbClr val="1F8A4C"/>
                 </a:solidFill>
                 <a:latin typeface="Arial" pitchFamily="34" charset="0"/>
                 <a:ea typeface="Arial" pitchFamily="34" charset="-122"/>
@@ -5298,7 +5221,7 @@
             <a:r>
               <a:rPr lang="en-US" sz="1500" dirty="0">
                 <a:solidFill>
-                  <a:srgbClr val="758091"/>
+                  <a:srgbClr val="6B7485"/>
                 </a:solidFill>
                 <a:latin typeface="Arial" pitchFamily="34" charset="0"/>
                 <a:ea typeface="Arial" pitchFamily="34" charset="-122"/>
@@ -5337,7 +5260,7 @@
             <a:r>
               <a:rPr lang="en-US" sz="1300" i="1" dirty="0">
                 <a:solidFill>
-                  <a:srgbClr val="758091"/>
+                  <a:srgbClr val="6B7485"/>
                 </a:solidFill>
                 <a:latin typeface="Calibri" pitchFamily="34" charset="0"/>
                 <a:ea typeface="Calibri" pitchFamily="34" charset="-122"/>
@@ -5366,21 +5289,14 @@
             </a:avLst>
           </a:prstGeom>
           <a:solidFill>
-            <a:srgbClr val="1E2533"/>
+            <a:srgbClr val="DDE3EC"/>
           </a:solidFill>
           <a:ln w="12700">
             <a:solidFill>
-              <a:srgbClr val="1E2533"/>
+              <a:srgbClr val="DDE3EC"/>
             </a:solidFill>
             <a:prstDash val="solid"/>
           </a:ln>
-          <a:effectLst>
-            <a:outerShdw sx="100000" sy="100000" kx="0" ky="0" algn="bl" rotWithShape="0" blurRad="228600" dist="50800" dir="5400000">
-              <a:srgbClr val="000000">
-                <a:alpha val="45000"/>
-              </a:srgbClr>
-            </a:outerShdw>
-          </a:effectLst>
         </p:spPr>
       </p:sp>
       <p:pic>
@@ -5421,7 +5337,7 @@
     <p:bg>
       <p:bgPr>
         <a:solidFill>
-          <a:srgbClr val="0B0D12"/>
+          <a:srgbClr val="FFFFFF"/>
         </a:solidFill>
       </p:bgPr>
     </p:bg>
@@ -5466,7 +5382,7 @@
             <a:r>
               <a:rPr lang="en-US" sz="1100" b="1" spc="240" kern="0" dirty="0">
                 <a:solidFill>
-                  <a:srgbClr val="4A86D8"/>
+                  <a:srgbClr val="2F6BC4"/>
                 </a:solidFill>
                 <a:latin typeface="Arial" pitchFamily="34" charset="0"/>
                 <a:ea typeface="Arial" pitchFamily="34" charset="-122"/>
@@ -5508,7 +5424,7 @@
             <a:r>
               <a:rPr lang="en-US" sz="3000" b="1" dirty="0">
                 <a:solidFill>
-                  <a:srgbClr val="F2F5FA"/>
+                  <a:srgbClr val="0F1522"/>
                 </a:solidFill>
                 <a:latin typeface="Arial" pitchFamily="34" charset="0"/>
                 <a:ea typeface="Arial" pitchFamily="34" charset="-122"/>
@@ -5528,7 +5444,7 @@
             <a:r>
               <a:rPr lang="en-US" sz="3000" b="1" dirty="0">
                 <a:solidFill>
-                  <a:srgbClr val="F2F5FA"/>
+                  <a:srgbClr val="0F1522"/>
                 </a:solidFill>
                 <a:latin typeface="Arial" pitchFamily="34" charset="0"/>
                 <a:ea typeface="Arial" pitchFamily="34" charset="-122"/>
@@ -5555,11 +5471,11 @@
             <a:avLst/>
           </a:prstGeom>
           <a:solidFill>
-            <a:srgbClr val="5FD28A"/>
+            <a:srgbClr val="1F8A4C"/>
           </a:solidFill>
           <a:ln w="12700">
             <a:solidFill>
-              <a:srgbClr val="5FD28A"/>
+              <a:srgbClr val="1F8A4C"/>
             </a:solidFill>
             <a:prstDash val="solid"/>
           </a:ln>
@@ -5592,7 +5508,7 @@
             <a:r>
               <a:rPr lang="en-US" sz="1500" dirty="0">
                 <a:solidFill>
-                  <a:srgbClr val="A8B2C4"/>
+                  <a:srgbClr val="4B5565"/>
                 </a:solidFill>
                 <a:latin typeface="Calibri" pitchFamily="34" charset="0"/>
                 <a:ea typeface="Calibri" pitchFamily="34" charset="-122"/>
@@ -5619,11 +5535,11 @@
             <a:avLst/>
           </a:prstGeom>
           <a:solidFill>
-            <a:srgbClr val="FFC857"/>
+            <a:srgbClr val="D9A21B"/>
           </a:solidFill>
           <a:ln w="12700">
             <a:solidFill>
-              <a:srgbClr val="FFC857"/>
+              <a:srgbClr val="D9A21B"/>
             </a:solidFill>
             <a:prstDash val="solid"/>
           </a:ln>
@@ -5656,7 +5572,7 @@
             <a:r>
               <a:rPr lang="en-US" sz="1500" dirty="0">
                 <a:solidFill>
-                  <a:srgbClr val="A8B2C4"/>
+                  <a:srgbClr val="4B5565"/>
                 </a:solidFill>
                 <a:latin typeface="Calibri" pitchFamily="34" charset="0"/>
                 <a:ea typeface="Calibri" pitchFamily="34" charset="-122"/>
@@ -5683,11 +5599,11 @@
             <a:avLst/>
           </a:prstGeom>
           <a:solidFill>
-            <a:srgbClr val="FF7060"/>
+            <a:srgbClr val="D64545"/>
           </a:solidFill>
           <a:ln w="12700">
             <a:solidFill>
-              <a:srgbClr val="FF7060"/>
+              <a:srgbClr val="D64545"/>
             </a:solidFill>
             <a:prstDash val="solid"/>
           </a:ln>
@@ -5720,7 +5636,7 @@
             <a:r>
               <a:rPr lang="en-US" sz="1500" dirty="0">
                 <a:solidFill>
-                  <a:srgbClr val="A8B2C4"/>
+                  <a:srgbClr val="4B5565"/>
                 </a:solidFill>
                 <a:latin typeface="Calibri" pitchFamily="34" charset="0"/>
                 <a:ea typeface="Calibri" pitchFamily="34" charset="-122"/>
@@ -5762,7 +5678,7 @@
             <a:r>
               <a:rPr lang="en-US" sz="1400" dirty="0">
                 <a:solidFill>
-                  <a:srgbClr val="A8B2C4"/>
+                  <a:srgbClr val="4B5565"/>
                 </a:solidFill>
                 <a:latin typeface="Calibri" pitchFamily="34" charset="0"/>
                 <a:ea typeface="Calibri" pitchFamily="34" charset="-122"/>
@@ -5804,7 +5720,7 @@
             <a:r>
               <a:rPr lang="en-US" sz="1400" b="1" dirty="0">
                 <a:solidFill>
-                  <a:srgbClr val="F2F5FA"/>
+                  <a:srgbClr val="0F1522"/>
                 </a:solidFill>
                 <a:latin typeface="Calibri" pitchFamily="34" charset="0"/>
                 <a:ea typeface="Calibri" pitchFamily="34" charset="-122"/>
@@ -5821,7 +5737,7 @@
             <a:r>
               <a:rPr lang="en-US" sz="1400" dirty="0">
                 <a:solidFill>
-                  <a:srgbClr val="A8B2C4"/>
+                  <a:srgbClr val="4B5565"/>
                 </a:solidFill>
                 <a:latin typeface="Calibri" pitchFamily="34" charset="0"/>
                 <a:ea typeface="Calibri" pitchFamily="34" charset="-122"/>
@@ -5850,21 +5766,14 @@
             </a:avLst>
           </a:prstGeom>
           <a:solidFill>
-            <a:srgbClr val="1E2533"/>
+            <a:srgbClr val="DDE3EC"/>
           </a:solidFill>
           <a:ln w="12700">
             <a:solidFill>
-              <a:srgbClr val="1E2533"/>
+              <a:srgbClr val="DDE3EC"/>
             </a:solidFill>
             <a:prstDash val="solid"/>
           </a:ln>
-          <a:effectLst>
-            <a:outerShdw sx="100000" sy="100000" kx="0" ky="0" algn="bl" rotWithShape="0" blurRad="228600" dist="50800" dir="5400000">
-              <a:srgbClr val="000000">
-                <a:alpha val="45000"/>
-              </a:srgbClr>
-            </a:outerShdw>
-          </a:effectLst>
         </p:spPr>
       </p:sp>
       <p:pic>
@@ -5905,7 +5814,7 @@
     <p:bg>
       <p:bgPr>
         <a:solidFill>
-          <a:srgbClr val="0B0D12"/>
+          <a:srgbClr val="FFFFFF"/>
         </a:solidFill>
       </p:bgPr>
     </p:bg>
@@ -5950,7 +5859,7 @@
             <a:r>
               <a:rPr lang="en-US" sz="1100" b="1" spc="240" kern="0" dirty="0">
                 <a:solidFill>
-                  <a:srgbClr val="4A86D8"/>
+                  <a:srgbClr val="2F6BC4"/>
                 </a:solidFill>
                 <a:latin typeface="Arial" pitchFamily="34" charset="0"/>
                 <a:ea typeface="Arial" pitchFamily="34" charset="-122"/>
@@ -5992,7 +5901,7 @@
             <a:r>
               <a:rPr lang="en-US" sz="3200" b="1" dirty="0">
                 <a:solidFill>
-                  <a:srgbClr val="F2F5FA"/>
+                  <a:srgbClr val="0F1522"/>
                 </a:solidFill>
                 <a:latin typeface="Arial" pitchFamily="34" charset="0"/>
                 <a:ea typeface="Arial" pitchFamily="34" charset="-122"/>
@@ -6012,7 +5921,7 @@
             <a:r>
               <a:rPr lang="en-US" sz="3200" b="1" dirty="0">
                 <a:solidFill>
-                  <a:srgbClr val="F2F5FA"/>
+                  <a:srgbClr val="0F1522"/>
                 </a:solidFill>
                 <a:latin typeface="Arial" pitchFamily="34" charset="0"/>
                 <a:ea typeface="Arial" pitchFamily="34" charset="-122"/>
@@ -6041,21 +5950,14 @@
             </a:avLst>
           </a:prstGeom>
           <a:solidFill>
-            <a:srgbClr val="161B26"/>
+            <a:srgbClr val="F2F2F7"/>
           </a:solidFill>
           <a:ln w="12700">
             <a:solidFill>
-              <a:srgbClr val="1E2533"/>
+              <a:srgbClr val="DDE3EC"/>
             </a:solidFill>
             <a:prstDash val="solid"/>
           </a:ln>
-          <a:effectLst>
-            <a:outerShdw sx="100000" sy="100000" kx="0" ky="0" algn="bl" rotWithShape="0" blurRad="228600" dist="50800" dir="5400000">
-              <a:srgbClr val="000000">
-                <a:alpha val="45000"/>
-              </a:srgbClr>
-            </a:outerShdw>
-          </a:effectLst>
         </p:spPr>
       </p:sp>
       <p:sp>
@@ -6085,7 +5987,7 @@
             <a:r>
               <a:rPr lang="en-US" sz="2100" b="1" dirty="0">
                 <a:solidFill>
-                  <a:srgbClr val="F2F5FA"/>
+                  <a:srgbClr val="0F1522"/>
                 </a:solidFill>
                 <a:latin typeface="Arial" pitchFamily="34" charset="0"/>
                 <a:ea typeface="Arial" pitchFamily="34" charset="-122"/>
@@ -6151,7 +6053,7 @@
             <a:r>
               <a:rPr lang="en-US" sz="1200" b="1" dirty="0">
                 <a:solidFill>
-                  <a:srgbClr val="F2F5FA"/>
+                  <a:srgbClr val="0F1522"/>
                 </a:solidFill>
                 <a:latin typeface="Calibri" pitchFamily="34" charset="0"/>
                 <a:ea typeface="Calibri" pitchFamily="34" charset="-122"/>
@@ -6168,7 +6070,7 @@
             <a:r>
               <a:rPr lang="en-US" sz="1200" dirty="0">
                 <a:solidFill>
-                  <a:srgbClr val="A8B2C4"/>
+                  <a:srgbClr val="4B5565"/>
                 </a:solidFill>
                 <a:latin typeface="Calibri" pitchFamily="34" charset="0"/>
                 <a:ea typeface="Calibri" pitchFamily="34" charset="-122"/>
@@ -6197,21 +6099,14 @@
             </a:avLst>
           </a:prstGeom>
           <a:solidFill>
-            <a:srgbClr val="161B26"/>
+            <a:srgbClr val="F2F2F7"/>
           </a:solidFill>
           <a:ln w="12700">
             <a:solidFill>
-              <a:srgbClr val="1E2533"/>
+              <a:srgbClr val="DDE3EC"/>
             </a:solidFill>
             <a:prstDash val="solid"/>
           </a:ln>
-          <a:effectLst>
-            <a:outerShdw sx="100000" sy="100000" kx="0" ky="0" algn="bl" rotWithShape="0" blurRad="228600" dist="50800" dir="5400000">
-              <a:srgbClr val="000000">
-                <a:alpha val="45000"/>
-              </a:srgbClr>
-            </a:outerShdw>
-          </a:effectLst>
         </p:spPr>
       </p:sp>
       <p:sp>
@@ -6241,7 +6136,7 @@
             <a:r>
               <a:rPr lang="en-US" sz="2100" b="1" dirty="0">
                 <a:solidFill>
-                  <a:srgbClr val="F2F5FA"/>
+                  <a:srgbClr val="0F1522"/>
                 </a:solidFill>
                 <a:latin typeface="Arial" pitchFamily="34" charset="0"/>
                 <a:ea typeface="Arial" pitchFamily="34" charset="-122"/>
@@ -6307,7 +6202,7 @@
             <a:r>
               <a:rPr lang="en-US" sz="1200" b="1" dirty="0">
                 <a:solidFill>
-                  <a:srgbClr val="F2F5FA"/>
+                  <a:srgbClr val="0F1522"/>
                 </a:solidFill>
                 <a:latin typeface="Calibri" pitchFamily="34" charset="0"/>
                 <a:ea typeface="Calibri" pitchFamily="34" charset="-122"/>
@@ -6324,7 +6219,7 @@
             <a:r>
               <a:rPr lang="en-US" sz="1200" dirty="0">
                 <a:solidFill>
-                  <a:srgbClr val="A8B2C4"/>
+                  <a:srgbClr val="4B5565"/>
                 </a:solidFill>
                 <a:latin typeface="Calibri" pitchFamily="34" charset="0"/>
                 <a:ea typeface="Calibri" pitchFamily="34" charset="-122"/>
@@ -6366,7 +6261,7 @@
             <a:r>
               <a:rPr lang="en-US" sz="1200" b="1" dirty="0">
                 <a:solidFill>
-                  <a:srgbClr val="5FD28A"/>
+                  <a:srgbClr val="1F8A4C"/>
                 </a:solidFill>
                 <a:latin typeface="Calibri" pitchFamily="34" charset="0"/>
                 <a:ea typeface="Calibri" pitchFamily="34" charset="-122"/>
@@ -6383,7 +6278,7 @@
             <a:r>
               <a:rPr lang="en-US" sz="1200" dirty="0">
                 <a:solidFill>
-                  <a:srgbClr val="A8B2C4"/>
+                  <a:srgbClr val="4B5565"/>
                 </a:solidFill>
                 <a:latin typeface="Calibri" pitchFamily="34" charset="0"/>
                 <a:ea typeface="Calibri" pitchFamily="34" charset="-122"/>
@@ -6409,7 +6304,7 @@
     <p:bg>
       <p:bgPr>
         <a:solidFill>
-          <a:srgbClr val="0B0D12"/>
+          <a:srgbClr val="FFFFFF"/>
         </a:solidFill>
       </p:bgPr>
     </p:bg>
@@ -6454,7 +6349,7 @@
             <a:r>
               <a:rPr lang="en-US" sz="1100" b="1" spc="240" kern="0" dirty="0">
                 <a:solidFill>
-                  <a:srgbClr val="4A86D8"/>
+                  <a:srgbClr val="2F6BC4"/>
                 </a:solidFill>
                 <a:latin typeface="Arial" pitchFamily="34" charset="0"/>
                 <a:ea typeface="Arial" pitchFamily="34" charset="-122"/>
@@ -6496,7 +6391,7 @@
             <a:r>
               <a:rPr lang="en-US" sz="3400" b="1" dirty="0">
                 <a:solidFill>
-                  <a:srgbClr val="F2F5FA"/>
+                  <a:srgbClr val="0F1522"/>
                 </a:solidFill>
                 <a:latin typeface="Arial" pitchFamily="34" charset="0"/>
                 <a:ea typeface="Arial" pitchFamily="34" charset="-122"/>
@@ -6516,7 +6411,7 @@
             <a:r>
               <a:rPr lang="en-US" sz="3400" b="1" dirty="0">
                 <a:solidFill>
-                  <a:srgbClr val="F2F5FA"/>
+                  <a:srgbClr val="0F1522"/>
                 </a:solidFill>
                 <a:latin typeface="Arial" pitchFamily="34" charset="0"/>
                 <a:ea typeface="Arial" pitchFamily="34" charset="-122"/>
@@ -6558,7 +6453,7 @@
             <a:r>
               <a:rPr lang="en-US" sz="1500" dirty="0">
                 <a:solidFill>
-                  <a:srgbClr val="A8B2C4"/>
+                  <a:srgbClr val="4B5565"/>
                 </a:solidFill>
                 <a:latin typeface="Calibri" pitchFamily="34" charset="0"/>
                 <a:ea typeface="Calibri" pitchFamily="34" charset="-122"/>
@@ -6597,7 +6492,7 @@
             <a:r>
               <a:rPr lang="en-US" sz="950" spc="120" kern="0" dirty="0">
                 <a:solidFill>
-                  <a:srgbClr val="758091"/>
+                  <a:srgbClr val="6B7485"/>
                 </a:solidFill>
                 <a:latin typeface="Arial" pitchFamily="34" charset="0"/>
                 <a:ea typeface="Arial" pitchFamily="34" charset="-122"/>
@@ -6639,7 +6534,7 @@
             <a:r>
               <a:rPr lang="en-US" sz="1300" dirty="0">
                 <a:solidFill>
-                  <a:srgbClr val="A8B2C4"/>
+                  <a:srgbClr val="4B5565"/>
                 </a:solidFill>
                 <a:latin typeface="Calibri" pitchFamily="34" charset="0"/>
                 <a:ea typeface="Calibri" pitchFamily="34" charset="-122"/>
@@ -6666,11 +6561,11 @@
             <a:avLst/>
           </a:prstGeom>
           <a:solidFill>
-            <a:srgbClr val="1E2533"/>
+            <a:srgbClr val="DDE3EC"/>
           </a:solidFill>
           <a:ln w="12700">
             <a:solidFill>
-              <a:srgbClr val="1E2533"/>
+              <a:srgbClr val="DDE3EC"/>
             </a:solidFill>
             <a:prstDash val="solid"/>
           </a:ln>
@@ -6703,7 +6598,7 @@
             <a:r>
               <a:rPr lang="en-US" sz="950" spc="120" kern="0" dirty="0">
                 <a:solidFill>
-                  <a:srgbClr val="758091"/>
+                  <a:srgbClr val="6B7485"/>
                 </a:solidFill>
                 <a:latin typeface="Arial" pitchFamily="34" charset="0"/>
                 <a:ea typeface="Arial" pitchFamily="34" charset="-122"/>
@@ -6745,7 +6640,7 @@
             <a:r>
               <a:rPr lang="en-US" sz="1300" dirty="0">
                 <a:solidFill>
-                  <a:srgbClr val="A8B2C4"/>
+                  <a:srgbClr val="4B5565"/>
                 </a:solidFill>
                 <a:latin typeface="Calibri" pitchFamily="34" charset="0"/>
                 <a:ea typeface="Calibri" pitchFamily="34" charset="-122"/>
@@ -6772,11 +6667,11 @@
             <a:avLst/>
           </a:prstGeom>
           <a:solidFill>
-            <a:srgbClr val="1E2533"/>
+            <a:srgbClr val="DDE3EC"/>
           </a:solidFill>
           <a:ln w="12700">
             <a:solidFill>
-              <a:srgbClr val="1E2533"/>
+              <a:srgbClr val="DDE3EC"/>
             </a:solidFill>
             <a:prstDash val="solid"/>
           </a:ln>
@@ -6809,7 +6704,7 @@
             <a:r>
               <a:rPr lang="en-US" sz="950" spc="120" kern="0" dirty="0">
                 <a:solidFill>
-                  <a:srgbClr val="758091"/>
+                  <a:srgbClr val="6B7485"/>
                 </a:solidFill>
                 <a:latin typeface="Arial" pitchFamily="34" charset="0"/>
                 <a:ea typeface="Arial" pitchFamily="34" charset="-122"/>
@@ -6851,7 +6746,7 @@
             <a:r>
               <a:rPr lang="en-US" sz="1300" dirty="0">
                 <a:solidFill>
-                  <a:srgbClr val="A8B2C4"/>
+                  <a:srgbClr val="4B5565"/>
                 </a:solidFill>
                 <a:latin typeface="Calibri" pitchFamily="34" charset="0"/>
                 <a:ea typeface="Calibri" pitchFamily="34" charset="-122"/>
@@ -6878,11 +6773,11 @@
             <a:avLst/>
           </a:prstGeom>
           <a:solidFill>
-            <a:srgbClr val="1E2533"/>
+            <a:srgbClr val="DDE3EC"/>
           </a:solidFill>
           <a:ln w="12700">
             <a:solidFill>
-              <a:srgbClr val="1E2533"/>
+              <a:srgbClr val="DDE3EC"/>
             </a:solidFill>
             <a:prstDash val="solid"/>
           </a:ln>
@@ -6915,7 +6810,7 @@
             <a:r>
               <a:rPr lang="en-US" sz="950" spc="120" kern="0" dirty="0">
                 <a:solidFill>
-                  <a:srgbClr val="758091"/>
+                  <a:srgbClr val="6B7485"/>
                 </a:solidFill>
                 <a:latin typeface="Arial" pitchFamily="34" charset="0"/>
                 <a:ea typeface="Arial" pitchFamily="34" charset="-122"/>
@@ -6957,7 +6852,7 @@
             <a:r>
               <a:rPr lang="en-US" sz="1300" dirty="0">
                 <a:solidFill>
-                  <a:srgbClr val="A8B2C4"/>
+                  <a:srgbClr val="4B5565"/>
                 </a:solidFill>
                 <a:latin typeface="Calibri" pitchFamily="34" charset="0"/>
                 <a:ea typeface="Calibri" pitchFamily="34" charset="-122"/>
@@ -6984,11 +6879,11 @@
             <a:avLst/>
           </a:prstGeom>
           <a:solidFill>
-            <a:srgbClr val="1E2533"/>
+            <a:srgbClr val="DDE3EC"/>
           </a:solidFill>
           <a:ln w="12700">
             <a:solidFill>
-              <a:srgbClr val="1E2533"/>
+              <a:srgbClr val="DDE3EC"/>
             </a:solidFill>
             <a:prstDash val="solid"/>
           </a:ln>
@@ -7021,7 +6916,7 @@
             <a:r>
               <a:rPr lang="en-US" sz="950" spc="120" kern="0" dirty="0">
                 <a:solidFill>
-                  <a:srgbClr val="758091"/>
+                  <a:srgbClr val="6B7485"/>
                 </a:solidFill>
                 <a:latin typeface="Arial" pitchFamily="34" charset="0"/>
                 <a:ea typeface="Arial" pitchFamily="34" charset="-122"/>
@@ -7063,7 +6958,7 @@
             <a:r>
               <a:rPr lang="en-US" sz="1300" dirty="0">
                 <a:solidFill>
-                  <a:srgbClr val="A8B2C4"/>
+                  <a:srgbClr val="4B5565"/>
                 </a:solidFill>
                 <a:latin typeface="Calibri" pitchFamily="34" charset="0"/>
                 <a:ea typeface="Calibri" pitchFamily="34" charset="-122"/>
@@ -7092,11 +6987,11 @@
             </a:avLst>
           </a:prstGeom>
           <a:solidFill>
-            <a:srgbClr val="161B26"/>
+            <a:srgbClr val="F2F2F7"/>
           </a:solidFill>
           <a:ln w="12700">
             <a:solidFill>
-              <a:srgbClr val="FFC857"/>
+              <a:srgbClr val="D9A21B"/>
             </a:solidFill>
             <a:prstDash val="solid"/>
           </a:ln>
@@ -7129,7 +7024,7 @@
             <a:r>
               <a:rPr lang="en-US" sz="2000" b="1" dirty="0">
                 <a:solidFill>
-                  <a:srgbClr val="FFC857"/>
+                  <a:srgbClr val="A86B00"/>
                 </a:solidFill>
                 <a:latin typeface="Arial" pitchFamily="34" charset="0"/>
                 <a:ea typeface="Arial" pitchFamily="34" charset="-122"/>
@@ -7168,7 +7063,7 @@
             <a:r>
               <a:rPr lang="en-US" sz="1700" b="1" dirty="0">
                 <a:solidFill>
-                  <a:srgbClr val="F2F5FA"/>
+                  <a:srgbClr val="0F1522"/>
                 </a:solidFill>
                 <a:latin typeface="Arial" pitchFamily="34" charset="0"/>
                 <a:ea typeface="Arial" pitchFamily="34" charset="-122"/>
@@ -7210,7 +7105,7 @@
             <a:r>
               <a:rPr lang="en-US" sz="1300" dirty="0">
                 <a:solidFill>
-                  <a:srgbClr val="A8B2C4"/>
+                  <a:srgbClr val="4B5565"/>
                 </a:solidFill>
                 <a:latin typeface="Calibri" pitchFamily="34" charset="0"/>
                 <a:ea typeface="Calibri" pitchFamily="34" charset="-122"/>
@@ -7239,7 +7134,7 @@
             <a:r>
               <a:rPr lang="en-US" sz="1300" dirty="0">
                 <a:solidFill>
-                  <a:srgbClr val="A8B2C4"/>
+                  <a:srgbClr val="4B5565"/>
                 </a:solidFill>
                 <a:latin typeface="Calibri" pitchFamily="34" charset="0"/>
                 <a:ea typeface="Calibri" pitchFamily="34" charset="-122"/>
@@ -7265,7 +7160,7 @@
     <p:bg>
       <p:bgPr>
         <a:solidFill>
-          <a:srgbClr val="0B0D12"/>
+          <a:srgbClr val="FFFFFF"/>
         </a:solidFill>
       </p:bgPr>
     </p:bg>
@@ -7310,7 +7205,7 @@
             <a:r>
               <a:rPr lang="en-US" sz="1100" b="1" spc="240" kern="0" dirty="0">
                 <a:solidFill>
-                  <a:srgbClr val="4A86D8"/>
+                  <a:srgbClr val="2F6BC4"/>
                 </a:solidFill>
                 <a:latin typeface="Arial" pitchFamily="34" charset="0"/>
                 <a:ea typeface="Arial" pitchFamily="34" charset="-122"/>
@@ -7352,7 +7247,7 @@
             <a:r>
               <a:rPr lang="en-US" sz="3400" b="1" dirty="0">
                 <a:solidFill>
-                  <a:srgbClr val="F2F5FA"/>
+                  <a:srgbClr val="0F1522"/>
                 </a:solidFill>
                 <a:latin typeface="Arial" pitchFamily="34" charset="0"/>
                 <a:ea typeface="Arial" pitchFamily="34" charset="-122"/>
@@ -7381,21 +7276,14 @@
             </a:avLst>
           </a:prstGeom>
           <a:solidFill>
-            <a:srgbClr val="161B26"/>
+            <a:srgbClr val="F2F2F7"/>
           </a:solidFill>
           <a:ln w="12700">
             <a:solidFill>
-              <a:srgbClr val="1E2533"/>
+              <a:srgbClr val="DDE3EC"/>
             </a:solidFill>
             <a:prstDash val="solid"/>
           </a:ln>
-          <a:effectLst>
-            <a:outerShdw sx="100000" sy="100000" kx="0" ky="0" algn="bl" rotWithShape="0" blurRad="228600" dist="50800" dir="5400000">
-              <a:srgbClr val="000000">
-                <a:alpha val="45000"/>
-              </a:srgbClr>
-            </a:outerShdw>
-          </a:effectLst>
         </p:spPr>
       </p:sp>
       <p:sp>
@@ -7425,7 +7313,7 @@
             <a:r>
               <a:rPr lang="en-US" sz="3800" b="1" dirty="0">
                 <a:solidFill>
-                  <a:srgbClr val="F2F5FA"/>
+                  <a:srgbClr val="0F1522"/>
                 </a:solidFill>
                 <a:latin typeface="Arial" pitchFamily="34" charset="0"/>
                 <a:ea typeface="Arial" pitchFamily="34" charset="-122"/>
@@ -7467,7 +7355,7 @@
             <a:r>
               <a:rPr lang="en-US" sz="900" spc="110" kern="0" dirty="0">
                 <a:solidFill>
-                  <a:srgbClr val="758091"/>
+                  <a:srgbClr val="6B7485"/>
                 </a:solidFill>
                 <a:latin typeface="Arial" pitchFamily="34" charset="0"/>
                 <a:ea typeface="Arial" pitchFamily="34" charset="-122"/>
@@ -7496,21 +7384,14 @@
             </a:avLst>
           </a:prstGeom>
           <a:solidFill>
-            <a:srgbClr val="161B26"/>
+            <a:srgbClr val="F2F2F7"/>
           </a:solidFill>
           <a:ln w="12700">
             <a:solidFill>
-              <a:srgbClr val="1E2533"/>
+              <a:srgbClr val="DDE3EC"/>
             </a:solidFill>
             <a:prstDash val="solid"/>
           </a:ln>
-          <a:effectLst>
-            <a:outerShdw sx="100000" sy="100000" kx="0" ky="0" algn="bl" rotWithShape="0" blurRad="228600" dist="50800" dir="5400000">
-              <a:srgbClr val="000000">
-                <a:alpha val="45000"/>
-              </a:srgbClr>
-            </a:outerShdw>
-          </a:effectLst>
         </p:spPr>
       </p:sp>
       <p:sp>
@@ -7540,7 +7421,7 @@
             <a:r>
               <a:rPr lang="en-US" sz="3800" b="1" dirty="0">
                 <a:solidFill>
-                  <a:srgbClr val="F2F5FA"/>
+                  <a:srgbClr val="0F1522"/>
                 </a:solidFill>
                 <a:latin typeface="Arial" pitchFamily="34" charset="0"/>
                 <a:ea typeface="Arial" pitchFamily="34" charset="-122"/>
@@ -7582,7 +7463,7 @@
             <a:r>
               <a:rPr lang="en-US" sz="900" spc="110" kern="0" dirty="0">
                 <a:solidFill>
-                  <a:srgbClr val="758091"/>
+                  <a:srgbClr val="6B7485"/>
                 </a:solidFill>
                 <a:latin typeface="Arial" pitchFamily="34" charset="0"/>
                 <a:ea typeface="Arial" pitchFamily="34" charset="-122"/>
@@ -7611,21 +7492,14 @@
             </a:avLst>
           </a:prstGeom>
           <a:solidFill>
-            <a:srgbClr val="161B26"/>
+            <a:srgbClr val="F2F2F7"/>
           </a:solidFill>
           <a:ln w="12700">
             <a:solidFill>
-              <a:srgbClr val="1E2533"/>
+              <a:srgbClr val="DDE3EC"/>
             </a:solidFill>
             <a:prstDash val="solid"/>
           </a:ln>
-          <a:effectLst>
-            <a:outerShdw sx="100000" sy="100000" kx="0" ky="0" algn="bl" rotWithShape="0" blurRad="228600" dist="50800" dir="5400000">
-              <a:srgbClr val="000000">
-                <a:alpha val="45000"/>
-              </a:srgbClr>
-            </a:outerShdw>
-          </a:effectLst>
         </p:spPr>
       </p:sp>
       <p:sp>
@@ -7655,7 +7529,7 @@
             <a:r>
               <a:rPr lang="en-US" sz="3800" b="1" dirty="0">
                 <a:solidFill>
-                  <a:srgbClr val="5FD28A"/>
+                  <a:srgbClr val="1F8A4C"/>
                 </a:solidFill>
                 <a:latin typeface="Arial" pitchFamily="34" charset="0"/>
                 <a:ea typeface="Arial" pitchFamily="34" charset="-122"/>
@@ -7697,7 +7571,7 @@
             <a:r>
               <a:rPr lang="en-US" sz="900" spc="110" kern="0" dirty="0">
                 <a:solidFill>
-                  <a:srgbClr val="758091"/>
+                  <a:srgbClr val="6B7485"/>
                 </a:solidFill>
                 <a:latin typeface="Arial" pitchFamily="34" charset="0"/>
                 <a:ea typeface="Arial" pitchFamily="34" charset="-122"/>
@@ -7726,21 +7600,14 @@
             </a:avLst>
           </a:prstGeom>
           <a:solidFill>
-            <a:srgbClr val="161B26"/>
+            <a:srgbClr val="F2F2F7"/>
           </a:solidFill>
           <a:ln w="12700">
             <a:solidFill>
-              <a:srgbClr val="1E2533"/>
+              <a:srgbClr val="DDE3EC"/>
             </a:solidFill>
             <a:prstDash val="solid"/>
           </a:ln>
-          <a:effectLst>
-            <a:outerShdw sx="100000" sy="100000" kx="0" ky="0" algn="bl" rotWithShape="0" blurRad="228600" dist="50800" dir="5400000">
-              <a:srgbClr val="000000">
-                <a:alpha val="45000"/>
-              </a:srgbClr>
-            </a:outerShdw>
-          </a:effectLst>
         </p:spPr>
       </p:sp>
       <p:sp>
@@ -7770,7 +7637,7 @@
             <a:r>
               <a:rPr lang="en-US" sz="3800" b="1" dirty="0">
                 <a:solidFill>
-                  <a:srgbClr val="5FD28A"/>
+                  <a:srgbClr val="1F8A4C"/>
                 </a:solidFill>
                 <a:latin typeface="Arial" pitchFamily="34" charset="0"/>
                 <a:ea typeface="Arial" pitchFamily="34" charset="-122"/>
@@ -7812,7 +7679,7 @@
             <a:r>
               <a:rPr lang="en-US" sz="900" spc="110" kern="0" dirty="0">
                 <a:solidFill>
-                  <a:srgbClr val="758091"/>
+                  <a:srgbClr val="6B7485"/>
                 </a:solidFill>
                 <a:latin typeface="Arial" pitchFamily="34" charset="0"/>
                 <a:ea typeface="Arial" pitchFamily="34" charset="-122"/>
@@ -7851,7 +7718,7 @@
             <a:r>
               <a:rPr lang="en-US" sz="1900" b="1" dirty="0">
                 <a:solidFill>
-                  <a:srgbClr val="F2F5FA"/>
+                  <a:srgbClr val="0F1522"/>
                 </a:solidFill>
                 <a:latin typeface="Arial" pitchFamily="34" charset="0"/>
                 <a:ea typeface="Arial" pitchFamily="34" charset="-122"/>
@@ -7897,7 +7764,7 @@
             <a:r>
               <a:rPr lang="en-US" sz="1400" dirty="0">
                 <a:solidFill>
-                  <a:srgbClr val="A8B2C4"/>
+                  <a:srgbClr val="4B5565"/>
                 </a:solidFill>
                 <a:latin typeface="Calibri" pitchFamily="34" charset="0"/>
                 <a:ea typeface="Calibri" pitchFamily="34" charset="-122"/>
@@ -7921,7 +7788,7 @@
             <a:r>
               <a:rPr lang="en-US" sz="1400" dirty="0">
                 <a:solidFill>
-                  <a:srgbClr val="A8B2C4"/>
+                  <a:srgbClr val="4B5565"/>
                 </a:solidFill>
                 <a:latin typeface="Calibri" pitchFamily="34" charset="0"/>
                 <a:ea typeface="Calibri" pitchFamily="34" charset="-122"/>
@@ -7945,7 +7812,7 @@
             <a:r>
               <a:rPr lang="en-US" sz="1400" dirty="0">
                 <a:solidFill>
-                  <a:srgbClr val="A8B2C4"/>
+                  <a:srgbClr val="4B5565"/>
                 </a:solidFill>
                 <a:latin typeface="Calibri" pitchFamily="34" charset="0"/>
                 <a:ea typeface="Calibri" pitchFamily="34" charset="-122"/>

</xml_diff>

<commit_message>
Add FAQ slides to the deck, and stop claiming ten engineers are on the trial
The Trial slide said 10 engineers and the opening notes said the app was
running on ten phones. The trial isn't staffed yet; the deck goes out with
the email that asks for those engineers. The tile now reads "10 engineers
wanted" and the notes say the same.

Two FAQ slides before Try it, six questions each, answered from what the app
actually does:
- Where the numbers come from: the credit values (Centrica sheet ID1923,
  one credit = 83.58 minutes, nine values still being checked), what
  happens when they change, how the weekly target is set, whether travel is
  included and the logic behind it, and whether MI or the payslip is used.
- How the balance works: how a deficit is worked out, how Coach helps clear
  one, leave / rest days / mentoring, weeks that weren't a fair test, what
  counts as NPT, and whether a manager can see an engineer's figures.

Co-Authored-By: Claude Opus 5 <noreply@anthropic.com>
</commit_message>
<xml_diff>
--- a/docs/presentation/CTAP-Tracker.pptx
+++ b/docs/presentation/CTAP-Tracker.pptx
@@ -15,6 +15,8 @@
     <p:sldId id="262" r:id="rId8"/>
     <p:sldId id="263" r:id="rId9"/>
     <p:sldId id="264" r:id="rId10"/>
+    <p:sldId id="267" r:id="rId18"/>
+    <p:sldId id="268" r:id="rId19"/>
     <p:sldId id="265" r:id="rId11"/>
   </p:sldIdLst>
   <p:notesMasterIdLst>
@@ -512,7 +514,7 @@
           <a:p>
             <a:r>
               <a:rPr lang="en-US" dirty="0"/>
-              <a:t>CTAP Tracker — a personal tool for Service &amp; Repair engineers to track their CTAP bonus in real time. Built by an engineer, running on ten phones for the trial. Everything you see is on-device; I will come back to that.</a:t>
+              <a:t>CTAP Tracker — a personal tool for Service &amp; Repair engineers to track their CTAP bonus in real time. Built by an engineer, and looking for ten engineers to trial it. Everything you see is on-device; I will come back to that.</a:t>
             </a:r>
             <a:endParaRPr lang="en-US" dirty="0"/>
           </a:p>
@@ -721,6 +723,182 @@
     <p:extLst>
       <p:ext uri="{BB962C8B-B14F-4D97-AF65-F5344CB8AC3E}">
         <p14:creationId xmlns:p14="http://schemas.microsoft.com/office/powerpoint/2010/main" val="2091734615"/>
+      </p:ext>
+    </p:extLst>
+  </p:cSld>
+  <p:clrMapOvr>
+    <a:masterClrMapping/>
+  </p:clrMapOvr>
+</p:notes>
+</file>
+
+<file path=ppt/notesSlides/notesSlide12.xml><?xml version="1.0" encoding="utf-8"?>
+<p:notes xmlns:a="http://schemas.openxmlformats.org/drawingml/2006/main" xmlns:r="http://schemas.openxmlformats.org/officeDocument/2006/relationships" xmlns:p="http://schemas.openxmlformats.org/presentationml/2006/main">
+  <p:cSld>
+    <p:spTree>
+      <p:nvGrpSpPr>
+        <p:cNvPr id="1" name=""/>
+        <p:cNvGrpSpPr/>
+        <p:nvPr/>
+      </p:nvGrpSpPr>
+      <p:grpSpPr>
+        <a:xfrm>
+          <a:off x="0" y="0"/>
+          <a:ext cx="0" cy="0"/>
+          <a:chOff x="0" y="0"/>
+          <a:chExt cx="0" cy="0"/>
+        </a:xfrm>
+      </p:grpSpPr>
+      <p:sp>
+        <p:nvSpPr>
+          <p:cNvPr id="2" name="Slide Image Placeholder 1"/>
+          <p:cNvSpPr>
+            <a:spLocks noGrp="1" noRot="1" noChangeAspect="1"/>
+          </p:cNvSpPr>
+          <p:nvPr>
+            <p:ph type="sldImg"/>
+          </p:nvPr>
+        </p:nvSpPr>
+        <p:spPr/>
+      </p:sp>
+      <p:sp>
+        <p:nvSpPr>
+          <p:cNvPr id="3" name="Notes Placeholder 2"/>
+          <p:cNvSpPr>
+            <a:spLocks noGrp="1"/>
+          </p:cNvSpPr>
+          <p:nvPr>
+            <p:ph type="body" idx="1"/>
+          </p:nvPr>
+        </p:nvSpPr>
+        <p:spPr/>
+        <p:txBody>
+          <a:bodyPr/>
+          <a:lstStyle/>
+          <a:p>
+            <a:r>
+              <a:rPr lang="en-GB" dirty="0"/>
+              <a:t>The questions a manager or an engineer asks first: where the credit values come from, how the target is set, and how travel is allowed for. Every answer describes what the app does today.</a:t>
+            </a:r>
+            <a:endParaRPr lang="en-GB" dirty="0"/>
+          </a:p>
+        </p:txBody>
+      </p:sp>
+      <p:sp>
+        <p:nvSpPr>
+          <p:cNvPr id="4" name="Slide Number Placeholder 3"/>
+          <p:cNvSpPr>
+            <a:spLocks noGrp="1"/>
+          </p:cNvSpPr>
+          <p:nvPr>
+            <p:ph type="sldNum" sz="quarter" idx="10"/>
+          </p:nvPr>
+        </p:nvSpPr>
+        <p:spPr/>
+        <p:txBody>
+          <a:bodyPr/>
+          <a:lstStyle/>
+          <a:p>
+            <a:fld id="{F7021451-1387-4CA6-816F-3879F97B5CBC}" type="slidenum">
+              <a:rPr lang="en-GB"/>
+              <a:t>11</a:t>
+            </a:fld>
+            <a:endParaRPr lang="en-GB"/>
+          </a:p>
+        </p:txBody>
+      </p:sp>
+    </p:spTree>
+    <p:extLst>
+      <p:ext uri="{BB962C8B-B14F-4D97-AF65-F5344CB8AC3E}">
+        <p14:creationId xmlns:p14="http://schemas.microsoft.com/office/powerpoint/2010/main" val="1840527391"/>
+      </p:ext>
+    </p:extLst>
+  </p:cSld>
+  <p:clrMapOvr>
+    <a:masterClrMapping/>
+  </p:clrMapOvr>
+</p:notes>
+</file>
+
+<file path=ppt/notesSlides/notesSlide13.xml><?xml version="1.0" encoding="utf-8"?>
+<p:notes xmlns:a="http://schemas.openxmlformats.org/drawingml/2006/main" xmlns:r="http://schemas.openxmlformats.org/officeDocument/2006/relationships" xmlns:p="http://schemas.openxmlformats.org/presentationml/2006/main">
+  <p:cSld>
+    <p:spTree>
+      <p:nvGrpSpPr>
+        <p:cNvPr id="1" name=""/>
+        <p:cNvGrpSpPr/>
+        <p:nvPr/>
+      </p:nvGrpSpPr>
+      <p:grpSpPr>
+        <a:xfrm>
+          <a:off x="0" y="0"/>
+          <a:ext cx="0" cy="0"/>
+          <a:chOff x="0" y="0"/>
+          <a:chExt cx="0" cy="0"/>
+        </a:xfrm>
+      </p:grpSpPr>
+      <p:sp>
+        <p:nvSpPr>
+          <p:cNvPr id="2" name="Slide Image Placeholder 1"/>
+          <p:cNvSpPr>
+            <a:spLocks noGrp="1" noRot="1" noChangeAspect="1"/>
+          </p:cNvSpPr>
+          <p:nvPr>
+            <p:ph type="sldImg"/>
+          </p:nvPr>
+        </p:nvSpPr>
+        <p:spPr/>
+      </p:sp>
+      <p:sp>
+        <p:nvSpPr>
+          <p:cNvPr id="3" name="Notes Placeholder 2"/>
+          <p:cNvSpPr>
+            <a:spLocks noGrp="1"/>
+          </p:cNvSpPr>
+          <p:nvPr>
+            <p:ph type="body" idx="1"/>
+          </p:nvPr>
+        </p:nvSpPr>
+        <p:spPr/>
+        <p:txBody>
+          <a:bodyPr/>
+          <a:lstStyle/>
+          <a:p>
+            <a:r>
+              <a:rPr lang="en-GB" dirty="0"/>
+              <a:t>How the balance and a deficit are worked out, and what changes a week's target. The privacy answer is the same one as the Where the figures live slide.</a:t>
+            </a:r>
+            <a:endParaRPr lang="en-GB" dirty="0"/>
+          </a:p>
+        </p:txBody>
+      </p:sp>
+      <p:sp>
+        <p:nvSpPr>
+          <p:cNvPr id="4" name="Slide Number Placeholder 3"/>
+          <p:cNvSpPr>
+            <a:spLocks noGrp="1"/>
+          </p:cNvSpPr>
+          <p:nvPr>
+            <p:ph type="sldNum" sz="quarter" idx="10"/>
+          </p:nvPr>
+        </p:nvSpPr>
+        <p:spPr/>
+        <p:txBody>
+          <a:bodyPr/>
+          <a:lstStyle/>
+          <a:p>
+            <a:fld id="{F7021451-1387-4CA6-816F-3879F97B5CBC}" type="slidenum">
+              <a:rPr lang="en-GB"/>
+              <a:t>12</a:t>
+            </a:fld>
+            <a:endParaRPr lang="en-GB"/>
+          </a:p>
+        </p:txBody>
+      </p:sp>
+    </p:spTree>
+    <p:extLst>
+      <p:ext uri="{BB962C8B-B14F-4D97-AF65-F5344CB8AC3E}">
+        <p14:creationId xmlns:p14="http://schemas.microsoft.com/office/powerpoint/2010/main" val="1840527392"/>
       </p:ext>
     </p:extLst>
   </p:cSld>
@@ -2823,6 +3001,1560 @@
 </p:sld>
 </file>
 
+<file path=ppt/slides/slide12.xml><?xml version="1.0" encoding="utf-8"?>
+<p:sld xmlns:a="http://schemas.openxmlformats.org/drawingml/2006/main" xmlns:r="http://schemas.openxmlformats.org/officeDocument/2006/relationships" xmlns:p="http://schemas.openxmlformats.org/presentationml/2006/main">
+  <p:cSld name="Slide 11">
+    <p:bg>
+      <p:bgPr>
+        <a:solidFill>
+          <a:srgbClr val="FFFFFF"/>
+        </a:solidFill>
+        <a:effectLst/>
+      </p:bgPr>
+    </p:bg>
+    <p:spTree>
+      <p:nvGrpSpPr>
+        <p:cNvPr id="1" name=""/>
+        <p:cNvGrpSpPr/>
+        <p:nvPr/>
+      </p:nvGrpSpPr>
+      <p:grpSpPr>
+        <a:xfrm>
+          <a:off x="0" y="0"/>
+          <a:ext cx="0" cy="0"/>
+          <a:chOff x="0" y="0"/>
+          <a:chExt cx="0" cy="0"/>
+        </a:xfrm>
+      </p:grpSpPr>
+      <p:sp>
+        <p:nvSpPr>
+          <p:cNvPr id="2" name="Text 2"/>
+          <p:cNvSpPr txBox="1"/>
+          <p:nvPr/>
+        </p:nvSpPr>
+        <p:spPr>
+          <a:xfrm>
+            <a:off x="566928" y="566928"/>
+            <a:ext cx="10058400" cy="237744"/>
+          </a:xfrm>
+          <a:prstGeom prst="rect">
+            <a:avLst/>
+          </a:prstGeom>
+          <a:noFill/>
+          <a:ln/>
+        </p:spPr>
+        <p:txBody>
+          <a:bodyPr wrap="square" lIns="0" tIns="0" rIns="0" bIns="0" rtlCol="0" anchor="ctr"/>
+          <a:lstStyle/>
+          <a:p>
+            <a:pPr indent="0" marL="0">
+              <a:buNone/>
+            </a:pPr>
+            <a:r>
+              <a:rPr lang="en-GB" sz="1100" b="1" spc="240" kern="0" dirty="0">
+                <a:solidFill>
+                  <a:srgbClr val="2F6BC4"/>
+                </a:solidFill>
+                <a:latin typeface="Arial" pitchFamily="34" charset="0"/>
+                <a:ea typeface="Arial" pitchFamily="34" charset="-122"/>
+                <a:cs typeface="Arial" pitchFamily="34" charset="-120"/>
+              </a:rPr>
+              <a:t>QUESTIONS PEOPLE ASK</a:t>
+            </a:r>
+            <a:endParaRPr lang="en-GB" sz="1100" dirty="0"/>
+          </a:p>
+        </p:txBody>
+      </p:sp>
+      <p:sp>
+        <p:nvSpPr>
+          <p:cNvPr id="3" name="Text 3"/>
+          <p:cNvSpPr txBox="1"/>
+          <p:nvPr/>
+        </p:nvSpPr>
+        <p:spPr>
+          <a:xfrm>
+            <a:off x="566928" y="877824"/>
+            <a:ext cx="10058400" cy="640080"/>
+          </a:xfrm>
+          <a:prstGeom prst="rect">
+            <a:avLst/>
+          </a:prstGeom>
+          <a:noFill/>
+          <a:ln/>
+        </p:spPr>
+        <p:txBody>
+          <a:bodyPr wrap="square" lIns="0" tIns="0" rIns="0" bIns="0" rtlCol="0" anchor="ctr"/>
+          <a:lstStyle/>
+          <a:p>
+            <a:pPr indent="0" marL="0">
+              <a:buNone/>
+            </a:pPr>
+            <a:r>
+              <a:rPr lang="en-GB" sz="3200" b="1" dirty="0">
+                <a:solidFill>
+                  <a:srgbClr val="0F1522"/>
+                </a:solidFill>
+                <a:latin typeface="Arial" pitchFamily="34" charset="0"/>
+                <a:ea typeface="Arial" pitchFamily="34" charset="-122"/>
+                <a:cs typeface="Arial" pitchFamily="34" charset="-120"/>
+              </a:rPr>
+              <a:t>Where the numbers come from.</a:t>
+            </a:r>
+            <a:endParaRPr lang="en-GB" sz="3200" dirty="0"/>
+          </a:p>
+        </p:txBody>
+      </p:sp>
+      <p:sp>
+        <p:nvSpPr>
+          <p:cNvPr id="4" name="Card 4"/>
+          <p:cNvSpPr/>
+          <p:nvPr/>
+        </p:nvSpPr>
+        <p:spPr>
+          <a:xfrm>
+            <a:off x="566928" y="1737360"/>
+            <a:ext cx="3493008" cy="2217420"/>
+          </a:xfrm>
+          <a:prstGeom prst="roundRect">
+            <a:avLst>
+              <a:gd name="adj" fmla="val 4800"/>
+            </a:avLst>
+          </a:prstGeom>
+          <a:solidFill>
+            <a:srgbClr val="F2F2F7"/>
+          </a:solidFill>
+          <a:ln w="12700">
+            <a:solidFill>
+              <a:srgbClr val="DDE3EC"/>
+            </a:solidFill>
+            <a:prstDash val="solid"/>
+          </a:ln>
+        </p:spPr>
+      </p:sp>
+      <p:sp>
+        <p:nvSpPr>
+          <p:cNvPr id="5" name="Text 5"/>
+          <p:cNvSpPr txBox="1"/>
+          <p:nvPr/>
+        </p:nvSpPr>
+        <p:spPr>
+          <a:xfrm>
+            <a:off x="822960" y="1965960"/>
+            <a:ext cx="2980944" cy="502920"/>
+          </a:xfrm>
+          <a:prstGeom prst="rect">
+            <a:avLst/>
+          </a:prstGeom>
+          <a:noFill/>
+          <a:ln/>
+        </p:spPr>
+        <p:txBody>
+          <a:bodyPr wrap="square" lIns="0" tIns="0" rIns="0" bIns="0" rtlCol="0" anchor="t"/>
+          <a:lstStyle/>
+          <a:p>
+            <a:pPr indent="0" marL="0">
+              <a:lnSpc>
+                <a:spcPts val="1800"/>
+              </a:lnSpc>
+              <a:buNone/>
+            </a:pPr>
+            <a:r>
+              <a:rPr lang="en-GB" sz="1400" b="1" dirty="0">
+                <a:solidFill>
+                  <a:srgbClr val="0F1522"/>
+                </a:solidFill>
+                <a:latin typeface="Arial" pitchFamily="34" charset="0"/>
+                <a:ea typeface="Arial" pitchFamily="34" charset="-122"/>
+                <a:cs typeface="Arial" pitchFamily="34" charset="-120"/>
+              </a:rPr>
+              <a:t>Where do the job credit values come from?</a:t>
+            </a:r>
+            <a:endParaRPr lang="en-GB" sz="1400" dirty="0"/>
+          </a:p>
+        </p:txBody>
+      </p:sp>
+      <p:sp>
+        <p:nvSpPr>
+          <p:cNvPr id="6" name="Text 6"/>
+          <p:cNvSpPr txBox="1"/>
+          <p:nvPr/>
+        </p:nvSpPr>
+        <p:spPr>
+          <a:xfrm>
+            <a:off x="822960" y="2514600"/>
+            <a:ext cx="2980944" cy="1257300"/>
+          </a:xfrm>
+          <a:prstGeom prst="rect">
+            <a:avLst/>
+          </a:prstGeom>
+          <a:noFill/>
+          <a:ln/>
+        </p:spPr>
+        <p:txBody>
+          <a:bodyPr wrap="square" lIns="0" tIns="0" rIns="0" bIns="0" rtlCol="0" anchor="t"/>
+          <a:lstStyle/>
+          <a:p>
+            <a:pPr indent="0" marL="0">
+              <a:lnSpc>
+                <a:spcPts val="1650"/>
+              </a:lnSpc>
+              <a:buNone/>
+            </a:pPr>
+            <a:r>
+              <a:rPr lang="en-GB" sz="1200" dirty="0">
+                <a:solidFill>
+                  <a:srgbClr val="4B5565"/>
+                </a:solidFill>
+                <a:latin typeface="Calibri" pitchFamily="34" charset="0"/>
+                <a:ea typeface="Calibri" pitchFamily="34" charset="-122"/>
+                <a:cs typeface="Calibri" pitchFamily="34" charset="-120"/>
+              </a:rPr>
+              <a:t>Centrica's sheet ID1923, Job Codes &amp; Credits. Each job uses the sheet's credit minutes, and one credit is 83.58 minutes. Nine older values are still being checked against the sheet.</a:t>
+            </a:r>
+            <a:endParaRPr lang="en-GB" sz="1200" dirty="0"/>
+          </a:p>
+        </p:txBody>
+      </p:sp>
+      <p:sp>
+        <p:nvSpPr>
+          <p:cNvPr id="7" name="Card 7"/>
+          <p:cNvSpPr/>
+          <p:nvPr/>
+        </p:nvSpPr>
+        <p:spPr>
+          <a:xfrm>
+            <a:off x="4334256" y="1737360"/>
+            <a:ext cx="3493008" cy="2217420"/>
+          </a:xfrm>
+          <a:prstGeom prst="roundRect">
+            <a:avLst>
+              <a:gd name="adj" fmla="val 4800"/>
+            </a:avLst>
+          </a:prstGeom>
+          <a:solidFill>
+            <a:srgbClr val="F2F2F7"/>
+          </a:solidFill>
+          <a:ln w="12700">
+            <a:solidFill>
+              <a:srgbClr val="DDE3EC"/>
+            </a:solidFill>
+            <a:prstDash val="solid"/>
+          </a:ln>
+        </p:spPr>
+      </p:sp>
+      <p:sp>
+        <p:nvSpPr>
+          <p:cNvPr id="8" name="Text 8"/>
+          <p:cNvSpPr txBox="1"/>
+          <p:nvPr/>
+        </p:nvSpPr>
+        <p:spPr>
+          <a:xfrm>
+            <a:off x="4590288" y="1965960"/>
+            <a:ext cx="2980944" cy="502920"/>
+          </a:xfrm>
+          <a:prstGeom prst="rect">
+            <a:avLst/>
+          </a:prstGeom>
+          <a:noFill/>
+          <a:ln/>
+        </p:spPr>
+        <p:txBody>
+          <a:bodyPr wrap="square" lIns="0" tIns="0" rIns="0" bIns="0" rtlCol="0" anchor="t"/>
+          <a:lstStyle/>
+          <a:p>
+            <a:pPr indent="0" marL="0">
+              <a:lnSpc>
+                <a:spcPts val="1800"/>
+              </a:lnSpc>
+              <a:buNone/>
+            </a:pPr>
+            <a:r>
+              <a:rPr lang="en-GB" sz="1400" b="1" dirty="0">
+                <a:solidFill>
+                  <a:srgbClr val="0F1522"/>
+                </a:solidFill>
+                <a:latin typeface="Arial" pitchFamily="34" charset="0"/>
+                <a:ea typeface="Arial" pitchFamily="34" charset="-122"/>
+                <a:cs typeface="Arial" pitchFamily="34" charset="-120"/>
+              </a:rPr>
+              <a:t>What happens when the credit values change?</a:t>
+            </a:r>
+            <a:endParaRPr lang="en-GB" sz="1400" dirty="0"/>
+          </a:p>
+        </p:txBody>
+      </p:sp>
+      <p:sp>
+        <p:nvSpPr>
+          <p:cNvPr id="9" name="Text 9"/>
+          <p:cNvSpPr txBox="1"/>
+          <p:nvPr/>
+        </p:nvSpPr>
+        <p:spPr>
+          <a:xfrm>
+            <a:off x="4590288" y="2514600"/>
+            <a:ext cx="2980944" cy="1257300"/>
+          </a:xfrm>
+          <a:prstGeom prst="rect">
+            <a:avLst/>
+          </a:prstGeom>
+          <a:noFill/>
+          <a:ln/>
+        </p:spPr>
+        <p:txBody>
+          <a:bodyPr wrap="square" lIns="0" tIns="0" rIns="0" bIns="0" rtlCol="0" anchor="t"/>
+          <a:lstStyle/>
+          <a:p>
+            <a:pPr indent="0" marL="0">
+              <a:lnSpc>
+                <a:spcPts val="1650"/>
+              </a:lnSpc>
+              <a:buNone/>
+            </a:pPr>
+            <a:r>
+              <a:rPr lang="en-GB" sz="1200" dirty="0">
+                <a:solidFill>
+                  <a:srgbClr val="4B5565"/>
+                </a:solidFill>
+                <a:latin typeface="Calibri" pitchFamily="34" charset="0"/>
+                <a:ea typeface="Calibri" pitchFamily="34" charset="-122"/>
+                <a:cs typeface="Calibri" pitchFamily="34" charset="-120"/>
+              </a:rPr>
+              <a:t>The job list is a snapshot of the scheme, so it's updated to match whenever a value changes. Jobs already logged keep the value they were logged with.</a:t>
+            </a:r>
+            <a:endParaRPr lang="en-GB" sz="1200" dirty="0"/>
+          </a:p>
+        </p:txBody>
+      </p:sp>
+      <p:sp>
+        <p:nvSpPr>
+          <p:cNvPr id="10" name="Card 10"/>
+          <p:cNvSpPr/>
+          <p:nvPr/>
+        </p:nvSpPr>
+        <p:spPr>
+          <a:xfrm>
+            <a:off x="8101584" y="1737360"/>
+            <a:ext cx="3493008" cy="2217420"/>
+          </a:xfrm>
+          <a:prstGeom prst="roundRect">
+            <a:avLst>
+              <a:gd name="adj" fmla="val 4800"/>
+            </a:avLst>
+          </a:prstGeom>
+          <a:solidFill>
+            <a:srgbClr val="F2F2F7"/>
+          </a:solidFill>
+          <a:ln w="12700">
+            <a:solidFill>
+              <a:srgbClr val="DDE3EC"/>
+            </a:solidFill>
+            <a:prstDash val="solid"/>
+          </a:ln>
+        </p:spPr>
+      </p:sp>
+      <p:sp>
+        <p:nvSpPr>
+          <p:cNvPr id="11" name="Text 11"/>
+          <p:cNvSpPr txBox="1"/>
+          <p:nvPr/>
+        </p:nvSpPr>
+        <p:spPr>
+          <a:xfrm>
+            <a:off x="8357616" y="1965960"/>
+            <a:ext cx="2980944" cy="502920"/>
+          </a:xfrm>
+          <a:prstGeom prst="rect">
+            <a:avLst/>
+          </a:prstGeom>
+          <a:noFill/>
+          <a:ln/>
+        </p:spPr>
+        <p:txBody>
+          <a:bodyPr wrap="square" lIns="0" tIns="0" rIns="0" bIns="0" rtlCol="0" anchor="t"/>
+          <a:lstStyle/>
+          <a:p>
+            <a:pPr indent="0" marL="0">
+              <a:lnSpc>
+                <a:spcPts val="1800"/>
+              </a:lnSpc>
+              <a:buNone/>
+            </a:pPr>
+            <a:r>
+              <a:rPr lang="en-GB" sz="1400" b="1" dirty="0">
+                <a:solidFill>
+                  <a:srgbClr val="0F1522"/>
+                </a:solidFill>
+                <a:latin typeface="Arial" pitchFamily="34" charset="0"/>
+                <a:ea typeface="Arial" pitchFamily="34" charset="-122"/>
+                <a:cs typeface="Arial" pitchFamily="34" charset="-120"/>
+              </a:rPr>
+              <a:t>How is my weekly target worked out?</a:t>
+            </a:r>
+            <a:endParaRPr lang="en-GB" sz="1400" dirty="0"/>
+          </a:p>
+        </p:txBody>
+      </p:sp>
+      <p:sp>
+        <p:nvSpPr>
+          <p:cNvPr id="12" name="Text 12"/>
+          <p:cNvSpPr txBox="1"/>
+          <p:nvPr/>
+        </p:nvSpPr>
+        <p:spPr>
+          <a:xfrm>
+            <a:off x="8357616" y="2514600"/>
+            <a:ext cx="2980944" cy="1257300"/>
+          </a:xfrm>
+          <a:prstGeom prst="rect">
+            <a:avLst/>
+          </a:prstGeom>
+          <a:noFill/>
+          <a:ln/>
+        </p:spPr>
+        <p:txBody>
+          <a:bodyPr wrap="square" lIns="0" tIns="0" rIns="0" bIns="0" rtlCol="0" anchor="t"/>
+          <a:lstStyle/>
+          <a:p>
+            <a:pPr indent="0" marL="0">
+              <a:lnSpc>
+                <a:spcPts val="1650"/>
+              </a:lnSpc>
+              <a:buNone/>
+            </a:pPr>
+            <a:r>
+              <a:rPr lang="en-GB" sz="1200" dirty="0">
+                <a:solidFill>
+                  <a:srgbClr val="4B5565"/>
+                </a:solidFill>
+                <a:latin typeface="Calibri" pitchFamily="34" charset="0"/>
+                <a:ea typeface="Calibri" pitchFamily="34" charset="-122"/>
+                <a:cs typeface="Calibri" pitchFamily="34" charset="-120"/>
+              </a:rPr>
+              <a:t>Your rostered hours (40, less any leave or mentor days) × 80%, less any NPT you log. After four finished weeks, the week's target becomes the average of your recent weeks.</a:t>
+            </a:r>
+            <a:endParaRPr lang="en-GB" sz="1200" dirty="0"/>
+          </a:p>
+        </p:txBody>
+      </p:sp>
+      <p:sp>
+        <p:nvSpPr>
+          <p:cNvPr id="13" name="Card 13"/>
+          <p:cNvSpPr/>
+          <p:nvPr/>
+        </p:nvSpPr>
+        <p:spPr>
+          <a:xfrm>
+            <a:off x="566928" y="4183380"/>
+            <a:ext cx="3493008" cy="2217420"/>
+          </a:xfrm>
+          <a:prstGeom prst="roundRect">
+            <a:avLst>
+              <a:gd name="adj" fmla="val 4800"/>
+            </a:avLst>
+          </a:prstGeom>
+          <a:solidFill>
+            <a:srgbClr val="F2F2F7"/>
+          </a:solidFill>
+          <a:ln w="12700">
+            <a:solidFill>
+              <a:srgbClr val="DDE3EC"/>
+            </a:solidFill>
+            <a:prstDash val="solid"/>
+          </a:ln>
+        </p:spPr>
+      </p:sp>
+      <p:sp>
+        <p:nvSpPr>
+          <p:cNvPr id="14" name="Text 14"/>
+          <p:cNvSpPr txBox="1"/>
+          <p:nvPr/>
+        </p:nvSpPr>
+        <p:spPr>
+          <a:xfrm>
+            <a:off x="822960" y="4411980"/>
+            <a:ext cx="2980944" cy="502920"/>
+          </a:xfrm>
+          <a:prstGeom prst="rect">
+            <a:avLst/>
+          </a:prstGeom>
+          <a:noFill/>
+          <a:ln/>
+        </p:spPr>
+        <p:txBody>
+          <a:bodyPr wrap="square" lIns="0" tIns="0" rIns="0" bIns="0" rtlCol="0" anchor="t"/>
+          <a:lstStyle/>
+          <a:p>
+            <a:pPr indent="0" marL="0">
+              <a:lnSpc>
+                <a:spcPts val="1800"/>
+              </a:lnSpc>
+              <a:buNone/>
+            </a:pPr>
+            <a:r>
+              <a:rPr lang="en-GB" sz="1400" b="1" dirty="0">
+                <a:solidFill>
+                  <a:srgbClr val="0F1522"/>
+                </a:solidFill>
+                <a:latin typeface="Arial" pitchFamily="34" charset="0"/>
+                <a:ea typeface="Arial" pitchFamily="34" charset="-122"/>
+                <a:cs typeface="Arial" pitchFamily="34" charset="-120"/>
+              </a:rPr>
+              <a:t>Is travel time included?</a:t>
+            </a:r>
+            <a:endParaRPr lang="en-GB" sz="1400" dirty="0"/>
+          </a:p>
+        </p:txBody>
+      </p:sp>
+      <p:sp>
+        <p:nvSpPr>
+          <p:cNvPr id="15" name="Text 15"/>
+          <p:cNvSpPr txBox="1"/>
+          <p:nvPr/>
+        </p:nvSpPr>
+        <p:spPr>
+          <a:xfrm>
+            <a:off x="822960" y="4960620"/>
+            <a:ext cx="2980944" cy="1257300"/>
+          </a:xfrm>
+          <a:prstGeom prst="rect">
+            <a:avLst/>
+          </a:prstGeom>
+          <a:noFill/>
+          <a:ln/>
+        </p:spPr>
+        <p:txBody>
+          <a:bodyPr wrap="square" lIns="0" tIns="0" rIns="0" bIns="0" rtlCol="0" anchor="t"/>
+          <a:lstStyle/>
+          <a:p>
+            <a:pPr indent="0" marL="0">
+              <a:lnSpc>
+                <a:spcPts val="1650"/>
+              </a:lnSpc>
+              <a:buNone/>
+            </a:pPr>
+            <a:r>
+              <a:rPr lang="en-GB" sz="1200" dirty="0">
+                <a:solidFill>
+                  <a:srgbClr val="4B5565"/>
+                </a:solidFill>
+                <a:latin typeface="Calibri" pitchFamily="34" charset="0"/>
+                <a:ea typeface="Calibri" pitchFamily="34" charset="-122"/>
+                <a:cs typeface="Calibri" pitchFamily="34" charset="-120"/>
+              </a:rPr>
+              <a:t>Not directly. Travel isn't credited and isn't logged day to day. The 80% target leaves room for it, and from your fifth week your own average reflects the travel you really do.</a:t>
+            </a:r>
+            <a:endParaRPr lang="en-GB" sz="1200" dirty="0"/>
+          </a:p>
+        </p:txBody>
+      </p:sp>
+      <p:sp>
+        <p:nvSpPr>
+          <p:cNvPr id="16" name="Card 16"/>
+          <p:cNvSpPr/>
+          <p:nvPr/>
+        </p:nvSpPr>
+        <p:spPr>
+          <a:xfrm>
+            <a:off x="4334256" y="4183380"/>
+            <a:ext cx="3493008" cy="2217420"/>
+          </a:xfrm>
+          <a:prstGeom prst="roundRect">
+            <a:avLst>
+              <a:gd name="adj" fmla="val 4800"/>
+            </a:avLst>
+          </a:prstGeom>
+          <a:solidFill>
+            <a:srgbClr val="F2F2F7"/>
+          </a:solidFill>
+          <a:ln w="12700">
+            <a:solidFill>
+              <a:srgbClr val="DDE3EC"/>
+            </a:solidFill>
+            <a:prstDash val="solid"/>
+          </a:ln>
+        </p:spPr>
+      </p:sp>
+      <p:sp>
+        <p:nvSpPr>
+          <p:cNvPr id="17" name="Text 17"/>
+          <p:cNvSpPr txBox="1"/>
+          <p:nvPr/>
+        </p:nvSpPr>
+        <p:spPr>
+          <a:xfrm>
+            <a:off x="4590288" y="4411980"/>
+            <a:ext cx="2980944" cy="502920"/>
+          </a:xfrm>
+          <a:prstGeom prst="rect">
+            <a:avLst/>
+          </a:prstGeom>
+          <a:noFill/>
+          <a:ln/>
+        </p:spPr>
+        <p:txBody>
+          <a:bodyPr wrap="square" lIns="0" tIns="0" rIns="0" bIns="0" rtlCol="0" anchor="t"/>
+          <a:lstStyle/>
+          <a:p>
+            <a:pPr indent="0" marL="0">
+              <a:lnSpc>
+                <a:spcPts val="1800"/>
+              </a:lnSpc>
+              <a:buNone/>
+            </a:pPr>
+            <a:r>
+              <a:rPr lang="en-GB" sz="1400" b="1" dirty="0">
+                <a:solidFill>
+                  <a:srgbClr val="0F1522"/>
+                </a:solidFill>
+                <a:latin typeface="Arial" pitchFamily="34" charset="0"/>
+                <a:ea typeface="Arial" pitchFamily="34" charset="-122"/>
+                <a:cs typeface="Arial" pitchFamily="34" charset="-120"/>
+              </a:rPr>
+              <a:t>What's the logic behind travel?</a:t>
+            </a:r>
+            <a:endParaRPr lang="en-GB" sz="1400" dirty="0"/>
+          </a:p>
+        </p:txBody>
+      </p:sp>
+      <p:sp>
+        <p:nvSpPr>
+          <p:cNvPr id="18" name="Text 18"/>
+          <p:cNvSpPr txBox="1"/>
+          <p:nvPr/>
+        </p:nvSpPr>
+        <p:spPr>
+          <a:xfrm>
+            <a:off x="4590288" y="4960620"/>
+            <a:ext cx="2980944" cy="1257300"/>
+          </a:xfrm>
+          <a:prstGeom prst="rect">
+            <a:avLst/>
+          </a:prstGeom>
+          <a:noFill/>
+          <a:ln/>
+        </p:spPr>
+        <p:txBody>
+          <a:bodyPr wrap="square" lIns="0" tIns="0" rIns="0" bIns="0" rtlCol="0" anchor="t"/>
+          <a:lstStyle/>
+          <a:p>
+            <a:pPr indent="0" marL="0">
+              <a:lnSpc>
+                <a:spcPts val="1650"/>
+              </a:lnSpc>
+              <a:buNone/>
+            </a:pPr>
+            <a:r>
+              <a:rPr lang="en-GB" sz="1200" dirty="0">
+                <a:solidFill>
+                  <a:srgbClr val="4B5565"/>
+                </a:solidFill>
+                <a:latin typeface="Calibri" pitchFamily="34" charset="0"/>
+                <a:ea typeface="Calibri" pitchFamily="34" charset="-122"/>
+                <a:cs typeface="Calibri" pitchFamily="34" charset="-120"/>
+              </a:rPr>
+              <a:t>Travel and Performance Factor take roughly 8 hours a week and can't be measured as you go, so 80% keeps the in-week figures realistic. Travel typed into History is a record only.</a:t>
+            </a:r>
+            <a:endParaRPr lang="en-GB" sz="1200" dirty="0"/>
+          </a:p>
+        </p:txBody>
+      </p:sp>
+      <p:sp>
+        <p:nvSpPr>
+          <p:cNvPr id="19" name="Card 19"/>
+          <p:cNvSpPr/>
+          <p:nvPr/>
+        </p:nvSpPr>
+        <p:spPr>
+          <a:xfrm>
+            <a:off x="8101584" y="4183380"/>
+            <a:ext cx="3493008" cy="2217420"/>
+          </a:xfrm>
+          <a:prstGeom prst="roundRect">
+            <a:avLst>
+              <a:gd name="adj" fmla="val 4800"/>
+            </a:avLst>
+          </a:prstGeom>
+          <a:solidFill>
+            <a:srgbClr val="F2F2F7"/>
+          </a:solidFill>
+          <a:ln w="12700">
+            <a:solidFill>
+              <a:srgbClr val="DDE3EC"/>
+            </a:solidFill>
+            <a:prstDash val="solid"/>
+          </a:ln>
+        </p:spPr>
+      </p:sp>
+      <p:sp>
+        <p:nvSpPr>
+          <p:cNvPr id="20" name="Text 20"/>
+          <p:cNvSpPr txBox="1"/>
+          <p:nvPr/>
+        </p:nvSpPr>
+        <p:spPr>
+          <a:xfrm>
+            <a:off x="8357616" y="4411980"/>
+            <a:ext cx="2980944" cy="502920"/>
+          </a:xfrm>
+          <a:prstGeom prst="rect">
+            <a:avLst/>
+          </a:prstGeom>
+          <a:noFill/>
+          <a:ln/>
+        </p:spPr>
+        <p:txBody>
+          <a:bodyPr wrap="square" lIns="0" tIns="0" rIns="0" bIns="0" rtlCol="0" anchor="t"/>
+          <a:lstStyle/>
+          <a:p>
+            <a:pPr indent="0" marL="0">
+              <a:lnSpc>
+                <a:spcPts val="1800"/>
+              </a:lnSpc>
+              <a:buNone/>
+            </a:pPr>
+            <a:r>
+              <a:rPr lang="en-GB" sz="1400" b="1" dirty="0">
+                <a:solidFill>
+                  <a:srgbClr val="0F1522"/>
+                </a:solidFill>
+                <a:latin typeface="Arial" pitchFamily="34" charset="0"/>
+                <a:ea typeface="Arial" pitchFamily="34" charset="-122"/>
+                <a:cs typeface="Arial" pitchFamily="34" charset="-120"/>
+              </a:rPr>
+              <a:t>Does it use MI or my payslip?</a:t>
+            </a:r>
+            <a:endParaRPr lang="en-GB" sz="1400" dirty="0"/>
+          </a:p>
+        </p:txBody>
+      </p:sp>
+      <p:sp>
+        <p:nvSpPr>
+          <p:cNvPr id="21" name="Text 21"/>
+          <p:cNvSpPr txBox="1"/>
+          <p:nvPr/>
+        </p:nvSpPr>
+        <p:spPr>
+          <a:xfrm>
+            <a:off x="8357616" y="4960620"/>
+            <a:ext cx="2980944" cy="1257300"/>
+          </a:xfrm>
+          <a:prstGeom prst="rect">
+            <a:avLst/>
+          </a:prstGeom>
+          <a:noFill/>
+          <a:ln/>
+        </p:spPr>
+        <p:txBody>
+          <a:bodyPr wrap="square" lIns="0" tIns="0" rIns="0" bIns="0" rtlCol="0" anchor="t"/>
+          <a:lstStyle/>
+          <a:p>
+            <a:pPr indent="0" marL="0">
+              <a:lnSpc>
+                <a:spcPts val="1650"/>
+              </a:lnSpc>
+              <a:buNone/>
+            </a:pPr>
+            <a:r>
+              <a:rPr lang="en-GB" sz="1200" dirty="0">
+                <a:solidFill>
+                  <a:srgbClr val="4B5565"/>
+                </a:solidFill>
+                <a:latin typeface="Calibri" pitchFamily="34" charset="0"/>
+                <a:ea typeface="Calibri" pitchFamily="34" charset="-122"/>
+                <a:cs typeface="Calibri" pitchFamily="34" charset="-120"/>
+              </a:rPr>
+              <a:t>No. MI arrives 10–14 days after the week and is never imported. Everything comes from what you log, so treat the figures as personal estimates and check them against your payslip.</a:t>
+            </a:r>
+            <a:endParaRPr lang="en-GB" sz="1200" dirty="0"/>
+          </a:p>
+        </p:txBody>
+      </p:sp>
+    </p:spTree>
+  </p:cSld>
+  <p:clrMapOvr>
+    <a:masterClrMapping/>
+  </p:clrMapOvr>
+</p:sld>
+</file>
+
+<file path=ppt/slides/slide13.xml><?xml version="1.0" encoding="utf-8"?>
+<p:sld xmlns:a="http://schemas.openxmlformats.org/drawingml/2006/main" xmlns:r="http://schemas.openxmlformats.org/officeDocument/2006/relationships" xmlns:p="http://schemas.openxmlformats.org/presentationml/2006/main">
+  <p:cSld name="Slide 12">
+    <p:bg>
+      <p:bgPr>
+        <a:solidFill>
+          <a:srgbClr val="FFFFFF"/>
+        </a:solidFill>
+        <a:effectLst/>
+      </p:bgPr>
+    </p:bg>
+    <p:spTree>
+      <p:nvGrpSpPr>
+        <p:cNvPr id="1" name=""/>
+        <p:cNvGrpSpPr/>
+        <p:nvPr/>
+      </p:nvGrpSpPr>
+      <p:grpSpPr>
+        <a:xfrm>
+          <a:off x="0" y="0"/>
+          <a:ext cx="0" cy="0"/>
+          <a:chOff x="0" y="0"/>
+          <a:chExt cx="0" cy="0"/>
+        </a:xfrm>
+      </p:grpSpPr>
+      <p:sp>
+        <p:nvSpPr>
+          <p:cNvPr id="2" name="Text 2"/>
+          <p:cNvSpPr txBox="1"/>
+          <p:nvPr/>
+        </p:nvSpPr>
+        <p:spPr>
+          <a:xfrm>
+            <a:off x="566928" y="566928"/>
+            <a:ext cx="10058400" cy="237744"/>
+          </a:xfrm>
+          <a:prstGeom prst="rect">
+            <a:avLst/>
+          </a:prstGeom>
+          <a:noFill/>
+          <a:ln/>
+        </p:spPr>
+        <p:txBody>
+          <a:bodyPr wrap="square" lIns="0" tIns="0" rIns="0" bIns="0" rtlCol="0" anchor="ctr"/>
+          <a:lstStyle/>
+          <a:p>
+            <a:pPr indent="0" marL="0">
+              <a:buNone/>
+            </a:pPr>
+            <a:r>
+              <a:rPr lang="en-GB" sz="1100" b="1" spc="240" kern="0" dirty="0">
+                <a:solidFill>
+                  <a:srgbClr val="2F6BC4"/>
+                </a:solidFill>
+                <a:latin typeface="Arial" pitchFamily="34" charset="0"/>
+                <a:ea typeface="Arial" pitchFamily="34" charset="-122"/>
+                <a:cs typeface="Arial" pitchFamily="34" charset="-120"/>
+              </a:rPr>
+              <a:t>QUESTIONS PEOPLE ASK</a:t>
+            </a:r>
+            <a:endParaRPr lang="en-GB" sz="1100" dirty="0"/>
+          </a:p>
+        </p:txBody>
+      </p:sp>
+      <p:sp>
+        <p:nvSpPr>
+          <p:cNvPr id="3" name="Text 3"/>
+          <p:cNvSpPr txBox="1"/>
+          <p:nvPr/>
+        </p:nvSpPr>
+        <p:spPr>
+          <a:xfrm>
+            <a:off x="566928" y="877824"/>
+            <a:ext cx="10058400" cy="640080"/>
+          </a:xfrm>
+          <a:prstGeom prst="rect">
+            <a:avLst/>
+          </a:prstGeom>
+          <a:noFill/>
+          <a:ln/>
+        </p:spPr>
+        <p:txBody>
+          <a:bodyPr wrap="square" lIns="0" tIns="0" rIns="0" bIns="0" rtlCol="0" anchor="ctr"/>
+          <a:lstStyle/>
+          <a:p>
+            <a:pPr indent="0" marL="0">
+              <a:buNone/>
+            </a:pPr>
+            <a:r>
+              <a:rPr lang="en-GB" sz="3200" b="1" dirty="0">
+                <a:solidFill>
+                  <a:srgbClr val="0F1522"/>
+                </a:solidFill>
+                <a:latin typeface="Arial" pitchFamily="34" charset="0"/>
+                <a:ea typeface="Arial" pitchFamily="34" charset="-122"/>
+                <a:cs typeface="Arial" pitchFamily="34" charset="-120"/>
+              </a:rPr>
+              <a:t>How the balance works.</a:t>
+            </a:r>
+            <a:endParaRPr lang="en-GB" sz="3200" dirty="0"/>
+          </a:p>
+        </p:txBody>
+      </p:sp>
+      <p:sp>
+        <p:nvSpPr>
+          <p:cNvPr id="4" name="Card 4"/>
+          <p:cNvSpPr/>
+          <p:nvPr/>
+        </p:nvSpPr>
+        <p:spPr>
+          <a:xfrm>
+            <a:off x="566928" y="1737360"/>
+            <a:ext cx="3493008" cy="2217420"/>
+          </a:xfrm>
+          <a:prstGeom prst="roundRect">
+            <a:avLst>
+              <a:gd name="adj" fmla="val 4800"/>
+            </a:avLst>
+          </a:prstGeom>
+          <a:solidFill>
+            <a:srgbClr val="F2F2F7"/>
+          </a:solidFill>
+          <a:ln w="12700">
+            <a:solidFill>
+              <a:srgbClr val="DDE3EC"/>
+            </a:solidFill>
+            <a:prstDash val="solid"/>
+          </a:ln>
+        </p:spPr>
+      </p:sp>
+      <p:sp>
+        <p:nvSpPr>
+          <p:cNvPr id="5" name="Text 5"/>
+          <p:cNvSpPr txBox="1"/>
+          <p:nvPr/>
+        </p:nvSpPr>
+        <p:spPr>
+          <a:xfrm>
+            <a:off x="822960" y="1965960"/>
+            <a:ext cx="2980944" cy="502920"/>
+          </a:xfrm>
+          <a:prstGeom prst="rect">
+            <a:avLst/>
+          </a:prstGeom>
+          <a:noFill/>
+          <a:ln/>
+        </p:spPr>
+        <p:txBody>
+          <a:bodyPr wrap="square" lIns="0" tIns="0" rIns="0" bIns="0" rtlCol="0" anchor="t"/>
+          <a:lstStyle/>
+          <a:p>
+            <a:pPr indent="0" marL="0">
+              <a:lnSpc>
+                <a:spcPts val="1800"/>
+              </a:lnSpc>
+              <a:buNone/>
+            </a:pPr>
+            <a:r>
+              <a:rPr lang="en-GB" sz="1400" b="1" dirty="0">
+                <a:solidFill>
+                  <a:srgbClr val="0F1522"/>
+                </a:solidFill>
+                <a:latin typeface="Arial" pitchFamily="34" charset="0"/>
+                <a:ea typeface="Arial" pitchFamily="34" charset="-122"/>
+                <a:cs typeface="Arial" pitchFamily="34" charset="-120"/>
+              </a:rPr>
+              <a:t>How does it work out a deficit?</a:t>
+            </a:r>
+            <a:endParaRPr lang="en-GB" sz="1400" dirty="0"/>
+          </a:p>
+        </p:txBody>
+      </p:sp>
+      <p:sp>
+        <p:nvSpPr>
+          <p:cNvPr id="6" name="Text 6"/>
+          <p:cNvSpPr txBox="1"/>
+          <p:nvPr/>
+        </p:nvSpPr>
+        <p:spPr>
+          <a:xfrm>
+            <a:off x="822960" y="2514600"/>
+            <a:ext cx="2980944" cy="1257300"/>
+          </a:xfrm>
+          <a:prstGeom prst="rect">
+            <a:avLst/>
+          </a:prstGeom>
+          <a:noFill/>
+          <a:ln/>
+        </p:spPr>
+        <p:txBody>
+          <a:bodyPr wrap="square" lIns="0" tIns="0" rIns="0" bIns="0" rtlCol="0" anchor="t"/>
+          <a:lstStyle/>
+          <a:p>
+            <a:pPr indent="0" marL="0">
+              <a:lnSpc>
+                <a:spcPts val="1650"/>
+              </a:lnSpc>
+              <a:buNone/>
+            </a:pPr>
+            <a:r>
+              <a:rPr lang="en-GB" sz="1200" dirty="0">
+                <a:solidFill>
+                  <a:srgbClr val="4B5565"/>
+                </a:solidFill>
+                <a:latin typeface="Calibri" pitchFamily="34" charset="0"/>
+                <a:ea typeface="Calibri" pitchFamily="34" charset="-122"/>
+                <a:cs typeface="Calibri" pitchFamily="34" charset="-120"/>
+              </a:rPr>
+              <a:t>Your starting balance, plus each finished week's credits minus that week's target (rostered hours × 80%, less NPT). Below zero is a deficit. This week counts once it ends.</a:t>
+            </a:r>
+            <a:endParaRPr lang="en-GB" sz="1200" dirty="0"/>
+          </a:p>
+        </p:txBody>
+      </p:sp>
+      <p:sp>
+        <p:nvSpPr>
+          <p:cNvPr id="7" name="Card 7"/>
+          <p:cNvSpPr/>
+          <p:nvPr/>
+        </p:nvSpPr>
+        <p:spPr>
+          <a:xfrm>
+            <a:off x="4334256" y="1737360"/>
+            <a:ext cx="3493008" cy="2217420"/>
+          </a:xfrm>
+          <a:prstGeom prst="roundRect">
+            <a:avLst>
+              <a:gd name="adj" fmla="val 4800"/>
+            </a:avLst>
+          </a:prstGeom>
+          <a:solidFill>
+            <a:srgbClr val="F2F2F7"/>
+          </a:solidFill>
+          <a:ln w="12700">
+            <a:solidFill>
+              <a:srgbClr val="DDE3EC"/>
+            </a:solidFill>
+            <a:prstDash val="solid"/>
+          </a:ln>
+        </p:spPr>
+      </p:sp>
+      <p:sp>
+        <p:nvSpPr>
+          <p:cNvPr id="8" name="Text 8"/>
+          <p:cNvSpPr txBox="1"/>
+          <p:nvPr/>
+        </p:nvSpPr>
+        <p:spPr>
+          <a:xfrm>
+            <a:off x="4590288" y="1965960"/>
+            <a:ext cx="2980944" cy="502920"/>
+          </a:xfrm>
+          <a:prstGeom prst="rect">
+            <a:avLst/>
+          </a:prstGeom>
+          <a:noFill/>
+          <a:ln/>
+        </p:spPr>
+        <p:txBody>
+          <a:bodyPr wrap="square" lIns="0" tIns="0" rIns="0" bIns="0" rtlCol="0" anchor="t"/>
+          <a:lstStyle/>
+          <a:p>
+            <a:pPr indent="0" marL="0">
+              <a:lnSpc>
+                <a:spcPts val="1800"/>
+              </a:lnSpc>
+              <a:buNone/>
+            </a:pPr>
+            <a:r>
+              <a:rPr lang="en-GB" sz="1400" b="1" dirty="0">
+                <a:solidFill>
+                  <a:srgbClr val="0F1522"/>
+                </a:solidFill>
+                <a:latin typeface="Arial" pitchFamily="34" charset="0"/>
+                <a:ea typeface="Arial" pitchFamily="34" charset="-122"/>
+                <a:cs typeface="Arial" pitchFamily="34" charset="-120"/>
+              </a:rPr>
+              <a:t>How does Coach help clear a deficit?</a:t>
+            </a:r>
+            <a:endParaRPr lang="en-GB" sz="1400" dirty="0"/>
+          </a:p>
+        </p:txBody>
+      </p:sp>
+      <p:sp>
+        <p:nvSpPr>
+          <p:cNvPr id="9" name="Text 9"/>
+          <p:cNvSpPr txBox="1"/>
+          <p:nvPr/>
+        </p:nvSpPr>
+        <p:spPr>
+          <a:xfrm>
+            <a:off x="4590288" y="2514600"/>
+            <a:ext cx="2980944" cy="1257300"/>
+          </a:xfrm>
+          <a:prstGeom prst="rect">
+            <a:avLst/>
+          </a:prstGeom>
+          <a:noFill/>
+          <a:ln/>
+        </p:spPr>
+        <p:txBody>
+          <a:bodyPr wrap="square" lIns="0" tIns="0" rIns="0" bIns="0" rtlCol="0" anchor="t"/>
+          <a:lstStyle/>
+          <a:p>
+            <a:pPr indent="0" marL="0">
+              <a:lnSpc>
+                <a:spcPts val="1650"/>
+              </a:lnSpc>
+              <a:buNone/>
+            </a:pPr>
+            <a:r>
+              <a:rPr lang="en-GB" sz="1200" dirty="0">
+                <a:solidFill>
+                  <a:srgbClr val="4B5565"/>
+                </a:solidFill>
+                <a:latin typeface="Calibri" pitchFamily="34" charset="0"/>
+                <a:ea typeface="Calibri" pitchFamily="34" charset="-122"/>
+                <a:cs typeface="Calibri" pitchFamily="34" charset="-120"/>
+              </a:rPr>
+              <a:t>It spreads the deficit over the next 20 working days, so 8.40h becomes +0.42h a day on top of target, and says whether last week shrank the deficit or added to it.</a:t>
+            </a:r>
+            <a:endParaRPr lang="en-GB" sz="1200" dirty="0"/>
+          </a:p>
+        </p:txBody>
+      </p:sp>
+      <p:sp>
+        <p:nvSpPr>
+          <p:cNvPr id="10" name="Card 10"/>
+          <p:cNvSpPr/>
+          <p:nvPr/>
+        </p:nvSpPr>
+        <p:spPr>
+          <a:xfrm>
+            <a:off x="8101584" y="1737360"/>
+            <a:ext cx="3493008" cy="2217420"/>
+          </a:xfrm>
+          <a:prstGeom prst="roundRect">
+            <a:avLst>
+              <a:gd name="adj" fmla="val 4800"/>
+            </a:avLst>
+          </a:prstGeom>
+          <a:solidFill>
+            <a:srgbClr val="F2F2F7"/>
+          </a:solidFill>
+          <a:ln w="12700">
+            <a:solidFill>
+              <a:srgbClr val="DDE3EC"/>
+            </a:solidFill>
+            <a:prstDash val="solid"/>
+          </a:ln>
+        </p:spPr>
+      </p:sp>
+      <p:sp>
+        <p:nvSpPr>
+          <p:cNvPr id="11" name="Text 11"/>
+          <p:cNvSpPr txBox="1"/>
+          <p:nvPr/>
+        </p:nvSpPr>
+        <p:spPr>
+          <a:xfrm>
+            <a:off x="8357616" y="1965960"/>
+            <a:ext cx="2980944" cy="502920"/>
+          </a:xfrm>
+          <a:prstGeom prst="rect">
+            <a:avLst/>
+          </a:prstGeom>
+          <a:noFill/>
+          <a:ln/>
+        </p:spPr>
+        <p:txBody>
+          <a:bodyPr wrap="square" lIns="0" tIns="0" rIns="0" bIns="0" rtlCol="0" anchor="t"/>
+          <a:lstStyle/>
+          <a:p>
+            <a:pPr indent="0" marL="0">
+              <a:lnSpc>
+                <a:spcPts val="1800"/>
+              </a:lnSpc>
+              <a:buNone/>
+            </a:pPr>
+            <a:r>
+              <a:rPr lang="en-GB" sz="1400" b="1" dirty="0">
+                <a:solidFill>
+                  <a:srgbClr val="0F1522"/>
+                </a:solidFill>
+                <a:latin typeface="Arial" pitchFamily="34" charset="0"/>
+                <a:ea typeface="Arial" pitchFamily="34" charset="-122"/>
+                <a:cs typeface="Arial" pitchFamily="34" charset="-120"/>
+              </a:rPr>
+              <a:t>What about leave, rest days and mentoring?</a:t>
+            </a:r>
+            <a:endParaRPr lang="en-GB" sz="1400" dirty="0"/>
+          </a:p>
+        </p:txBody>
+      </p:sp>
+      <p:sp>
+        <p:nvSpPr>
+          <p:cNvPr id="12" name="Text 12"/>
+          <p:cNvSpPr txBox="1"/>
+          <p:nvPr/>
+        </p:nvSpPr>
+        <p:spPr>
+          <a:xfrm>
+            <a:off x="8357616" y="2514600"/>
+            <a:ext cx="2980944" cy="1257300"/>
+          </a:xfrm>
+          <a:prstGeom prst="rect">
+            <a:avLst/>
+          </a:prstGeom>
+          <a:noFill/>
+          <a:ln/>
+        </p:spPr>
+        <p:txBody>
+          <a:bodyPr wrap="square" lIns="0" tIns="0" rIns="0" bIns="0" rtlCol="0" anchor="t"/>
+          <a:lstStyle/>
+          <a:p>
+            <a:pPr indent="0" marL="0">
+              <a:lnSpc>
+                <a:spcPts val="1650"/>
+              </a:lnSpc>
+              <a:buNone/>
+            </a:pPr>
+            <a:r>
+              <a:rPr lang="en-GB" sz="1200" dirty="0">
+                <a:solidFill>
+                  <a:srgbClr val="4B5565"/>
+                </a:solidFill>
+                <a:latin typeface="Calibri" pitchFamily="34" charset="0"/>
+                <a:ea typeface="Calibri" pitchFamily="34" charset="-122"/>
+                <a:cs typeface="Calibri" pitchFamily="34" charset="-120"/>
+              </a:rPr>
+              <a:t>Leave takes that day's hours off the week; a rest day (no shift times) doesn't. A full mentor day has no target, and a partial one takes 20% off, as the scheme sets.</a:t>
+            </a:r>
+            <a:endParaRPr lang="en-GB" sz="1200" dirty="0"/>
+          </a:p>
+        </p:txBody>
+      </p:sp>
+      <p:sp>
+        <p:nvSpPr>
+          <p:cNvPr id="13" name="Card 13"/>
+          <p:cNvSpPr/>
+          <p:nvPr/>
+        </p:nvSpPr>
+        <p:spPr>
+          <a:xfrm>
+            <a:off x="566928" y="4183380"/>
+            <a:ext cx="3493008" cy="2217420"/>
+          </a:xfrm>
+          <a:prstGeom prst="roundRect">
+            <a:avLst>
+              <a:gd name="adj" fmla="val 4800"/>
+            </a:avLst>
+          </a:prstGeom>
+          <a:solidFill>
+            <a:srgbClr val="F2F2F7"/>
+          </a:solidFill>
+          <a:ln w="12700">
+            <a:solidFill>
+              <a:srgbClr val="DDE3EC"/>
+            </a:solidFill>
+            <a:prstDash val="solid"/>
+          </a:ln>
+        </p:spPr>
+      </p:sp>
+      <p:sp>
+        <p:nvSpPr>
+          <p:cNvPr id="14" name="Text 14"/>
+          <p:cNvSpPr txBox="1"/>
+          <p:nvPr/>
+        </p:nvSpPr>
+        <p:spPr>
+          <a:xfrm>
+            <a:off x="822960" y="4411980"/>
+            <a:ext cx="2980944" cy="502920"/>
+          </a:xfrm>
+          <a:prstGeom prst="rect">
+            <a:avLst/>
+          </a:prstGeom>
+          <a:noFill/>
+          <a:ln/>
+        </p:spPr>
+        <p:txBody>
+          <a:bodyPr wrap="square" lIns="0" tIns="0" rIns="0" bIns="0" rtlCol="0" anchor="t"/>
+          <a:lstStyle/>
+          <a:p>
+            <a:pPr indent="0" marL="0">
+              <a:lnSpc>
+                <a:spcPts val="1800"/>
+              </a:lnSpc>
+              <a:buNone/>
+            </a:pPr>
+            <a:r>
+              <a:rPr lang="en-GB" sz="1400" b="1" dirty="0">
+                <a:solidFill>
+                  <a:srgbClr val="0F1522"/>
+                </a:solidFill>
+                <a:latin typeface="Arial" pitchFamily="34" charset="0"/>
+                <a:ea typeface="Arial" pitchFamily="34" charset="-122"/>
+                <a:cs typeface="Arial" pitchFamily="34" charset="-120"/>
+              </a:rPr>
+              <a:t>What if a week wasn't a fair test?</a:t>
+            </a:r>
+            <a:endParaRPr lang="en-GB" sz="1400" dirty="0"/>
+          </a:p>
+        </p:txBody>
+      </p:sp>
+      <p:sp>
+        <p:nvSpPr>
+          <p:cNvPr id="15" name="Text 15"/>
+          <p:cNvSpPr txBox="1"/>
+          <p:nvPr/>
+        </p:nvSpPr>
+        <p:spPr>
+          <a:xfrm>
+            <a:off x="822960" y="4960620"/>
+            <a:ext cx="2980944" cy="1257300"/>
+          </a:xfrm>
+          <a:prstGeom prst="rect">
+            <a:avLst/>
+          </a:prstGeom>
+          <a:noFill/>
+          <a:ln/>
+        </p:spPr>
+        <p:txBody>
+          <a:bodyPr wrap="square" lIns="0" tIns="0" rIns="0" bIns="0" rtlCol="0" anchor="t"/>
+          <a:lstStyle/>
+          <a:p>
+            <a:pPr indent="0" marL="0">
+              <a:lnSpc>
+                <a:spcPts val="1650"/>
+              </a:lnSpc>
+              <a:buNone/>
+            </a:pPr>
+            <a:r>
+              <a:rPr lang="en-GB" sz="1200" dirty="0">
+                <a:solidFill>
+                  <a:srgbClr val="4B5565"/>
+                </a:solidFill>
+                <a:latin typeface="Calibri" pitchFamily="34" charset="0"/>
+                <a:ea typeface="Calibri" pitchFamily="34" charset="-122"/>
+                <a:cs typeface="Calibri" pitchFamily="34" charset="-120"/>
+              </a:rPr>
+              <a:t>Untick "In CTAP" for that week in History, for full sickness or a phased return, say. The week stays visible but leaves the balance alone.</a:t>
+            </a:r>
+            <a:endParaRPr lang="en-GB" sz="1200" dirty="0"/>
+          </a:p>
+        </p:txBody>
+      </p:sp>
+      <p:sp>
+        <p:nvSpPr>
+          <p:cNvPr id="16" name="Card 16"/>
+          <p:cNvSpPr/>
+          <p:nvPr/>
+        </p:nvSpPr>
+        <p:spPr>
+          <a:xfrm>
+            <a:off x="4334256" y="4183380"/>
+            <a:ext cx="3493008" cy="2217420"/>
+          </a:xfrm>
+          <a:prstGeom prst="roundRect">
+            <a:avLst>
+              <a:gd name="adj" fmla="val 4800"/>
+            </a:avLst>
+          </a:prstGeom>
+          <a:solidFill>
+            <a:srgbClr val="F2F2F7"/>
+          </a:solidFill>
+          <a:ln w="12700">
+            <a:solidFill>
+              <a:srgbClr val="DDE3EC"/>
+            </a:solidFill>
+            <a:prstDash val="solid"/>
+          </a:ln>
+        </p:spPr>
+      </p:sp>
+      <p:sp>
+        <p:nvSpPr>
+          <p:cNvPr id="17" name="Text 17"/>
+          <p:cNvSpPr txBox="1"/>
+          <p:nvPr/>
+        </p:nvSpPr>
+        <p:spPr>
+          <a:xfrm>
+            <a:off x="4590288" y="4411980"/>
+            <a:ext cx="2980944" cy="502920"/>
+          </a:xfrm>
+          <a:prstGeom prst="rect">
+            <a:avLst/>
+          </a:prstGeom>
+          <a:noFill/>
+          <a:ln/>
+        </p:spPr>
+        <p:txBody>
+          <a:bodyPr wrap="square" lIns="0" tIns="0" rIns="0" bIns="0" rtlCol="0" anchor="t"/>
+          <a:lstStyle/>
+          <a:p>
+            <a:pPr indent="0" marL="0">
+              <a:lnSpc>
+                <a:spcPts val="1800"/>
+              </a:lnSpc>
+              <a:buNone/>
+            </a:pPr>
+            <a:r>
+              <a:rPr lang="en-GB" sz="1400" b="1" dirty="0">
+                <a:solidFill>
+                  <a:srgbClr val="0F1522"/>
+                </a:solidFill>
+                <a:latin typeface="Arial" pitchFamily="34" charset="0"/>
+                <a:ea typeface="Arial" pitchFamily="34" charset="-122"/>
+                <a:cs typeface="Arial" pitchFamily="34" charset="-120"/>
+              </a:rPr>
+              <a:t>What counts as NPT?</a:t>
+            </a:r>
+            <a:endParaRPr lang="en-GB" sz="1400" dirty="0"/>
+          </a:p>
+        </p:txBody>
+      </p:sp>
+      <p:sp>
+        <p:nvSpPr>
+          <p:cNvPr id="18" name="Text 18"/>
+          <p:cNvSpPr txBox="1"/>
+          <p:nvPr/>
+        </p:nvSpPr>
+        <p:spPr>
+          <a:xfrm>
+            <a:off x="4590288" y="4960620"/>
+            <a:ext cx="2980944" cy="1257300"/>
+          </a:xfrm>
+          <a:prstGeom prst="rect">
+            <a:avLst/>
+          </a:prstGeom>
+          <a:noFill/>
+          <a:ln/>
+        </p:spPr>
+        <p:txBody>
+          <a:bodyPr wrap="square" lIns="0" tIns="0" rIns="0" bIns="0" rtlCol="0" anchor="t"/>
+          <a:lstStyle/>
+          <a:p>
+            <a:pPr indent="0" marL="0">
+              <a:lnSpc>
+                <a:spcPts val="1650"/>
+              </a:lnSpc>
+              <a:buNone/>
+            </a:pPr>
+            <a:r>
+              <a:rPr lang="en-GB" sz="1200" dirty="0">
+                <a:solidFill>
+                  <a:srgbClr val="4B5565"/>
+                </a:solidFill>
+                <a:latin typeface="Calibri" pitchFamily="34" charset="0"/>
+                <a:ea typeface="Calibri" pitchFamily="34" charset="-122"/>
+                <a:cs typeface="Calibri" pitchFamily="34" charset="-120"/>
+              </a:rPr>
+              <a:t>Time on the clock the scheme doesn't pay for, like an early finish. It comes off that week's target after the 80%. Wait time, EV charging and Bybox collections earn credits instead.</a:t>
+            </a:r>
+            <a:endParaRPr lang="en-GB" sz="1200" dirty="0"/>
+          </a:p>
+        </p:txBody>
+      </p:sp>
+      <p:sp>
+        <p:nvSpPr>
+          <p:cNvPr id="19" name="Card 19"/>
+          <p:cNvSpPr/>
+          <p:nvPr/>
+        </p:nvSpPr>
+        <p:spPr>
+          <a:xfrm>
+            <a:off x="8101584" y="4183380"/>
+            <a:ext cx="3493008" cy="2217420"/>
+          </a:xfrm>
+          <a:prstGeom prst="roundRect">
+            <a:avLst>
+              <a:gd name="adj" fmla="val 4800"/>
+            </a:avLst>
+          </a:prstGeom>
+          <a:solidFill>
+            <a:srgbClr val="F2F2F7"/>
+          </a:solidFill>
+          <a:ln w="12700">
+            <a:solidFill>
+              <a:srgbClr val="DDE3EC"/>
+            </a:solidFill>
+            <a:prstDash val="solid"/>
+          </a:ln>
+        </p:spPr>
+      </p:sp>
+      <p:sp>
+        <p:nvSpPr>
+          <p:cNvPr id="20" name="Text 20"/>
+          <p:cNvSpPr txBox="1"/>
+          <p:nvPr/>
+        </p:nvSpPr>
+        <p:spPr>
+          <a:xfrm>
+            <a:off x="8357616" y="4411980"/>
+            <a:ext cx="2980944" cy="502920"/>
+          </a:xfrm>
+          <a:prstGeom prst="rect">
+            <a:avLst/>
+          </a:prstGeom>
+          <a:noFill/>
+          <a:ln/>
+        </p:spPr>
+        <p:txBody>
+          <a:bodyPr wrap="square" lIns="0" tIns="0" rIns="0" bIns="0" rtlCol="0" anchor="t"/>
+          <a:lstStyle/>
+          <a:p>
+            <a:pPr indent="0" marL="0">
+              <a:lnSpc>
+                <a:spcPts val="1800"/>
+              </a:lnSpc>
+              <a:buNone/>
+            </a:pPr>
+            <a:r>
+              <a:rPr lang="en-GB" sz="1400" b="1" dirty="0">
+                <a:solidFill>
+                  <a:srgbClr val="0F1522"/>
+                </a:solidFill>
+                <a:latin typeface="Arial" pitchFamily="34" charset="0"/>
+                <a:ea typeface="Arial" pitchFamily="34" charset="-122"/>
+                <a:cs typeface="Arial" pitchFamily="34" charset="-120"/>
+              </a:rPr>
+              <a:t>Can my manager see my figures?</a:t>
+            </a:r>
+            <a:endParaRPr lang="en-GB" sz="1400" dirty="0"/>
+          </a:p>
+        </p:txBody>
+      </p:sp>
+      <p:sp>
+        <p:nvSpPr>
+          <p:cNvPr id="21" name="Text 21"/>
+          <p:cNvSpPr txBox="1"/>
+          <p:nvPr/>
+        </p:nvSpPr>
+        <p:spPr>
+          <a:xfrm>
+            <a:off x="8357616" y="4960620"/>
+            <a:ext cx="2980944" cy="1257300"/>
+          </a:xfrm>
+          <a:prstGeom prst="rect">
+            <a:avLst/>
+          </a:prstGeom>
+          <a:noFill/>
+          <a:ln/>
+        </p:spPr>
+        <p:txBody>
+          <a:bodyPr wrap="square" lIns="0" tIns="0" rIns="0" bIns="0" rtlCol="0" anchor="t"/>
+          <a:lstStyle/>
+          <a:p>
+            <a:pPr indent="0" marL="0">
+              <a:lnSpc>
+                <a:spcPts val="1650"/>
+              </a:lnSpc>
+              <a:buNone/>
+            </a:pPr>
+            <a:r>
+              <a:rPr lang="en-GB" sz="1200" dirty="0">
+                <a:solidFill>
+                  <a:srgbClr val="4B5565"/>
+                </a:solidFill>
+                <a:latin typeface="Calibri" pitchFamily="34" charset="0"/>
+                <a:ea typeface="Calibri" pitchFamily="34" charset="-122"/>
+                <a:cs typeface="Calibri" pitchFamily="34" charset="-120"/>
+              </a:rPr>
+              <a:t>No. There's no account and nothing is uploaded, so everything stays on the engineer's phone. The flip side is there's no backup if the phone is lost or the app is deleted.</a:t>
+            </a:r>
+            <a:endParaRPr lang="en-GB" sz="1200" dirty="0"/>
+          </a:p>
+        </p:txBody>
+      </p:sp>
+    </p:spTree>
+  </p:cSld>
+  <p:clrMapOvr>
+    <a:masterClrMapping/>
+  </p:clrMapOvr>
+</p:sld>
+</file>
+
 <file path=ppt/slides/slide2.xml><?xml version="1.0" encoding="utf-8"?>
 <p:sld xmlns:a="http://schemas.openxmlformats.org/drawingml/2006/main" xmlns:r="http://schemas.openxmlformats.org/officeDocument/2006/relationships" xmlns:p="http://schemas.openxmlformats.org/presentationml/2006/main">
   <p:cSld name="Slide 2">
@@ -7469,7 +9201,7 @@
                 <a:ea typeface="Arial" pitchFamily="34" charset="-122"/>
                 <a:cs typeface="Arial" pitchFamily="34" charset="-120"/>
               </a:rPr>
-              <a:t>ENGINEERS</a:t>
+              <a:t>ENGINEERS WANTED</a:t>
             </a:r>
             <a:endParaRPr lang="en-US" sz="900" dirty="0"/>
           </a:p>

</xml_diff>

<commit_message>
Park the FAQ slides until the trial has its first engineers
The FAQs will go out once the first ten engineers are on the trial, not with
the email that recruits them. The two slides are removed; they are kept in
the previous commit (c5cc7f8) to bring back later. "10 engineers wanted" on
the Trial slide stays.

Co-Authored-By: Claude Opus 5 <noreply@anthropic.com>
</commit_message>
<xml_diff>
--- a/docs/presentation/CTAP-Tracker.pptx
+++ b/docs/presentation/CTAP-Tracker.pptx
@@ -15,8 +15,6 @@
     <p:sldId id="262" r:id="rId8"/>
     <p:sldId id="263" r:id="rId9"/>
     <p:sldId id="264" r:id="rId10"/>
-    <p:sldId id="267" r:id="rId18"/>
-    <p:sldId id="268" r:id="rId19"/>
     <p:sldId id="265" r:id="rId11"/>
   </p:sldIdLst>
   <p:notesMasterIdLst>
@@ -723,182 +721,6 @@
     <p:extLst>
       <p:ext uri="{BB962C8B-B14F-4D97-AF65-F5344CB8AC3E}">
         <p14:creationId xmlns:p14="http://schemas.microsoft.com/office/powerpoint/2010/main" val="2091734615"/>
-      </p:ext>
-    </p:extLst>
-  </p:cSld>
-  <p:clrMapOvr>
-    <a:masterClrMapping/>
-  </p:clrMapOvr>
-</p:notes>
-</file>
-
-<file path=ppt/notesSlides/notesSlide12.xml><?xml version="1.0" encoding="utf-8"?>
-<p:notes xmlns:a="http://schemas.openxmlformats.org/drawingml/2006/main" xmlns:r="http://schemas.openxmlformats.org/officeDocument/2006/relationships" xmlns:p="http://schemas.openxmlformats.org/presentationml/2006/main">
-  <p:cSld>
-    <p:spTree>
-      <p:nvGrpSpPr>
-        <p:cNvPr id="1" name=""/>
-        <p:cNvGrpSpPr/>
-        <p:nvPr/>
-      </p:nvGrpSpPr>
-      <p:grpSpPr>
-        <a:xfrm>
-          <a:off x="0" y="0"/>
-          <a:ext cx="0" cy="0"/>
-          <a:chOff x="0" y="0"/>
-          <a:chExt cx="0" cy="0"/>
-        </a:xfrm>
-      </p:grpSpPr>
-      <p:sp>
-        <p:nvSpPr>
-          <p:cNvPr id="2" name="Slide Image Placeholder 1"/>
-          <p:cNvSpPr>
-            <a:spLocks noGrp="1" noRot="1" noChangeAspect="1"/>
-          </p:cNvSpPr>
-          <p:nvPr>
-            <p:ph type="sldImg"/>
-          </p:nvPr>
-        </p:nvSpPr>
-        <p:spPr/>
-      </p:sp>
-      <p:sp>
-        <p:nvSpPr>
-          <p:cNvPr id="3" name="Notes Placeholder 2"/>
-          <p:cNvSpPr>
-            <a:spLocks noGrp="1"/>
-          </p:cNvSpPr>
-          <p:nvPr>
-            <p:ph type="body" idx="1"/>
-          </p:nvPr>
-        </p:nvSpPr>
-        <p:spPr/>
-        <p:txBody>
-          <a:bodyPr/>
-          <a:lstStyle/>
-          <a:p>
-            <a:r>
-              <a:rPr lang="en-GB" dirty="0"/>
-              <a:t>The questions a manager or an engineer asks first: where the credit values come from, how the target is set, and how travel is allowed for. Every answer describes what the app does today.</a:t>
-            </a:r>
-            <a:endParaRPr lang="en-GB" dirty="0"/>
-          </a:p>
-        </p:txBody>
-      </p:sp>
-      <p:sp>
-        <p:nvSpPr>
-          <p:cNvPr id="4" name="Slide Number Placeholder 3"/>
-          <p:cNvSpPr>
-            <a:spLocks noGrp="1"/>
-          </p:cNvSpPr>
-          <p:nvPr>
-            <p:ph type="sldNum" sz="quarter" idx="10"/>
-          </p:nvPr>
-        </p:nvSpPr>
-        <p:spPr/>
-        <p:txBody>
-          <a:bodyPr/>
-          <a:lstStyle/>
-          <a:p>
-            <a:fld id="{F7021451-1387-4CA6-816F-3879F97B5CBC}" type="slidenum">
-              <a:rPr lang="en-GB"/>
-              <a:t>11</a:t>
-            </a:fld>
-            <a:endParaRPr lang="en-GB"/>
-          </a:p>
-        </p:txBody>
-      </p:sp>
-    </p:spTree>
-    <p:extLst>
-      <p:ext uri="{BB962C8B-B14F-4D97-AF65-F5344CB8AC3E}">
-        <p14:creationId xmlns:p14="http://schemas.microsoft.com/office/powerpoint/2010/main" val="1840527391"/>
-      </p:ext>
-    </p:extLst>
-  </p:cSld>
-  <p:clrMapOvr>
-    <a:masterClrMapping/>
-  </p:clrMapOvr>
-</p:notes>
-</file>
-
-<file path=ppt/notesSlides/notesSlide13.xml><?xml version="1.0" encoding="utf-8"?>
-<p:notes xmlns:a="http://schemas.openxmlformats.org/drawingml/2006/main" xmlns:r="http://schemas.openxmlformats.org/officeDocument/2006/relationships" xmlns:p="http://schemas.openxmlformats.org/presentationml/2006/main">
-  <p:cSld>
-    <p:spTree>
-      <p:nvGrpSpPr>
-        <p:cNvPr id="1" name=""/>
-        <p:cNvGrpSpPr/>
-        <p:nvPr/>
-      </p:nvGrpSpPr>
-      <p:grpSpPr>
-        <a:xfrm>
-          <a:off x="0" y="0"/>
-          <a:ext cx="0" cy="0"/>
-          <a:chOff x="0" y="0"/>
-          <a:chExt cx="0" cy="0"/>
-        </a:xfrm>
-      </p:grpSpPr>
-      <p:sp>
-        <p:nvSpPr>
-          <p:cNvPr id="2" name="Slide Image Placeholder 1"/>
-          <p:cNvSpPr>
-            <a:spLocks noGrp="1" noRot="1" noChangeAspect="1"/>
-          </p:cNvSpPr>
-          <p:nvPr>
-            <p:ph type="sldImg"/>
-          </p:nvPr>
-        </p:nvSpPr>
-        <p:spPr/>
-      </p:sp>
-      <p:sp>
-        <p:nvSpPr>
-          <p:cNvPr id="3" name="Notes Placeholder 2"/>
-          <p:cNvSpPr>
-            <a:spLocks noGrp="1"/>
-          </p:cNvSpPr>
-          <p:nvPr>
-            <p:ph type="body" idx="1"/>
-          </p:nvPr>
-        </p:nvSpPr>
-        <p:spPr/>
-        <p:txBody>
-          <a:bodyPr/>
-          <a:lstStyle/>
-          <a:p>
-            <a:r>
-              <a:rPr lang="en-GB" dirty="0"/>
-              <a:t>How the balance and a deficit are worked out, and what changes a week's target. The privacy answer is the same one as the Where the figures live slide.</a:t>
-            </a:r>
-            <a:endParaRPr lang="en-GB" dirty="0"/>
-          </a:p>
-        </p:txBody>
-      </p:sp>
-      <p:sp>
-        <p:nvSpPr>
-          <p:cNvPr id="4" name="Slide Number Placeholder 3"/>
-          <p:cNvSpPr>
-            <a:spLocks noGrp="1"/>
-          </p:cNvSpPr>
-          <p:nvPr>
-            <p:ph type="sldNum" sz="quarter" idx="10"/>
-          </p:nvPr>
-        </p:nvSpPr>
-        <p:spPr/>
-        <p:txBody>
-          <a:bodyPr/>
-          <a:lstStyle/>
-          <a:p>
-            <a:fld id="{F7021451-1387-4CA6-816F-3879F97B5CBC}" type="slidenum">
-              <a:rPr lang="en-GB"/>
-              <a:t>12</a:t>
-            </a:fld>
-            <a:endParaRPr lang="en-GB"/>
-          </a:p>
-        </p:txBody>
-      </p:sp>
-    </p:spTree>
-    <p:extLst>
-      <p:ext uri="{BB962C8B-B14F-4D97-AF65-F5344CB8AC3E}">
-        <p14:creationId xmlns:p14="http://schemas.microsoft.com/office/powerpoint/2010/main" val="1840527392"/>
       </p:ext>
     </p:extLst>
   </p:cSld>
@@ -3001,1560 +2823,6 @@
 </p:sld>
 </file>
 
-<file path=ppt/slides/slide12.xml><?xml version="1.0" encoding="utf-8"?>
-<p:sld xmlns:a="http://schemas.openxmlformats.org/drawingml/2006/main" xmlns:r="http://schemas.openxmlformats.org/officeDocument/2006/relationships" xmlns:p="http://schemas.openxmlformats.org/presentationml/2006/main">
-  <p:cSld name="Slide 11">
-    <p:bg>
-      <p:bgPr>
-        <a:solidFill>
-          <a:srgbClr val="FFFFFF"/>
-        </a:solidFill>
-        <a:effectLst/>
-      </p:bgPr>
-    </p:bg>
-    <p:spTree>
-      <p:nvGrpSpPr>
-        <p:cNvPr id="1" name=""/>
-        <p:cNvGrpSpPr/>
-        <p:nvPr/>
-      </p:nvGrpSpPr>
-      <p:grpSpPr>
-        <a:xfrm>
-          <a:off x="0" y="0"/>
-          <a:ext cx="0" cy="0"/>
-          <a:chOff x="0" y="0"/>
-          <a:chExt cx="0" cy="0"/>
-        </a:xfrm>
-      </p:grpSpPr>
-      <p:sp>
-        <p:nvSpPr>
-          <p:cNvPr id="2" name="Text 2"/>
-          <p:cNvSpPr txBox="1"/>
-          <p:nvPr/>
-        </p:nvSpPr>
-        <p:spPr>
-          <a:xfrm>
-            <a:off x="566928" y="566928"/>
-            <a:ext cx="10058400" cy="237744"/>
-          </a:xfrm>
-          <a:prstGeom prst="rect">
-            <a:avLst/>
-          </a:prstGeom>
-          <a:noFill/>
-          <a:ln/>
-        </p:spPr>
-        <p:txBody>
-          <a:bodyPr wrap="square" lIns="0" tIns="0" rIns="0" bIns="0" rtlCol="0" anchor="ctr"/>
-          <a:lstStyle/>
-          <a:p>
-            <a:pPr indent="0" marL="0">
-              <a:buNone/>
-            </a:pPr>
-            <a:r>
-              <a:rPr lang="en-GB" sz="1100" b="1" spc="240" kern="0" dirty="0">
-                <a:solidFill>
-                  <a:srgbClr val="2F6BC4"/>
-                </a:solidFill>
-                <a:latin typeface="Arial" pitchFamily="34" charset="0"/>
-                <a:ea typeface="Arial" pitchFamily="34" charset="-122"/>
-                <a:cs typeface="Arial" pitchFamily="34" charset="-120"/>
-              </a:rPr>
-              <a:t>QUESTIONS PEOPLE ASK</a:t>
-            </a:r>
-            <a:endParaRPr lang="en-GB" sz="1100" dirty="0"/>
-          </a:p>
-        </p:txBody>
-      </p:sp>
-      <p:sp>
-        <p:nvSpPr>
-          <p:cNvPr id="3" name="Text 3"/>
-          <p:cNvSpPr txBox="1"/>
-          <p:nvPr/>
-        </p:nvSpPr>
-        <p:spPr>
-          <a:xfrm>
-            <a:off x="566928" y="877824"/>
-            <a:ext cx="10058400" cy="640080"/>
-          </a:xfrm>
-          <a:prstGeom prst="rect">
-            <a:avLst/>
-          </a:prstGeom>
-          <a:noFill/>
-          <a:ln/>
-        </p:spPr>
-        <p:txBody>
-          <a:bodyPr wrap="square" lIns="0" tIns="0" rIns="0" bIns="0" rtlCol="0" anchor="ctr"/>
-          <a:lstStyle/>
-          <a:p>
-            <a:pPr indent="0" marL="0">
-              <a:buNone/>
-            </a:pPr>
-            <a:r>
-              <a:rPr lang="en-GB" sz="3200" b="1" dirty="0">
-                <a:solidFill>
-                  <a:srgbClr val="0F1522"/>
-                </a:solidFill>
-                <a:latin typeface="Arial" pitchFamily="34" charset="0"/>
-                <a:ea typeface="Arial" pitchFamily="34" charset="-122"/>
-                <a:cs typeface="Arial" pitchFamily="34" charset="-120"/>
-              </a:rPr>
-              <a:t>Where the numbers come from.</a:t>
-            </a:r>
-            <a:endParaRPr lang="en-GB" sz="3200" dirty="0"/>
-          </a:p>
-        </p:txBody>
-      </p:sp>
-      <p:sp>
-        <p:nvSpPr>
-          <p:cNvPr id="4" name="Card 4"/>
-          <p:cNvSpPr/>
-          <p:nvPr/>
-        </p:nvSpPr>
-        <p:spPr>
-          <a:xfrm>
-            <a:off x="566928" y="1737360"/>
-            <a:ext cx="3493008" cy="2217420"/>
-          </a:xfrm>
-          <a:prstGeom prst="roundRect">
-            <a:avLst>
-              <a:gd name="adj" fmla="val 4800"/>
-            </a:avLst>
-          </a:prstGeom>
-          <a:solidFill>
-            <a:srgbClr val="F2F2F7"/>
-          </a:solidFill>
-          <a:ln w="12700">
-            <a:solidFill>
-              <a:srgbClr val="DDE3EC"/>
-            </a:solidFill>
-            <a:prstDash val="solid"/>
-          </a:ln>
-        </p:spPr>
-      </p:sp>
-      <p:sp>
-        <p:nvSpPr>
-          <p:cNvPr id="5" name="Text 5"/>
-          <p:cNvSpPr txBox="1"/>
-          <p:nvPr/>
-        </p:nvSpPr>
-        <p:spPr>
-          <a:xfrm>
-            <a:off x="822960" y="1965960"/>
-            <a:ext cx="2980944" cy="502920"/>
-          </a:xfrm>
-          <a:prstGeom prst="rect">
-            <a:avLst/>
-          </a:prstGeom>
-          <a:noFill/>
-          <a:ln/>
-        </p:spPr>
-        <p:txBody>
-          <a:bodyPr wrap="square" lIns="0" tIns="0" rIns="0" bIns="0" rtlCol="0" anchor="t"/>
-          <a:lstStyle/>
-          <a:p>
-            <a:pPr indent="0" marL="0">
-              <a:lnSpc>
-                <a:spcPts val="1800"/>
-              </a:lnSpc>
-              <a:buNone/>
-            </a:pPr>
-            <a:r>
-              <a:rPr lang="en-GB" sz="1400" b="1" dirty="0">
-                <a:solidFill>
-                  <a:srgbClr val="0F1522"/>
-                </a:solidFill>
-                <a:latin typeface="Arial" pitchFamily="34" charset="0"/>
-                <a:ea typeface="Arial" pitchFamily="34" charset="-122"/>
-                <a:cs typeface="Arial" pitchFamily="34" charset="-120"/>
-              </a:rPr>
-              <a:t>Where do the job credit values come from?</a:t>
-            </a:r>
-            <a:endParaRPr lang="en-GB" sz="1400" dirty="0"/>
-          </a:p>
-        </p:txBody>
-      </p:sp>
-      <p:sp>
-        <p:nvSpPr>
-          <p:cNvPr id="6" name="Text 6"/>
-          <p:cNvSpPr txBox="1"/>
-          <p:nvPr/>
-        </p:nvSpPr>
-        <p:spPr>
-          <a:xfrm>
-            <a:off x="822960" y="2514600"/>
-            <a:ext cx="2980944" cy="1257300"/>
-          </a:xfrm>
-          <a:prstGeom prst="rect">
-            <a:avLst/>
-          </a:prstGeom>
-          <a:noFill/>
-          <a:ln/>
-        </p:spPr>
-        <p:txBody>
-          <a:bodyPr wrap="square" lIns="0" tIns="0" rIns="0" bIns="0" rtlCol="0" anchor="t"/>
-          <a:lstStyle/>
-          <a:p>
-            <a:pPr indent="0" marL="0">
-              <a:lnSpc>
-                <a:spcPts val="1650"/>
-              </a:lnSpc>
-              <a:buNone/>
-            </a:pPr>
-            <a:r>
-              <a:rPr lang="en-GB" sz="1200" dirty="0">
-                <a:solidFill>
-                  <a:srgbClr val="4B5565"/>
-                </a:solidFill>
-                <a:latin typeface="Calibri" pitchFamily="34" charset="0"/>
-                <a:ea typeface="Calibri" pitchFamily="34" charset="-122"/>
-                <a:cs typeface="Calibri" pitchFamily="34" charset="-120"/>
-              </a:rPr>
-              <a:t>Centrica's sheet ID1923, Job Codes &amp; Credits. Each job uses the sheet's credit minutes, and one credit is 83.58 minutes. Nine older values are still being checked against the sheet.</a:t>
-            </a:r>
-            <a:endParaRPr lang="en-GB" sz="1200" dirty="0"/>
-          </a:p>
-        </p:txBody>
-      </p:sp>
-      <p:sp>
-        <p:nvSpPr>
-          <p:cNvPr id="7" name="Card 7"/>
-          <p:cNvSpPr/>
-          <p:nvPr/>
-        </p:nvSpPr>
-        <p:spPr>
-          <a:xfrm>
-            <a:off x="4334256" y="1737360"/>
-            <a:ext cx="3493008" cy="2217420"/>
-          </a:xfrm>
-          <a:prstGeom prst="roundRect">
-            <a:avLst>
-              <a:gd name="adj" fmla="val 4800"/>
-            </a:avLst>
-          </a:prstGeom>
-          <a:solidFill>
-            <a:srgbClr val="F2F2F7"/>
-          </a:solidFill>
-          <a:ln w="12700">
-            <a:solidFill>
-              <a:srgbClr val="DDE3EC"/>
-            </a:solidFill>
-            <a:prstDash val="solid"/>
-          </a:ln>
-        </p:spPr>
-      </p:sp>
-      <p:sp>
-        <p:nvSpPr>
-          <p:cNvPr id="8" name="Text 8"/>
-          <p:cNvSpPr txBox="1"/>
-          <p:nvPr/>
-        </p:nvSpPr>
-        <p:spPr>
-          <a:xfrm>
-            <a:off x="4590288" y="1965960"/>
-            <a:ext cx="2980944" cy="502920"/>
-          </a:xfrm>
-          <a:prstGeom prst="rect">
-            <a:avLst/>
-          </a:prstGeom>
-          <a:noFill/>
-          <a:ln/>
-        </p:spPr>
-        <p:txBody>
-          <a:bodyPr wrap="square" lIns="0" tIns="0" rIns="0" bIns="0" rtlCol="0" anchor="t"/>
-          <a:lstStyle/>
-          <a:p>
-            <a:pPr indent="0" marL="0">
-              <a:lnSpc>
-                <a:spcPts val="1800"/>
-              </a:lnSpc>
-              <a:buNone/>
-            </a:pPr>
-            <a:r>
-              <a:rPr lang="en-GB" sz="1400" b="1" dirty="0">
-                <a:solidFill>
-                  <a:srgbClr val="0F1522"/>
-                </a:solidFill>
-                <a:latin typeface="Arial" pitchFamily="34" charset="0"/>
-                <a:ea typeface="Arial" pitchFamily="34" charset="-122"/>
-                <a:cs typeface="Arial" pitchFamily="34" charset="-120"/>
-              </a:rPr>
-              <a:t>What happens when the credit values change?</a:t>
-            </a:r>
-            <a:endParaRPr lang="en-GB" sz="1400" dirty="0"/>
-          </a:p>
-        </p:txBody>
-      </p:sp>
-      <p:sp>
-        <p:nvSpPr>
-          <p:cNvPr id="9" name="Text 9"/>
-          <p:cNvSpPr txBox="1"/>
-          <p:nvPr/>
-        </p:nvSpPr>
-        <p:spPr>
-          <a:xfrm>
-            <a:off x="4590288" y="2514600"/>
-            <a:ext cx="2980944" cy="1257300"/>
-          </a:xfrm>
-          <a:prstGeom prst="rect">
-            <a:avLst/>
-          </a:prstGeom>
-          <a:noFill/>
-          <a:ln/>
-        </p:spPr>
-        <p:txBody>
-          <a:bodyPr wrap="square" lIns="0" tIns="0" rIns="0" bIns="0" rtlCol="0" anchor="t"/>
-          <a:lstStyle/>
-          <a:p>
-            <a:pPr indent="0" marL="0">
-              <a:lnSpc>
-                <a:spcPts val="1650"/>
-              </a:lnSpc>
-              <a:buNone/>
-            </a:pPr>
-            <a:r>
-              <a:rPr lang="en-GB" sz="1200" dirty="0">
-                <a:solidFill>
-                  <a:srgbClr val="4B5565"/>
-                </a:solidFill>
-                <a:latin typeface="Calibri" pitchFamily="34" charset="0"/>
-                <a:ea typeface="Calibri" pitchFamily="34" charset="-122"/>
-                <a:cs typeface="Calibri" pitchFamily="34" charset="-120"/>
-              </a:rPr>
-              <a:t>The job list is a snapshot of the scheme, so it's updated to match whenever a value changes. Jobs already logged keep the value they were logged with.</a:t>
-            </a:r>
-            <a:endParaRPr lang="en-GB" sz="1200" dirty="0"/>
-          </a:p>
-        </p:txBody>
-      </p:sp>
-      <p:sp>
-        <p:nvSpPr>
-          <p:cNvPr id="10" name="Card 10"/>
-          <p:cNvSpPr/>
-          <p:nvPr/>
-        </p:nvSpPr>
-        <p:spPr>
-          <a:xfrm>
-            <a:off x="8101584" y="1737360"/>
-            <a:ext cx="3493008" cy="2217420"/>
-          </a:xfrm>
-          <a:prstGeom prst="roundRect">
-            <a:avLst>
-              <a:gd name="adj" fmla="val 4800"/>
-            </a:avLst>
-          </a:prstGeom>
-          <a:solidFill>
-            <a:srgbClr val="F2F2F7"/>
-          </a:solidFill>
-          <a:ln w="12700">
-            <a:solidFill>
-              <a:srgbClr val="DDE3EC"/>
-            </a:solidFill>
-            <a:prstDash val="solid"/>
-          </a:ln>
-        </p:spPr>
-      </p:sp>
-      <p:sp>
-        <p:nvSpPr>
-          <p:cNvPr id="11" name="Text 11"/>
-          <p:cNvSpPr txBox="1"/>
-          <p:nvPr/>
-        </p:nvSpPr>
-        <p:spPr>
-          <a:xfrm>
-            <a:off x="8357616" y="1965960"/>
-            <a:ext cx="2980944" cy="502920"/>
-          </a:xfrm>
-          <a:prstGeom prst="rect">
-            <a:avLst/>
-          </a:prstGeom>
-          <a:noFill/>
-          <a:ln/>
-        </p:spPr>
-        <p:txBody>
-          <a:bodyPr wrap="square" lIns="0" tIns="0" rIns="0" bIns="0" rtlCol="0" anchor="t"/>
-          <a:lstStyle/>
-          <a:p>
-            <a:pPr indent="0" marL="0">
-              <a:lnSpc>
-                <a:spcPts val="1800"/>
-              </a:lnSpc>
-              <a:buNone/>
-            </a:pPr>
-            <a:r>
-              <a:rPr lang="en-GB" sz="1400" b="1" dirty="0">
-                <a:solidFill>
-                  <a:srgbClr val="0F1522"/>
-                </a:solidFill>
-                <a:latin typeface="Arial" pitchFamily="34" charset="0"/>
-                <a:ea typeface="Arial" pitchFamily="34" charset="-122"/>
-                <a:cs typeface="Arial" pitchFamily="34" charset="-120"/>
-              </a:rPr>
-              <a:t>How is my weekly target worked out?</a:t>
-            </a:r>
-            <a:endParaRPr lang="en-GB" sz="1400" dirty="0"/>
-          </a:p>
-        </p:txBody>
-      </p:sp>
-      <p:sp>
-        <p:nvSpPr>
-          <p:cNvPr id="12" name="Text 12"/>
-          <p:cNvSpPr txBox="1"/>
-          <p:nvPr/>
-        </p:nvSpPr>
-        <p:spPr>
-          <a:xfrm>
-            <a:off x="8357616" y="2514600"/>
-            <a:ext cx="2980944" cy="1257300"/>
-          </a:xfrm>
-          <a:prstGeom prst="rect">
-            <a:avLst/>
-          </a:prstGeom>
-          <a:noFill/>
-          <a:ln/>
-        </p:spPr>
-        <p:txBody>
-          <a:bodyPr wrap="square" lIns="0" tIns="0" rIns="0" bIns="0" rtlCol="0" anchor="t"/>
-          <a:lstStyle/>
-          <a:p>
-            <a:pPr indent="0" marL="0">
-              <a:lnSpc>
-                <a:spcPts val="1650"/>
-              </a:lnSpc>
-              <a:buNone/>
-            </a:pPr>
-            <a:r>
-              <a:rPr lang="en-GB" sz="1200" dirty="0">
-                <a:solidFill>
-                  <a:srgbClr val="4B5565"/>
-                </a:solidFill>
-                <a:latin typeface="Calibri" pitchFamily="34" charset="0"/>
-                <a:ea typeface="Calibri" pitchFamily="34" charset="-122"/>
-                <a:cs typeface="Calibri" pitchFamily="34" charset="-120"/>
-              </a:rPr>
-              <a:t>Your rostered hours (40, less any leave or mentor days) × 80%, less any NPT you log. After four finished weeks, the week's target becomes the average of your recent weeks.</a:t>
-            </a:r>
-            <a:endParaRPr lang="en-GB" sz="1200" dirty="0"/>
-          </a:p>
-        </p:txBody>
-      </p:sp>
-      <p:sp>
-        <p:nvSpPr>
-          <p:cNvPr id="13" name="Card 13"/>
-          <p:cNvSpPr/>
-          <p:nvPr/>
-        </p:nvSpPr>
-        <p:spPr>
-          <a:xfrm>
-            <a:off x="566928" y="4183380"/>
-            <a:ext cx="3493008" cy="2217420"/>
-          </a:xfrm>
-          <a:prstGeom prst="roundRect">
-            <a:avLst>
-              <a:gd name="adj" fmla="val 4800"/>
-            </a:avLst>
-          </a:prstGeom>
-          <a:solidFill>
-            <a:srgbClr val="F2F2F7"/>
-          </a:solidFill>
-          <a:ln w="12700">
-            <a:solidFill>
-              <a:srgbClr val="DDE3EC"/>
-            </a:solidFill>
-            <a:prstDash val="solid"/>
-          </a:ln>
-        </p:spPr>
-      </p:sp>
-      <p:sp>
-        <p:nvSpPr>
-          <p:cNvPr id="14" name="Text 14"/>
-          <p:cNvSpPr txBox="1"/>
-          <p:nvPr/>
-        </p:nvSpPr>
-        <p:spPr>
-          <a:xfrm>
-            <a:off x="822960" y="4411980"/>
-            <a:ext cx="2980944" cy="502920"/>
-          </a:xfrm>
-          <a:prstGeom prst="rect">
-            <a:avLst/>
-          </a:prstGeom>
-          <a:noFill/>
-          <a:ln/>
-        </p:spPr>
-        <p:txBody>
-          <a:bodyPr wrap="square" lIns="0" tIns="0" rIns="0" bIns="0" rtlCol="0" anchor="t"/>
-          <a:lstStyle/>
-          <a:p>
-            <a:pPr indent="0" marL="0">
-              <a:lnSpc>
-                <a:spcPts val="1800"/>
-              </a:lnSpc>
-              <a:buNone/>
-            </a:pPr>
-            <a:r>
-              <a:rPr lang="en-GB" sz="1400" b="1" dirty="0">
-                <a:solidFill>
-                  <a:srgbClr val="0F1522"/>
-                </a:solidFill>
-                <a:latin typeface="Arial" pitchFamily="34" charset="0"/>
-                <a:ea typeface="Arial" pitchFamily="34" charset="-122"/>
-                <a:cs typeface="Arial" pitchFamily="34" charset="-120"/>
-              </a:rPr>
-              <a:t>Is travel time included?</a:t>
-            </a:r>
-            <a:endParaRPr lang="en-GB" sz="1400" dirty="0"/>
-          </a:p>
-        </p:txBody>
-      </p:sp>
-      <p:sp>
-        <p:nvSpPr>
-          <p:cNvPr id="15" name="Text 15"/>
-          <p:cNvSpPr txBox="1"/>
-          <p:nvPr/>
-        </p:nvSpPr>
-        <p:spPr>
-          <a:xfrm>
-            <a:off x="822960" y="4960620"/>
-            <a:ext cx="2980944" cy="1257300"/>
-          </a:xfrm>
-          <a:prstGeom prst="rect">
-            <a:avLst/>
-          </a:prstGeom>
-          <a:noFill/>
-          <a:ln/>
-        </p:spPr>
-        <p:txBody>
-          <a:bodyPr wrap="square" lIns="0" tIns="0" rIns="0" bIns="0" rtlCol="0" anchor="t"/>
-          <a:lstStyle/>
-          <a:p>
-            <a:pPr indent="0" marL="0">
-              <a:lnSpc>
-                <a:spcPts val="1650"/>
-              </a:lnSpc>
-              <a:buNone/>
-            </a:pPr>
-            <a:r>
-              <a:rPr lang="en-GB" sz="1200" dirty="0">
-                <a:solidFill>
-                  <a:srgbClr val="4B5565"/>
-                </a:solidFill>
-                <a:latin typeface="Calibri" pitchFamily="34" charset="0"/>
-                <a:ea typeface="Calibri" pitchFamily="34" charset="-122"/>
-                <a:cs typeface="Calibri" pitchFamily="34" charset="-120"/>
-              </a:rPr>
-              <a:t>Not directly. Travel isn't credited and isn't logged day to day. The 80% target leaves room for it, and from your fifth week your own average reflects the travel you really do.</a:t>
-            </a:r>
-            <a:endParaRPr lang="en-GB" sz="1200" dirty="0"/>
-          </a:p>
-        </p:txBody>
-      </p:sp>
-      <p:sp>
-        <p:nvSpPr>
-          <p:cNvPr id="16" name="Card 16"/>
-          <p:cNvSpPr/>
-          <p:nvPr/>
-        </p:nvSpPr>
-        <p:spPr>
-          <a:xfrm>
-            <a:off x="4334256" y="4183380"/>
-            <a:ext cx="3493008" cy="2217420"/>
-          </a:xfrm>
-          <a:prstGeom prst="roundRect">
-            <a:avLst>
-              <a:gd name="adj" fmla="val 4800"/>
-            </a:avLst>
-          </a:prstGeom>
-          <a:solidFill>
-            <a:srgbClr val="F2F2F7"/>
-          </a:solidFill>
-          <a:ln w="12700">
-            <a:solidFill>
-              <a:srgbClr val="DDE3EC"/>
-            </a:solidFill>
-            <a:prstDash val="solid"/>
-          </a:ln>
-        </p:spPr>
-      </p:sp>
-      <p:sp>
-        <p:nvSpPr>
-          <p:cNvPr id="17" name="Text 17"/>
-          <p:cNvSpPr txBox="1"/>
-          <p:nvPr/>
-        </p:nvSpPr>
-        <p:spPr>
-          <a:xfrm>
-            <a:off x="4590288" y="4411980"/>
-            <a:ext cx="2980944" cy="502920"/>
-          </a:xfrm>
-          <a:prstGeom prst="rect">
-            <a:avLst/>
-          </a:prstGeom>
-          <a:noFill/>
-          <a:ln/>
-        </p:spPr>
-        <p:txBody>
-          <a:bodyPr wrap="square" lIns="0" tIns="0" rIns="0" bIns="0" rtlCol="0" anchor="t"/>
-          <a:lstStyle/>
-          <a:p>
-            <a:pPr indent="0" marL="0">
-              <a:lnSpc>
-                <a:spcPts val="1800"/>
-              </a:lnSpc>
-              <a:buNone/>
-            </a:pPr>
-            <a:r>
-              <a:rPr lang="en-GB" sz="1400" b="1" dirty="0">
-                <a:solidFill>
-                  <a:srgbClr val="0F1522"/>
-                </a:solidFill>
-                <a:latin typeface="Arial" pitchFamily="34" charset="0"/>
-                <a:ea typeface="Arial" pitchFamily="34" charset="-122"/>
-                <a:cs typeface="Arial" pitchFamily="34" charset="-120"/>
-              </a:rPr>
-              <a:t>What's the logic behind travel?</a:t>
-            </a:r>
-            <a:endParaRPr lang="en-GB" sz="1400" dirty="0"/>
-          </a:p>
-        </p:txBody>
-      </p:sp>
-      <p:sp>
-        <p:nvSpPr>
-          <p:cNvPr id="18" name="Text 18"/>
-          <p:cNvSpPr txBox="1"/>
-          <p:nvPr/>
-        </p:nvSpPr>
-        <p:spPr>
-          <a:xfrm>
-            <a:off x="4590288" y="4960620"/>
-            <a:ext cx="2980944" cy="1257300"/>
-          </a:xfrm>
-          <a:prstGeom prst="rect">
-            <a:avLst/>
-          </a:prstGeom>
-          <a:noFill/>
-          <a:ln/>
-        </p:spPr>
-        <p:txBody>
-          <a:bodyPr wrap="square" lIns="0" tIns="0" rIns="0" bIns="0" rtlCol="0" anchor="t"/>
-          <a:lstStyle/>
-          <a:p>
-            <a:pPr indent="0" marL="0">
-              <a:lnSpc>
-                <a:spcPts val="1650"/>
-              </a:lnSpc>
-              <a:buNone/>
-            </a:pPr>
-            <a:r>
-              <a:rPr lang="en-GB" sz="1200" dirty="0">
-                <a:solidFill>
-                  <a:srgbClr val="4B5565"/>
-                </a:solidFill>
-                <a:latin typeface="Calibri" pitchFamily="34" charset="0"/>
-                <a:ea typeface="Calibri" pitchFamily="34" charset="-122"/>
-                <a:cs typeface="Calibri" pitchFamily="34" charset="-120"/>
-              </a:rPr>
-              <a:t>Travel and Performance Factor take roughly 8 hours a week and can't be measured as you go, so 80% keeps the in-week figures realistic. Travel typed into History is a record only.</a:t>
-            </a:r>
-            <a:endParaRPr lang="en-GB" sz="1200" dirty="0"/>
-          </a:p>
-        </p:txBody>
-      </p:sp>
-      <p:sp>
-        <p:nvSpPr>
-          <p:cNvPr id="19" name="Card 19"/>
-          <p:cNvSpPr/>
-          <p:nvPr/>
-        </p:nvSpPr>
-        <p:spPr>
-          <a:xfrm>
-            <a:off x="8101584" y="4183380"/>
-            <a:ext cx="3493008" cy="2217420"/>
-          </a:xfrm>
-          <a:prstGeom prst="roundRect">
-            <a:avLst>
-              <a:gd name="adj" fmla="val 4800"/>
-            </a:avLst>
-          </a:prstGeom>
-          <a:solidFill>
-            <a:srgbClr val="F2F2F7"/>
-          </a:solidFill>
-          <a:ln w="12700">
-            <a:solidFill>
-              <a:srgbClr val="DDE3EC"/>
-            </a:solidFill>
-            <a:prstDash val="solid"/>
-          </a:ln>
-        </p:spPr>
-      </p:sp>
-      <p:sp>
-        <p:nvSpPr>
-          <p:cNvPr id="20" name="Text 20"/>
-          <p:cNvSpPr txBox="1"/>
-          <p:nvPr/>
-        </p:nvSpPr>
-        <p:spPr>
-          <a:xfrm>
-            <a:off x="8357616" y="4411980"/>
-            <a:ext cx="2980944" cy="502920"/>
-          </a:xfrm>
-          <a:prstGeom prst="rect">
-            <a:avLst/>
-          </a:prstGeom>
-          <a:noFill/>
-          <a:ln/>
-        </p:spPr>
-        <p:txBody>
-          <a:bodyPr wrap="square" lIns="0" tIns="0" rIns="0" bIns="0" rtlCol="0" anchor="t"/>
-          <a:lstStyle/>
-          <a:p>
-            <a:pPr indent="0" marL="0">
-              <a:lnSpc>
-                <a:spcPts val="1800"/>
-              </a:lnSpc>
-              <a:buNone/>
-            </a:pPr>
-            <a:r>
-              <a:rPr lang="en-GB" sz="1400" b="1" dirty="0">
-                <a:solidFill>
-                  <a:srgbClr val="0F1522"/>
-                </a:solidFill>
-                <a:latin typeface="Arial" pitchFamily="34" charset="0"/>
-                <a:ea typeface="Arial" pitchFamily="34" charset="-122"/>
-                <a:cs typeface="Arial" pitchFamily="34" charset="-120"/>
-              </a:rPr>
-              <a:t>Does it use MI or my payslip?</a:t>
-            </a:r>
-            <a:endParaRPr lang="en-GB" sz="1400" dirty="0"/>
-          </a:p>
-        </p:txBody>
-      </p:sp>
-      <p:sp>
-        <p:nvSpPr>
-          <p:cNvPr id="21" name="Text 21"/>
-          <p:cNvSpPr txBox="1"/>
-          <p:nvPr/>
-        </p:nvSpPr>
-        <p:spPr>
-          <a:xfrm>
-            <a:off x="8357616" y="4960620"/>
-            <a:ext cx="2980944" cy="1257300"/>
-          </a:xfrm>
-          <a:prstGeom prst="rect">
-            <a:avLst/>
-          </a:prstGeom>
-          <a:noFill/>
-          <a:ln/>
-        </p:spPr>
-        <p:txBody>
-          <a:bodyPr wrap="square" lIns="0" tIns="0" rIns="0" bIns="0" rtlCol="0" anchor="t"/>
-          <a:lstStyle/>
-          <a:p>
-            <a:pPr indent="0" marL="0">
-              <a:lnSpc>
-                <a:spcPts val="1650"/>
-              </a:lnSpc>
-              <a:buNone/>
-            </a:pPr>
-            <a:r>
-              <a:rPr lang="en-GB" sz="1200" dirty="0">
-                <a:solidFill>
-                  <a:srgbClr val="4B5565"/>
-                </a:solidFill>
-                <a:latin typeface="Calibri" pitchFamily="34" charset="0"/>
-                <a:ea typeface="Calibri" pitchFamily="34" charset="-122"/>
-                <a:cs typeface="Calibri" pitchFamily="34" charset="-120"/>
-              </a:rPr>
-              <a:t>No. MI arrives 10–14 days after the week and is never imported. Everything comes from what you log, so treat the figures as personal estimates and check them against your payslip.</a:t>
-            </a:r>
-            <a:endParaRPr lang="en-GB" sz="1200" dirty="0"/>
-          </a:p>
-        </p:txBody>
-      </p:sp>
-    </p:spTree>
-  </p:cSld>
-  <p:clrMapOvr>
-    <a:masterClrMapping/>
-  </p:clrMapOvr>
-</p:sld>
-</file>
-
-<file path=ppt/slides/slide13.xml><?xml version="1.0" encoding="utf-8"?>
-<p:sld xmlns:a="http://schemas.openxmlformats.org/drawingml/2006/main" xmlns:r="http://schemas.openxmlformats.org/officeDocument/2006/relationships" xmlns:p="http://schemas.openxmlformats.org/presentationml/2006/main">
-  <p:cSld name="Slide 12">
-    <p:bg>
-      <p:bgPr>
-        <a:solidFill>
-          <a:srgbClr val="FFFFFF"/>
-        </a:solidFill>
-        <a:effectLst/>
-      </p:bgPr>
-    </p:bg>
-    <p:spTree>
-      <p:nvGrpSpPr>
-        <p:cNvPr id="1" name=""/>
-        <p:cNvGrpSpPr/>
-        <p:nvPr/>
-      </p:nvGrpSpPr>
-      <p:grpSpPr>
-        <a:xfrm>
-          <a:off x="0" y="0"/>
-          <a:ext cx="0" cy="0"/>
-          <a:chOff x="0" y="0"/>
-          <a:chExt cx="0" cy="0"/>
-        </a:xfrm>
-      </p:grpSpPr>
-      <p:sp>
-        <p:nvSpPr>
-          <p:cNvPr id="2" name="Text 2"/>
-          <p:cNvSpPr txBox="1"/>
-          <p:nvPr/>
-        </p:nvSpPr>
-        <p:spPr>
-          <a:xfrm>
-            <a:off x="566928" y="566928"/>
-            <a:ext cx="10058400" cy="237744"/>
-          </a:xfrm>
-          <a:prstGeom prst="rect">
-            <a:avLst/>
-          </a:prstGeom>
-          <a:noFill/>
-          <a:ln/>
-        </p:spPr>
-        <p:txBody>
-          <a:bodyPr wrap="square" lIns="0" tIns="0" rIns="0" bIns="0" rtlCol="0" anchor="ctr"/>
-          <a:lstStyle/>
-          <a:p>
-            <a:pPr indent="0" marL="0">
-              <a:buNone/>
-            </a:pPr>
-            <a:r>
-              <a:rPr lang="en-GB" sz="1100" b="1" spc="240" kern="0" dirty="0">
-                <a:solidFill>
-                  <a:srgbClr val="2F6BC4"/>
-                </a:solidFill>
-                <a:latin typeface="Arial" pitchFamily="34" charset="0"/>
-                <a:ea typeface="Arial" pitchFamily="34" charset="-122"/>
-                <a:cs typeface="Arial" pitchFamily="34" charset="-120"/>
-              </a:rPr>
-              <a:t>QUESTIONS PEOPLE ASK</a:t>
-            </a:r>
-            <a:endParaRPr lang="en-GB" sz="1100" dirty="0"/>
-          </a:p>
-        </p:txBody>
-      </p:sp>
-      <p:sp>
-        <p:nvSpPr>
-          <p:cNvPr id="3" name="Text 3"/>
-          <p:cNvSpPr txBox="1"/>
-          <p:nvPr/>
-        </p:nvSpPr>
-        <p:spPr>
-          <a:xfrm>
-            <a:off x="566928" y="877824"/>
-            <a:ext cx="10058400" cy="640080"/>
-          </a:xfrm>
-          <a:prstGeom prst="rect">
-            <a:avLst/>
-          </a:prstGeom>
-          <a:noFill/>
-          <a:ln/>
-        </p:spPr>
-        <p:txBody>
-          <a:bodyPr wrap="square" lIns="0" tIns="0" rIns="0" bIns="0" rtlCol="0" anchor="ctr"/>
-          <a:lstStyle/>
-          <a:p>
-            <a:pPr indent="0" marL="0">
-              <a:buNone/>
-            </a:pPr>
-            <a:r>
-              <a:rPr lang="en-GB" sz="3200" b="1" dirty="0">
-                <a:solidFill>
-                  <a:srgbClr val="0F1522"/>
-                </a:solidFill>
-                <a:latin typeface="Arial" pitchFamily="34" charset="0"/>
-                <a:ea typeface="Arial" pitchFamily="34" charset="-122"/>
-                <a:cs typeface="Arial" pitchFamily="34" charset="-120"/>
-              </a:rPr>
-              <a:t>How the balance works.</a:t>
-            </a:r>
-            <a:endParaRPr lang="en-GB" sz="3200" dirty="0"/>
-          </a:p>
-        </p:txBody>
-      </p:sp>
-      <p:sp>
-        <p:nvSpPr>
-          <p:cNvPr id="4" name="Card 4"/>
-          <p:cNvSpPr/>
-          <p:nvPr/>
-        </p:nvSpPr>
-        <p:spPr>
-          <a:xfrm>
-            <a:off x="566928" y="1737360"/>
-            <a:ext cx="3493008" cy="2217420"/>
-          </a:xfrm>
-          <a:prstGeom prst="roundRect">
-            <a:avLst>
-              <a:gd name="adj" fmla="val 4800"/>
-            </a:avLst>
-          </a:prstGeom>
-          <a:solidFill>
-            <a:srgbClr val="F2F2F7"/>
-          </a:solidFill>
-          <a:ln w="12700">
-            <a:solidFill>
-              <a:srgbClr val="DDE3EC"/>
-            </a:solidFill>
-            <a:prstDash val="solid"/>
-          </a:ln>
-        </p:spPr>
-      </p:sp>
-      <p:sp>
-        <p:nvSpPr>
-          <p:cNvPr id="5" name="Text 5"/>
-          <p:cNvSpPr txBox="1"/>
-          <p:nvPr/>
-        </p:nvSpPr>
-        <p:spPr>
-          <a:xfrm>
-            <a:off x="822960" y="1965960"/>
-            <a:ext cx="2980944" cy="502920"/>
-          </a:xfrm>
-          <a:prstGeom prst="rect">
-            <a:avLst/>
-          </a:prstGeom>
-          <a:noFill/>
-          <a:ln/>
-        </p:spPr>
-        <p:txBody>
-          <a:bodyPr wrap="square" lIns="0" tIns="0" rIns="0" bIns="0" rtlCol="0" anchor="t"/>
-          <a:lstStyle/>
-          <a:p>
-            <a:pPr indent="0" marL="0">
-              <a:lnSpc>
-                <a:spcPts val="1800"/>
-              </a:lnSpc>
-              <a:buNone/>
-            </a:pPr>
-            <a:r>
-              <a:rPr lang="en-GB" sz="1400" b="1" dirty="0">
-                <a:solidFill>
-                  <a:srgbClr val="0F1522"/>
-                </a:solidFill>
-                <a:latin typeface="Arial" pitchFamily="34" charset="0"/>
-                <a:ea typeface="Arial" pitchFamily="34" charset="-122"/>
-                <a:cs typeface="Arial" pitchFamily="34" charset="-120"/>
-              </a:rPr>
-              <a:t>How does it work out a deficit?</a:t>
-            </a:r>
-            <a:endParaRPr lang="en-GB" sz="1400" dirty="0"/>
-          </a:p>
-        </p:txBody>
-      </p:sp>
-      <p:sp>
-        <p:nvSpPr>
-          <p:cNvPr id="6" name="Text 6"/>
-          <p:cNvSpPr txBox="1"/>
-          <p:nvPr/>
-        </p:nvSpPr>
-        <p:spPr>
-          <a:xfrm>
-            <a:off x="822960" y="2514600"/>
-            <a:ext cx="2980944" cy="1257300"/>
-          </a:xfrm>
-          <a:prstGeom prst="rect">
-            <a:avLst/>
-          </a:prstGeom>
-          <a:noFill/>
-          <a:ln/>
-        </p:spPr>
-        <p:txBody>
-          <a:bodyPr wrap="square" lIns="0" tIns="0" rIns="0" bIns="0" rtlCol="0" anchor="t"/>
-          <a:lstStyle/>
-          <a:p>
-            <a:pPr indent="0" marL="0">
-              <a:lnSpc>
-                <a:spcPts val="1650"/>
-              </a:lnSpc>
-              <a:buNone/>
-            </a:pPr>
-            <a:r>
-              <a:rPr lang="en-GB" sz="1200" dirty="0">
-                <a:solidFill>
-                  <a:srgbClr val="4B5565"/>
-                </a:solidFill>
-                <a:latin typeface="Calibri" pitchFamily="34" charset="0"/>
-                <a:ea typeface="Calibri" pitchFamily="34" charset="-122"/>
-                <a:cs typeface="Calibri" pitchFamily="34" charset="-120"/>
-              </a:rPr>
-              <a:t>Your starting balance, plus each finished week's credits minus that week's target (rostered hours × 80%, less NPT). Below zero is a deficit. This week counts once it ends.</a:t>
-            </a:r>
-            <a:endParaRPr lang="en-GB" sz="1200" dirty="0"/>
-          </a:p>
-        </p:txBody>
-      </p:sp>
-      <p:sp>
-        <p:nvSpPr>
-          <p:cNvPr id="7" name="Card 7"/>
-          <p:cNvSpPr/>
-          <p:nvPr/>
-        </p:nvSpPr>
-        <p:spPr>
-          <a:xfrm>
-            <a:off x="4334256" y="1737360"/>
-            <a:ext cx="3493008" cy="2217420"/>
-          </a:xfrm>
-          <a:prstGeom prst="roundRect">
-            <a:avLst>
-              <a:gd name="adj" fmla="val 4800"/>
-            </a:avLst>
-          </a:prstGeom>
-          <a:solidFill>
-            <a:srgbClr val="F2F2F7"/>
-          </a:solidFill>
-          <a:ln w="12700">
-            <a:solidFill>
-              <a:srgbClr val="DDE3EC"/>
-            </a:solidFill>
-            <a:prstDash val="solid"/>
-          </a:ln>
-        </p:spPr>
-      </p:sp>
-      <p:sp>
-        <p:nvSpPr>
-          <p:cNvPr id="8" name="Text 8"/>
-          <p:cNvSpPr txBox="1"/>
-          <p:nvPr/>
-        </p:nvSpPr>
-        <p:spPr>
-          <a:xfrm>
-            <a:off x="4590288" y="1965960"/>
-            <a:ext cx="2980944" cy="502920"/>
-          </a:xfrm>
-          <a:prstGeom prst="rect">
-            <a:avLst/>
-          </a:prstGeom>
-          <a:noFill/>
-          <a:ln/>
-        </p:spPr>
-        <p:txBody>
-          <a:bodyPr wrap="square" lIns="0" tIns="0" rIns="0" bIns="0" rtlCol="0" anchor="t"/>
-          <a:lstStyle/>
-          <a:p>
-            <a:pPr indent="0" marL="0">
-              <a:lnSpc>
-                <a:spcPts val="1800"/>
-              </a:lnSpc>
-              <a:buNone/>
-            </a:pPr>
-            <a:r>
-              <a:rPr lang="en-GB" sz="1400" b="1" dirty="0">
-                <a:solidFill>
-                  <a:srgbClr val="0F1522"/>
-                </a:solidFill>
-                <a:latin typeface="Arial" pitchFamily="34" charset="0"/>
-                <a:ea typeface="Arial" pitchFamily="34" charset="-122"/>
-                <a:cs typeface="Arial" pitchFamily="34" charset="-120"/>
-              </a:rPr>
-              <a:t>How does Coach help clear a deficit?</a:t>
-            </a:r>
-            <a:endParaRPr lang="en-GB" sz="1400" dirty="0"/>
-          </a:p>
-        </p:txBody>
-      </p:sp>
-      <p:sp>
-        <p:nvSpPr>
-          <p:cNvPr id="9" name="Text 9"/>
-          <p:cNvSpPr txBox="1"/>
-          <p:nvPr/>
-        </p:nvSpPr>
-        <p:spPr>
-          <a:xfrm>
-            <a:off x="4590288" y="2514600"/>
-            <a:ext cx="2980944" cy="1257300"/>
-          </a:xfrm>
-          <a:prstGeom prst="rect">
-            <a:avLst/>
-          </a:prstGeom>
-          <a:noFill/>
-          <a:ln/>
-        </p:spPr>
-        <p:txBody>
-          <a:bodyPr wrap="square" lIns="0" tIns="0" rIns="0" bIns="0" rtlCol="0" anchor="t"/>
-          <a:lstStyle/>
-          <a:p>
-            <a:pPr indent="0" marL="0">
-              <a:lnSpc>
-                <a:spcPts val="1650"/>
-              </a:lnSpc>
-              <a:buNone/>
-            </a:pPr>
-            <a:r>
-              <a:rPr lang="en-GB" sz="1200" dirty="0">
-                <a:solidFill>
-                  <a:srgbClr val="4B5565"/>
-                </a:solidFill>
-                <a:latin typeface="Calibri" pitchFamily="34" charset="0"/>
-                <a:ea typeface="Calibri" pitchFamily="34" charset="-122"/>
-                <a:cs typeface="Calibri" pitchFamily="34" charset="-120"/>
-              </a:rPr>
-              <a:t>It spreads the deficit over the next 20 working days, so 8.40h becomes +0.42h a day on top of target, and says whether last week shrank the deficit or added to it.</a:t>
-            </a:r>
-            <a:endParaRPr lang="en-GB" sz="1200" dirty="0"/>
-          </a:p>
-        </p:txBody>
-      </p:sp>
-      <p:sp>
-        <p:nvSpPr>
-          <p:cNvPr id="10" name="Card 10"/>
-          <p:cNvSpPr/>
-          <p:nvPr/>
-        </p:nvSpPr>
-        <p:spPr>
-          <a:xfrm>
-            <a:off x="8101584" y="1737360"/>
-            <a:ext cx="3493008" cy="2217420"/>
-          </a:xfrm>
-          <a:prstGeom prst="roundRect">
-            <a:avLst>
-              <a:gd name="adj" fmla="val 4800"/>
-            </a:avLst>
-          </a:prstGeom>
-          <a:solidFill>
-            <a:srgbClr val="F2F2F7"/>
-          </a:solidFill>
-          <a:ln w="12700">
-            <a:solidFill>
-              <a:srgbClr val="DDE3EC"/>
-            </a:solidFill>
-            <a:prstDash val="solid"/>
-          </a:ln>
-        </p:spPr>
-      </p:sp>
-      <p:sp>
-        <p:nvSpPr>
-          <p:cNvPr id="11" name="Text 11"/>
-          <p:cNvSpPr txBox="1"/>
-          <p:nvPr/>
-        </p:nvSpPr>
-        <p:spPr>
-          <a:xfrm>
-            <a:off x="8357616" y="1965960"/>
-            <a:ext cx="2980944" cy="502920"/>
-          </a:xfrm>
-          <a:prstGeom prst="rect">
-            <a:avLst/>
-          </a:prstGeom>
-          <a:noFill/>
-          <a:ln/>
-        </p:spPr>
-        <p:txBody>
-          <a:bodyPr wrap="square" lIns="0" tIns="0" rIns="0" bIns="0" rtlCol="0" anchor="t"/>
-          <a:lstStyle/>
-          <a:p>
-            <a:pPr indent="0" marL="0">
-              <a:lnSpc>
-                <a:spcPts val="1800"/>
-              </a:lnSpc>
-              <a:buNone/>
-            </a:pPr>
-            <a:r>
-              <a:rPr lang="en-GB" sz="1400" b="1" dirty="0">
-                <a:solidFill>
-                  <a:srgbClr val="0F1522"/>
-                </a:solidFill>
-                <a:latin typeface="Arial" pitchFamily="34" charset="0"/>
-                <a:ea typeface="Arial" pitchFamily="34" charset="-122"/>
-                <a:cs typeface="Arial" pitchFamily="34" charset="-120"/>
-              </a:rPr>
-              <a:t>What about leave, rest days and mentoring?</a:t>
-            </a:r>
-            <a:endParaRPr lang="en-GB" sz="1400" dirty="0"/>
-          </a:p>
-        </p:txBody>
-      </p:sp>
-      <p:sp>
-        <p:nvSpPr>
-          <p:cNvPr id="12" name="Text 12"/>
-          <p:cNvSpPr txBox="1"/>
-          <p:nvPr/>
-        </p:nvSpPr>
-        <p:spPr>
-          <a:xfrm>
-            <a:off x="8357616" y="2514600"/>
-            <a:ext cx="2980944" cy="1257300"/>
-          </a:xfrm>
-          <a:prstGeom prst="rect">
-            <a:avLst/>
-          </a:prstGeom>
-          <a:noFill/>
-          <a:ln/>
-        </p:spPr>
-        <p:txBody>
-          <a:bodyPr wrap="square" lIns="0" tIns="0" rIns="0" bIns="0" rtlCol="0" anchor="t"/>
-          <a:lstStyle/>
-          <a:p>
-            <a:pPr indent="0" marL="0">
-              <a:lnSpc>
-                <a:spcPts val="1650"/>
-              </a:lnSpc>
-              <a:buNone/>
-            </a:pPr>
-            <a:r>
-              <a:rPr lang="en-GB" sz="1200" dirty="0">
-                <a:solidFill>
-                  <a:srgbClr val="4B5565"/>
-                </a:solidFill>
-                <a:latin typeface="Calibri" pitchFamily="34" charset="0"/>
-                <a:ea typeface="Calibri" pitchFamily="34" charset="-122"/>
-                <a:cs typeface="Calibri" pitchFamily="34" charset="-120"/>
-              </a:rPr>
-              <a:t>Leave takes that day's hours off the week; a rest day (no shift times) doesn't. A full mentor day has no target, and a partial one takes 20% off, as the scheme sets.</a:t>
-            </a:r>
-            <a:endParaRPr lang="en-GB" sz="1200" dirty="0"/>
-          </a:p>
-        </p:txBody>
-      </p:sp>
-      <p:sp>
-        <p:nvSpPr>
-          <p:cNvPr id="13" name="Card 13"/>
-          <p:cNvSpPr/>
-          <p:nvPr/>
-        </p:nvSpPr>
-        <p:spPr>
-          <a:xfrm>
-            <a:off x="566928" y="4183380"/>
-            <a:ext cx="3493008" cy="2217420"/>
-          </a:xfrm>
-          <a:prstGeom prst="roundRect">
-            <a:avLst>
-              <a:gd name="adj" fmla="val 4800"/>
-            </a:avLst>
-          </a:prstGeom>
-          <a:solidFill>
-            <a:srgbClr val="F2F2F7"/>
-          </a:solidFill>
-          <a:ln w="12700">
-            <a:solidFill>
-              <a:srgbClr val="DDE3EC"/>
-            </a:solidFill>
-            <a:prstDash val="solid"/>
-          </a:ln>
-        </p:spPr>
-      </p:sp>
-      <p:sp>
-        <p:nvSpPr>
-          <p:cNvPr id="14" name="Text 14"/>
-          <p:cNvSpPr txBox="1"/>
-          <p:nvPr/>
-        </p:nvSpPr>
-        <p:spPr>
-          <a:xfrm>
-            <a:off x="822960" y="4411980"/>
-            <a:ext cx="2980944" cy="502920"/>
-          </a:xfrm>
-          <a:prstGeom prst="rect">
-            <a:avLst/>
-          </a:prstGeom>
-          <a:noFill/>
-          <a:ln/>
-        </p:spPr>
-        <p:txBody>
-          <a:bodyPr wrap="square" lIns="0" tIns="0" rIns="0" bIns="0" rtlCol="0" anchor="t"/>
-          <a:lstStyle/>
-          <a:p>
-            <a:pPr indent="0" marL="0">
-              <a:lnSpc>
-                <a:spcPts val="1800"/>
-              </a:lnSpc>
-              <a:buNone/>
-            </a:pPr>
-            <a:r>
-              <a:rPr lang="en-GB" sz="1400" b="1" dirty="0">
-                <a:solidFill>
-                  <a:srgbClr val="0F1522"/>
-                </a:solidFill>
-                <a:latin typeface="Arial" pitchFamily="34" charset="0"/>
-                <a:ea typeface="Arial" pitchFamily="34" charset="-122"/>
-                <a:cs typeface="Arial" pitchFamily="34" charset="-120"/>
-              </a:rPr>
-              <a:t>What if a week wasn't a fair test?</a:t>
-            </a:r>
-            <a:endParaRPr lang="en-GB" sz="1400" dirty="0"/>
-          </a:p>
-        </p:txBody>
-      </p:sp>
-      <p:sp>
-        <p:nvSpPr>
-          <p:cNvPr id="15" name="Text 15"/>
-          <p:cNvSpPr txBox="1"/>
-          <p:nvPr/>
-        </p:nvSpPr>
-        <p:spPr>
-          <a:xfrm>
-            <a:off x="822960" y="4960620"/>
-            <a:ext cx="2980944" cy="1257300"/>
-          </a:xfrm>
-          <a:prstGeom prst="rect">
-            <a:avLst/>
-          </a:prstGeom>
-          <a:noFill/>
-          <a:ln/>
-        </p:spPr>
-        <p:txBody>
-          <a:bodyPr wrap="square" lIns="0" tIns="0" rIns="0" bIns="0" rtlCol="0" anchor="t"/>
-          <a:lstStyle/>
-          <a:p>
-            <a:pPr indent="0" marL="0">
-              <a:lnSpc>
-                <a:spcPts val="1650"/>
-              </a:lnSpc>
-              <a:buNone/>
-            </a:pPr>
-            <a:r>
-              <a:rPr lang="en-GB" sz="1200" dirty="0">
-                <a:solidFill>
-                  <a:srgbClr val="4B5565"/>
-                </a:solidFill>
-                <a:latin typeface="Calibri" pitchFamily="34" charset="0"/>
-                <a:ea typeface="Calibri" pitchFamily="34" charset="-122"/>
-                <a:cs typeface="Calibri" pitchFamily="34" charset="-120"/>
-              </a:rPr>
-              <a:t>Untick "In CTAP" for that week in History, for full sickness or a phased return, say. The week stays visible but leaves the balance alone.</a:t>
-            </a:r>
-            <a:endParaRPr lang="en-GB" sz="1200" dirty="0"/>
-          </a:p>
-        </p:txBody>
-      </p:sp>
-      <p:sp>
-        <p:nvSpPr>
-          <p:cNvPr id="16" name="Card 16"/>
-          <p:cNvSpPr/>
-          <p:nvPr/>
-        </p:nvSpPr>
-        <p:spPr>
-          <a:xfrm>
-            <a:off x="4334256" y="4183380"/>
-            <a:ext cx="3493008" cy="2217420"/>
-          </a:xfrm>
-          <a:prstGeom prst="roundRect">
-            <a:avLst>
-              <a:gd name="adj" fmla="val 4800"/>
-            </a:avLst>
-          </a:prstGeom>
-          <a:solidFill>
-            <a:srgbClr val="F2F2F7"/>
-          </a:solidFill>
-          <a:ln w="12700">
-            <a:solidFill>
-              <a:srgbClr val="DDE3EC"/>
-            </a:solidFill>
-            <a:prstDash val="solid"/>
-          </a:ln>
-        </p:spPr>
-      </p:sp>
-      <p:sp>
-        <p:nvSpPr>
-          <p:cNvPr id="17" name="Text 17"/>
-          <p:cNvSpPr txBox="1"/>
-          <p:nvPr/>
-        </p:nvSpPr>
-        <p:spPr>
-          <a:xfrm>
-            <a:off x="4590288" y="4411980"/>
-            <a:ext cx="2980944" cy="502920"/>
-          </a:xfrm>
-          <a:prstGeom prst="rect">
-            <a:avLst/>
-          </a:prstGeom>
-          <a:noFill/>
-          <a:ln/>
-        </p:spPr>
-        <p:txBody>
-          <a:bodyPr wrap="square" lIns="0" tIns="0" rIns="0" bIns="0" rtlCol="0" anchor="t"/>
-          <a:lstStyle/>
-          <a:p>
-            <a:pPr indent="0" marL="0">
-              <a:lnSpc>
-                <a:spcPts val="1800"/>
-              </a:lnSpc>
-              <a:buNone/>
-            </a:pPr>
-            <a:r>
-              <a:rPr lang="en-GB" sz="1400" b="1" dirty="0">
-                <a:solidFill>
-                  <a:srgbClr val="0F1522"/>
-                </a:solidFill>
-                <a:latin typeface="Arial" pitchFamily="34" charset="0"/>
-                <a:ea typeface="Arial" pitchFamily="34" charset="-122"/>
-                <a:cs typeface="Arial" pitchFamily="34" charset="-120"/>
-              </a:rPr>
-              <a:t>What counts as NPT?</a:t>
-            </a:r>
-            <a:endParaRPr lang="en-GB" sz="1400" dirty="0"/>
-          </a:p>
-        </p:txBody>
-      </p:sp>
-      <p:sp>
-        <p:nvSpPr>
-          <p:cNvPr id="18" name="Text 18"/>
-          <p:cNvSpPr txBox="1"/>
-          <p:nvPr/>
-        </p:nvSpPr>
-        <p:spPr>
-          <a:xfrm>
-            <a:off x="4590288" y="4960620"/>
-            <a:ext cx="2980944" cy="1257300"/>
-          </a:xfrm>
-          <a:prstGeom prst="rect">
-            <a:avLst/>
-          </a:prstGeom>
-          <a:noFill/>
-          <a:ln/>
-        </p:spPr>
-        <p:txBody>
-          <a:bodyPr wrap="square" lIns="0" tIns="0" rIns="0" bIns="0" rtlCol="0" anchor="t"/>
-          <a:lstStyle/>
-          <a:p>
-            <a:pPr indent="0" marL="0">
-              <a:lnSpc>
-                <a:spcPts val="1650"/>
-              </a:lnSpc>
-              <a:buNone/>
-            </a:pPr>
-            <a:r>
-              <a:rPr lang="en-GB" sz="1200" dirty="0">
-                <a:solidFill>
-                  <a:srgbClr val="4B5565"/>
-                </a:solidFill>
-                <a:latin typeface="Calibri" pitchFamily="34" charset="0"/>
-                <a:ea typeface="Calibri" pitchFamily="34" charset="-122"/>
-                <a:cs typeface="Calibri" pitchFamily="34" charset="-120"/>
-              </a:rPr>
-              <a:t>Time on the clock the scheme doesn't pay for, like an early finish. It comes off that week's target after the 80%. Wait time, EV charging and Bybox collections earn credits instead.</a:t>
-            </a:r>
-            <a:endParaRPr lang="en-GB" sz="1200" dirty="0"/>
-          </a:p>
-        </p:txBody>
-      </p:sp>
-      <p:sp>
-        <p:nvSpPr>
-          <p:cNvPr id="19" name="Card 19"/>
-          <p:cNvSpPr/>
-          <p:nvPr/>
-        </p:nvSpPr>
-        <p:spPr>
-          <a:xfrm>
-            <a:off x="8101584" y="4183380"/>
-            <a:ext cx="3493008" cy="2217420"/>
-          </a:xfrm>
-          <a:prstGeom prst="roundRect">
-            <a:avLst>
-              <a:gd name="adj" fmla="val 4800"/>
-            </a:avLst>
-          </a:prstGeom>
-          <a:solidFill>
-            <a:srgbClr val="F2F2F7"/>
-          </a:solidFill>
-          <a:ln w="12700">
-            <a:solidFill>
-              <a:srgbClr val="DDE3EC"/>
-            </a:solidFill>
-            <a:prstDash val="solid"/>
-          </a:ln>
-        </p:spPr>
-      </p:sp>
-      <p:sp>
-        <p:nvSpPr>
-          <p:cNvPr id="20" name="Text 20"/>
-          <p:cNvSpPr txBox="1"/>
-          <p:nvPr/>
-        </p:nvSpPr>
-        <p:spPr>
-          <a:xfrm>
-            <a:off x="8357616" y="4411980"/>
-            <a:ext cx="2980944" cy="502920"/>
-          </a:xfrm>
-          <a:prstGeom prst="rect">
-            <a:avLst/>
-          </a:prstGeom>
-          <a:noFill/>
-          <a:ln/>
-        </p:spPr>
-        <p:txBody>
-          <a:bodyPr wrap="square" lIns="0" tIns="0" rIns="0" bIns="0" rtlCol="0" anchor="t"/>
-          <a:lstStyle/>
-          <a:p>
-            <a:pPr indent="0" marL="0">
-              <a:lnSpc>
-                <a:spcPts val="1800"/>
-              </a:lnSpc>
-              <a:buNone/>
-            </a:pPr>
-            <a:r>
-              <a:rPr lang="en-GB" sz="1400" b="1" dirty="0">
-                <a:solidFill>
-                  <a:srgbClr val="0F1522"/>
-                </a:solidFill>
-                <a:latin typeface="Arial" pitchFamily="34" charset="0"/>
-                <a:ea typeface="Arial" pitchFamily="34" charset="-122"/>
-                <a:cs typeface="Arial" pitchFamily="34" charset="-120"/>
-              </a:rPr>
-              <a:t>Can my manager see my figures?</a:t>
-            </a:r>
-            <a:endParaRPr lang="en-GB" sz="1400" dirty="0"/>
-          </a:p>
-        </p:txBody>
-      </p:sp>
-      <p:sp>
-        <p:nvSpPr>
-          <p:cNvPr id="21" name="Text 21"/>
-          <p:cNvSpPr txBox="1"/>
-          <p:nvPr/>
-        </p:nvSpPr>
-        <p:spPr>
-          <a:xfrm>
-            <a:off x="8357616" y="4960620"/>
-            <a:ext cx="2980944" cy="1257300"/>
-          </a:xfrm>
-          <a:prstGeom prst="rect">
-            <a:avLst/>
-          </a:prstGeom>
-          <a:noFill/>
-          <a:ln/>
-        </p:spPr>
-        <p:txBody>
-          <a:bodyPr wrap="square" lIns="0" tIns="0" rIns="0" bIns="0" rtlCol="0" anchor="t"/>
-          <a:lstStyle/>
-          <a:p>
-            <a:pPr indent="0" marL="0">
-              <a:lnSpc>
-                <a:spcPts val="1650"/>
-              </a:lnSpc>
-              <a:buNone/>
-            </a:pPr>
-            <a:r>
-              <a:rPr lang="en-GB" sz="1200" dirty="0">
-                <a:solidFill>
-                  <a:srgbClr val="4B5565"/>
-                </a:solidFill>
-                <a:latin typeface="Calibri" pitchFamily="34" charset="0"/>
-                <a:ea typeface="Calibri" pitchFamily="34" charset="-122"/>
-                <a:cs typeface="Calibri" pitchFamily="34" charset="-120"/>
-              </a:rPr>
-              <a:t>No. There's no account and nothing is uploaded, so everything stays on the engineer's phone. The flip side is there's no backup if the phone is lost or the app is deleted.</a:t>
-            </a:r>
-            <a:endParaRPr lang="en-GB" sz="1200" dirty="0"/>
-          </a:p>
-        </p:txBody>
-      </p:sp>
-    </p:spTree>
-  </p:cSld>
-  <p:clrMapOvr>
-    <a:masterClrMapping/>
-  </p:clrMapOvr>
-</p:sld>
-</file>
-
 <file path=ppt/slides/slide2.xml><?xml version="1.0" encoding="utf-8"?>
 <p:sld xmlns:a="http://schemas.openxmlformats.org/drawingml/2006/main" xmlns:r="http://schemas.openxmlformats.org/officeDocument/2006/relationships" xmlns:p="http://schemas.openxmlformats.org/presentationml/2006/main">
   <p:cSld name="Slide 2">

</xml_diff>

<commit_message>
Ask for five to ten trial engineers on the deck, not a fixed ten
Co-Authored-By: Claude Fable 5.1 <noreply@anthropic.com>
</commit_message>
<xml_diff>
--- a/docs/presentation/CTAP-Tracker.pptx
+++ b/docs/presentation/CTAP-Tracker.pptx
@@ -512,7 +512,7 @@
           <a:p>
             <a:r>
               <a:rPr lang="en-US" dirty="0"/>
-              <a:t>CTAP Tracker — a personal tool for Service &amp; Repair engineers to track their CTAP bonus in real time. Built by an engineer, and looking for ten engineers to trial it. Everything you see is on-device; I will come back to that.</a:t>
+              <a:t>CTAP Tracker — a personal tool for Service &amp; Repair engineers to track their CTAP bonus in real time. Built by an engineer, and looking for a handful of engineers, five to ten, to trial it: anyone a manager thinks would get something out of it. Everything you see is on-device; I will come back to that.</a:t>
             </a:r>
             <a:endParaRPr lang="en-US" dirty="0"/>
           </a:p>
@@ -7427,7 +7427,7 @@
                 <a:ea typeface="Arial" pitchFamily="34" charset="-122"/>
                 <a:cs typeface="Arial" pitchFamily="34" charset="-120"/>
               </a:rPr>
-              <a:t>10</a:t>
+              <a:t>5–10</a:t>
             </a:r>
             <a:endParaRPr lang="en-US" sz="3800" dirty="0"/>
           </a:p>

</xml_diff>

<commit_message>
Rewrite the deck in Jake's voice: Coach and the check-in get their own case, the data slide is plain, Try it is gone
Jake's read-through: too corporate. Coach Mode is now sold on what it
does (run rate, what lifts the balance most on a visit, never dispatched
work) and the check-in on GROW and being an honest diary only the
engineer reads. "On the engineer's phone. That is the whole answer."
becomes "Everything stays on your phone." with the catch stated plainly.
The Still open list and the Try it slide are removed: nobody can install
it without the link, so the last slide now says who he's looking for and
carries the contact line and disclaimer. Ten slides.

Co-Authored-By: Claude Fable 5.1 <noreply@anthropic.com>
</commit_message>
<xml_diff>
--- a/docs/presentation/CTAP-Tracker.pptx
+++ b/docs/presentation/CTAP-Tracker.pptx
@@ -15,7 +15,6 @@
     <p:sldId id="262" r:id="rId8"/>
     <p:sldId id="263" r:id="rId9"/>
     <p:sldId id="264" r:id="rId10"/>
-    <p:sldId id="265" r:id="rId11"/>
   </p:sldIdLst>
   <p:notesMasterIdLst>
     <p:notesMasterId r:id="rId12"/>
@@ -554,94 +553,6 @@
 </p:notes>
 </file>
 
-<file path=ppt/notesSlides/notesSlide10.xml><?xml version="1.0" encoding="utf-8"?>
-<p:notes xmlns:a="http://schemas.openxmlformats.org/drawingml/2006/main" xmlns:r="http://schemas.openxmlformats.org/officeDocument/2006/relationships" xmlns:p="http://schemas.openxmlformats.org/presentationml/2006/main">
-  <p:cSld>
-    <p:spTree>
-      <p:nvGrpSpPr>
-        <p:cNvPr id="1" name=""/>
-        <p:cNvGrpSpPr/>
-        <p:nvPr/>
-      </p:nvGrpSpPr>
-      <p:grpSpPr>
-        <a:xfrm>
-          <a:off x="0" y="0"/>
-          <a:ext cx="0" cy="0"/>
-          <a:chOff x="0" y="0"/>
-          <a:chExt cx="0" cy="0"/>
-        </a:xfrm>
-      </p:grpSpPr>
-      <p:sp>
-        <p:nvSpPr>
-          <p:cNvPr id="2" name="Slide Image Placeholder 1"/>
-          <p:cNvSpPr>
-            <a:spLocks noGrp="1" noRot="1" noChangeAspect="1"/>
-          </p:cNvSpPr>
-          <p:nvPr>
-            <p:ph type="sldImg"/>
-          </p:nvPr>
-        </p:nvSpPr>
-        <p:spPr/>
-      </p:sp>
-      <p:sp>
-        <p:nvSpPr>
-          <p:cNvPr id="3" name="Notes Placeholder 2"/>
-          <p:cNvSpPr>
-            <a:spLocks noGrp="1"/>
-          </p:cNvSpPr>
-          <p:nvPr>
-            <p:ph type="body" idx="1"/>
-          </p:nvPr>
-        </p:nvSpPr>
-        <p:spPr/>
-        <p:txBody>
-          <a:bodyPr/>
-          <a:lstStyle/>
-          <a:p>
-            <a:r>
-              <a:rPr lang="en-US" dirty="0"/>
-              <a:t>Anyone can install it from that link in under a minute. Happy to walk a group through the first-run setup.</a:t>
-            </a:r>
-            <a:endParaRPr lang="en-US" dirty="0"/>
-          </a:p>
-        </p:txBody>
-      </p:sp>
-      <p:sp>
-        <p:nvSpPr>
-          <p:cNvPr id="4" name="Slide Number Placeholder 3"/>
-          <p:cNvSpPr>
-            <a:spLocks noGrp="1"/>
-          </p:cNvSpPr>
-          <p:nvPr>
-            <p:ph type="sldNum" sz="quarter" idx="10"/>
-          </p:nvPr>
-        </p:nvSpPr>
-        <p:spPr/>
-        <p:txBody>
-          <a:bodyPr/>
-          <a:lstStyle/>
-          <a:p>
-            <a:fld id="{F7021451-1387-4CA6-816F-3879F97B5CBC}" type="slidenum">
-              <a:rPr lang="en-US"/>
-              <a:t>10</a:t>
-            </a:fld>
-            <a:endParaRPr lang="en-US"/>
-          </a:p>
-        </p:txBody>
-      </p:sp>
-    </p:spTree>
-    <p:extLst>
-      <p:ext uri="{BB962C8B-B14F-4D97-AF65-F5344CB8AC3E}">
-        <p14:creationId xmlns:p14="http://schemas.microsoft.com/office/powerpoint/2010/main" val="1024086991"/>
-      </p:ext>
-    </p:extLst>
-  </p:cSld>
-  <p:clrMapOvr>
-    <a:masterClrMapping/>
-  </p:clrMapOvr>
-</p:notes>
-</file>
-
 <file path=ppt/notesSlides/notesSlide11.xml><?xml version="1.0" encoding="utf-8"?>
 <p:notes xmlns:a="http://schemas.openxmlformats.org/drawingml/2006/main" xmlns:r="http://schemas.openxmlformats.org/officeDocument/2006/relationships" xmlns:p="http://schemas.openxmlformats.org/presentationml/2006/main">
   <p:cSld>
@@ -1216,7 +1127,7 @@
           <a:p>
             <a:r>
               <a:rPr lang="en-US" dirty="0"/>
-              <a:t>Both optional, both off in one tap. I want to be explicit about the check-in because it is the one people will ask about: it is a private diary, there is no management view of it, and that is a property of the build rather than a promise.</a:t>
+              <a:t>Both optional, both off in one tap in Settings. Coach is the bit I would show a new engineer first: it turns the figures into a run rate and tells you what the extras on a visit are worth. The check-in is a private diary built on GROW. There is no management view of it, and that is a property of the build rather than a promise.</a:t>
             </a:r>
             <a:endParaRPr lang="en-US" dirty="0"/>
           </a:p>
@@ -1304,7 +1215,7 @@
           <a:p>
             <a:r>
               <a:rPr lang="en-US" dirty="0"/>
-              <a:t>This is the slide the room will want. The employer blocker was never about access control — it was about the data leaving the device, and the only answer to that is that nothing is transmitted. The cost is real and we state it up front: no backup, no recovery.</a:t>
+              <a:t>The data question, answered the simple way: nothing leaves the phone, so there is nothing to protect on a server and nobody to share it with. The catch is real and we say it up front: no backup, no recovery.</a:t>
             </a:r>
             <a:endParaRPr lang="en-US" dirty="0"/>
           </a:p>
@@ -1392,7 +1303,7 @@
           <a:p>
             <a:r>
               <a:rPr lang="en-US" dirty="0"/>
-              <a:t>Being straight about what is not done. The catalogue figures are the one that could affect an engineer directly, so that is the priority. Offline is tested but not yet watched on a handset.</a:t>
+              <a:t>What is shipped, and the ask: a handful of engineers, five to ten, who a manager thinks would get something out of it. Engineers a little behind on CTAP and new starters get the most from seeing the figures day to day. Nobody can install it without the link, so it goes out to whoever comes forward.</a:t>
             </a:r>
             <a:endParaRPr lang="en-US" dirty="0"/>
           </a:p>
@@ -1980,326 +1891,6 @@
 </p:sld>
 </file>
 
-<file path=ppt/slides/slide10.xml><?xml version="1.0" encoding="utf-8"?>
-<p:sld xmlns:a="http://schemas.openxmlformats.org/drawingml/2006/main" xmlns:r="http://schemas.openxmlformats.org/officeDocument/2006/relationships" xmlns:p="http://schemas.openxmlformats.org/presentationml/2006/main">
-  <p:cSld name="Slide 10">
-    <p:bg>
-      <p:bgPr>
-        <a:solidFill>
-          <a:srgbClr val="FFFFFF"/>
-        </a:solidFill>
-      </p:bgPr>
-    </p:bg>
-    <p:spTree>
-      <p:nvGrpSpPr>
-        <p:cNvPr id="1" name=""/>
-        <p:cNvGrpSpPr/>
-        <p:nvPr/>
-      </p:nvGrpSpPr>
-      <p:grpSpPr>
-        <a:xfrm>
-          <a:off x="0" y="0"/>
-          <a:ext cx="0" cy="0"/>
-          <a:chOff x="0" y="0"/>
-          <a:chExt cx="0" cy="0"/>
-        </a:xfrm>
-      </p:grpSpPr>
-      <p:sp>
-        <p:nvSpPr>
-          <p:cNvPr id="2" name="Text 0"/>
-          <p:cNvSpPr txBox="1"/>
-          <p:nvPr/>
-        </p:nvSpPr>
-        <p:spPr>
-          <a:xfrm>
-            <a:off x="566928" y="1965960"/>
-            <a:ext cx="7315200" cy="914400"/>
-          </a:xfrm>
-          <a:prstGeom prst="rect">
-            <a:avLst/>
-          </a:prstGeom>
-          <a:noFill/>
-          <a:ln/>
-        </p:spPr>
-        <p:txBody>
-          <a:bodyPr wrap="square" lIns="0" tIns="0" rIns="0" bIns="0" rtlCol="0" anchor="ctr"/>
-          <a:lstStyle/>
-          <a:p>
-            <a:pPr indent="0" marL="0">
-              <a:buNone/>
-            </a:pPr>
-            <a:r>
-              <a:rPr lang="en-US" sz="5400" b="1" dirty="0">
-                <a:solidFill>
-                  <a:srgbClr val="0F1522"/>
-                </a:solidFill>
-                <a:latin typeface="Arial" pitchFamily="34" charset="0"/>
-                <a:ea typeface="Arial" pitchFamily="34" charset="-122"/>
-                <a:cs typeface="Arial" pitchFamily="34" charset="-120"/>
-              </a:rPr>
-              <a:t>Try it</a:t>
-            </a:r>
-            <a:endParaRPr lang="en-US" sz="5400" dirty="0"/>
-          </a:p>
-        </p:txBody>
-      </p:sp>
-      <p:sp>
-        <p:nvSpPr>
-          <p:cNvPr id="3" name="Text 1"/>
-          <p:cNvSpPr txBox="1"/>
-          <p:nvPr/>
-        </p:nvSpPr>
-        <p:spPr>
-          <a:xfrm>
-            <a:off x="566928" y="2971800"/>
-            <a:ext cx="7315200" cy="502920"/>
-          </a:xfrm>
-          <a:prstGeom prst="rect">
-            <a:avLst/>
-          </a:prstGeom>
-          <a:noFill/>
-          <a:ln/>
-        </p:spPr>
-        <p:txBody>
-          <a:bodyPr wrap="square" lIns="0" tIns="0" rIns="0" bIns="0" rtlCol="0" anchor="ctr"/>
-          <a:lstStyle/>
-          <a:p>
-            <a:pPr indent="0" marL="0">
-              <a:buNone/>
-            </a:pPr>
-            <a:r>
-              <a:rPr lang="en-US" sz="2100" dirty="0">
-                <a:solidFill>
-                  <a:srgbClr val="2F6BC4"/>
-                </a:solidFill>
-                <a:latin typeface="Arial" pitchFamily="34" charset="0"/>
-                <a:ea typeface="Arial" pitchFamily="34" charset="-122"/>
-                <a:cs typeface="Arial" pitchFamily="34" charset="-120"/>
-              </a:rPr>
-              <a:t>belacorg.github.io/CTAPTracker</a:t>
-            </a:r>
-            <a:endParaRPr lang="en-US" sz="2100" dirty="0"/>
-          </a:p>
-        </p:txBody>
-      </p:sp>
-      <p:sp>
-        <p:nvSpPr>
-          <p:cNvPr id="4" name="Text 2"/>
-          <p:cNvSpPr txBox="1"/>
-          <p:nvPr/>
-        </p:nvSpPr>
-        <p:spPr>
-          <a:xfrm>
-            <a:off x="566928" y="3611880"/>
-            <a:ext cx="7315200" cy="365760"/>
-          </a:xfrm>
-          <a:prstGeom prst="rect">
-            <a:avLst/>
-          </a:prstGeom>
-          <a:noFill/>
-          <a:ln/>
-        </p:spPr>
-        <p:txBody>
-          <a:bodyPr wrap="square" lIns="0" tIns="0" rIns="0" bIns="0" rtlCol="0" anchor="ctr"/>
-          <a:lstStyle/>
-          <a:p>
-            <a:pPr indent="0" marL="0">
-              <a:buNone/>
-            </a:pPr>
-            <a:r>
-              <a:rPr lang="en-US" sz="1600" dirty="0">
-                <a:solidFill>
-                  <a:srgbClr val="4B5565"/>
-                </a:solidFill>
-                <a:latin typeface="Calibri" pitchFamily="34" charset="0"/>
-                <a:ea typeface="Calibri" pitchFamily="34" charset="-122"/>
-                <a:cs typeface="Calibri" pitchFamily="34" charset="-120"/>
-              </a:rPr>
-              <a:t>Open it in Safari  →  Share  →  Add to Home Screen</a:t>
-            </a:r>
-            <a:endParaRPr lang="en-US" sz="1600" dirty="0"/>
-          </a:p>
-        </p:txBody>
-      </p:sp>
-      <p:sp>
-        <p:nvSpPr>
-          <p:cNvPr id="5" name="Text 3"/>
-          <p:cNvSpPr txBox="1"/>
-          <p:nvPr/>
-        </p:nvSpPr>
-        <p:spPr>
-          <a:xfrm>
-            <a:off x="566928" y="4069080"/>
-            <a:ext cx="7315200" cy="365760"/>
-          </a:xfrm>
-          <a:prstGeom prst="rect">
-            <a:avLst/>
-          </a:prstGeom>
-          <a:noFill/>
-          <a:ln/>
-        </p:spPr>
-        <p:txBody>
-          <a:bodyPr wrap="square" lIns="0" tIns="0" rIns="0" bIns="0" rtlCol="0" anchor="ctr"/>
-          <a:lstStyle/>
-          <a:p>
-            <a:pPr indent="0" marL="0">
-              <a:buNone/>
-            </a:pPr>
-            <a:r>
-              <a:rPr lang="en-US" sz="1400" i="1" dirty="0">
-                <a:solidFill>
-                  <a:srgbClr val="6B7485"/>
-                </a:solidFill>
-                <a:latin typeface="Calibri" pitchFamily="34" charset="0"/>
-                <a:ea typeface="Calibri" pitchFamily="34" charset="-122"/>
-                <a:cs typeface="Calibri" pitchFamily="34" charset="-120"/>
-              </a:rPr>
-              <a:t>No account. No sign-in. No app store. Nothing leaves the phone.</a:t>
-            </a:r>
-            <a:endParaRPr lang="en-US" sz="1400" dirty="0"/>
-          </a:p>
-        </p:txBody>
-      </p:sp>
-      <p:sp>
-        <p:nvSpPr>
-          <p:cNvPr id="6" name="Text 4"/>
-          <p:cNvSpPr txBox="1"/>
-          <p:nvPr/>
-        </p:nvSpPr>
-        <p:spPr>
-          <a:xfrm>
-            <a:off x="566928" y="5029200"/>
-            <a:ext cx="7315200" cy="320040"/>
-          </a:xfrm>
-          <a:prstGeom prst="rect">
-            <a:avLst/>
-          </a:prstGeom>
-          <a:noFill/>
-          <a:ln/>
-        </p:spPr>
-        <p:txBody>
-          <a:bodyPr wrap="square" lIns="0" tIns="0" rIns="0" bIns="0" rtlCol="0" anchor="ctr"/>
-          <a:lstStyle/>
-          <a:p>
-            <a:pPr indent="0" marL="0">
-              <a:buNone/>
-            </a:pPr>
-            <a:r>
-              <a:rPr lang="en-US" sz="1300" dirty="0">
-                <a:solidFill>
-                  <a:srgbClr val="6B7485"/>
-                </a:solidFill>
-                <a:latin typeface="Calibri" pitchFamily="34" charset="0"/>
-                <a:ea typeface="Calibri" pitchFamily="34" charset="-122"/>
-                <a:cs typeface="Calibri" pitchFamily="34" charset="-120"/>
-              </a:rPr>
-              <a:t>Jake Rainford  ·  Service &amp; Repair Engineer  ·  questions on email or Teams</a:t>
-            </a:r>
-            <a:endParaRPr lang="en-US" sz="1300" dirty="0"/>
-          </a:p>
-        </p:txBody>
-      </p:sp>
-      <p:sp>
-        <p:nvSpPr>
-          <p:cNvPr id="7" name="Text 5"/>
-          <p:cNvSpPr txBox="1"/>
-          <p:nvPr/>
-        </p:nvSpPr>
-        <p:spPr>
-          <a:xfrm>
-            <a:off x="566928" y="5943600"/>
-            <a:ext cx="7498080" cy="640080"/>
-          </a:xfrm>
-          <a:prstGeom prst="rect">
-            <a:avLst/>
-          </a:prstGeom>
-          <a:noFill/>
-          <a:ln/>
-        </p:spPr>
-        <p:txBody>
-          <a:bodyPr wrap="square" lIns="0" tIns="0" rIns="0" bIns="0" rtlCol="0" anchor="ctr"/>
-          <a:lstStyle/>
-          <a:p>
-            <a:pPr indent="0" marL="0">
-              <a:lnSpc>
-                <a:spcPts val="1400"/>
-              </a:lnSpc>
-              <a:buNone/>
-            </a:pPr>
-            <a:r>
-              <a:rPr lang="en-US" sz="1050" dirty="0">
-                <a:solidFill>
-                  <a:srgbClr val="6B7485"/>
-                </a:solidFill>
-                <a:latin typeface="Calibri" pitchFamily="34" charset="0"/>
-                <a:ea typeface="Calibri" pitchFamily="34" charset="-122"/>
-                <a:cs typeface="Calibri" pitchFamily="34" charset="-120"/>
-              </a:rPr>
-              <a:t>Personal estimates only — verify against your payslip and company tools. Not affiliated with, endorsed by, or representative of Centrica plc, British Gas or any employer.</a:t>
-            </a:r>
-            <a:endParaRPr lang="en-US" sz="1050" dirty="0"/>
-          </a:p>
-        </p:txBody>
-      </p:sp>
-      <p:sp>
-        <p:nvSpPr>
-          <p:cNvPr id="8" name="Shape 6"/>
-          <p:cNvSpPr/>
-          <p:nvPr/>
-        </p:nvSpPr>
-        <p:spPr>
-          <a:xfrm>
-            <a:off x="8983980" y="754380"/>
-            <a:ext cx="2545586" cy="5349240"/>
-          </a:xfrm>
-          <a:prstGeom prst="roundRect">
-            <a:avLst>
-              <a:gd name="adj" fmla="val 7903"/>
-            </a:avLst>
-          </a:prstGeom>
-          <a:solidFill>
-            <a:srgbClr val="DDE3EC"/>
-          </a:solidFill>
-          <a:ln w="12700">
-            <a:solidFill>
-              <a:srgbClr val="DDE3EC"/>
-            </a:solidFill>
-            <a:prstDash val="solid"/>
-          </a:ln>
-        </p:spPr>
-      </p:sp>
-      <p:pic>
-        <p:nvPicPr>
-          <p:cNvPr id="9" name="Image 0" descr="shots/setup-card.png">    </p:cNvPr>
-          <p:cNvPicPr>
-            <a:picLocks noChangeAspect="1"/>
-          </p:cNvPicPr>
-          <p:nvPr/>
-        </p:nvPicPr>
-        <p:blipFill>
-          <a:blip r:embed="rId1"/>
-          <a:stretch>
-            <a:fillRect/>
-          </a:stretch>
-        </p:blipFill>
-        <p:spPr>
-          <a:xfrm>
-            <a:off x="9052560" y="822960"/>
-            <a:ext cx="2408426" cy="5212080"/>
-          </a:xfrm>
-          <a:prstGeom prst="rect">
-            <a:avLst/>
-          </a:prstGeom>
-        </p:spPr>
-      </p:pic>
-    </p:spTree>
-  </p:cSld>
-  <p:clrMapOvr>
-    <a:masterClrMapping/>
-  </p:clrMapOvr>
-</p:sld>
-</file>
-
 <file path=ppt/slides/slide11.xml><?xml version="1.0" encoding="utf-8"?>
 <p:sld xmlns:a="http://schemas.openxmlformats.org/drawingml/2006/main" xmlns:r="http://schemas.openxmlformats.org/officeDocument/2006/relationships" xmlns:p="http://schemas.openxmlformats.org/presentationml/2006/main">
   <p:cSld name="Slide 5">
@@ -2914,7 +2505,7 @@
               <a:buNone/>
             </a:pPr>
             <a:r>
-              <a:rPr lang="en-US" sz="3800" b="1" dirty="0">
+              <a:rPr lang="en-GB" sz="3800" b="1" dirty="0">
                 <a:solidFill>
                   <a:srgbClr val="0F1522"/>
                 </a:solidFill>
@@ -2924,7 +2515,7 @@
               </a:rPr>
               <a:t>You find out a week was short</a:t>
             </a:r>
-            <a:endParaRPr lang="en-US" sz="3800" dirty="0"/>
+            <a:endParaRPr lang="en-GB" sz="3800" dirty="0"/>
           </a:p>
           <a:p>
             <a:pPr indent="0" marL="0">
@@ -2934,7 +2525,7 @@
               <a:buNone/>
             </a:pPr>
             <a:r>
-              <a:rPr lang="en-US" sz="3800" b="1" dirty="0">
+              <a:rPr lang="en-GB" sz="3800" b="1" dirty="0">
                 <a:solidFill>
                   <a:srgbClr val="0F1522"/>
                 </a:solidFill>
@@ -2942,9 +2533,9 @@
                 <a:ea typeface="Arial" pitchFamily="34" charset="-122"/>
                 <a:cs typeface="Arial" pitchFamily="34" charset="-120"/>
               </a:rPr>
-              <a:t>when it is already gone.</a:t>
-            </a:r>
-            <a:endParaRPr lang="en-US" sz="3800" dirty="0"/>
+              <a:t>when it’s already gone.</a:t>
+            </a:r>
+            <a:endParaRPr lang="en-GB" sz="3800" dirty="0"/>
           </a:p>
         </p:txBody>
       </p:sp>
@@ -3128,7 +2719,7 @@
                 <a:ea typeface="Calibri" pitchFamily="34" charset="-122"/>
                 <a:cs typeface="Calibri" pitchFamily="34" charset="-120"/>
               </a:rPr>
-              <a:t>By the time the figures come back, the week they describe is long finished.</a:t>
+              <a:t>By the time the figures come back, the week they’re about is long gone.</a:t>
             </a:r>
             <a:endParaRPr lang="en-US" sz="1300" dirty="0"/>
           </a:p>
@@ -3314,7 +2905,7 @@
                 <a:ea typeface="Calibri" pitchFamily="34" charset="-122"/>
                 <a:cs typeface="Calibri" pitchFamily="34" charset="-120"/>
               </a:rPr>
-              <a:t>No way to see mid-week that you are behind while there is still week left to fix it.</a:t>
+              <a:t>Nothing tells you mid-week that you’re behind while there’s still time to do something about it.</a:t>
             </a:r>
             <a:endParaRPr lang="en-US" sz="1300" dirty="0"/>
           </a:p>
@@ -3500,7 +3091,7 @@
                 <a:ea typeface="Calibri" pitchFamily="34" charset="-122"/>
                 <a:cs typeface="Calibri" pitchFamily="34" charset="-120"/>
               </a:rPr>
-              <a:t>The bonus sits as a number of hours nobody converts into what actually reaches your bank.</a:t>
+              <a:t>The bonus is a number of hours. Nobody tells you what that is in your pocket.</a:t>
             </a:r>
             <a:endParaRPr lang="en-US" sz="1300" dirty="0"/>
           </a:p>
@@ -3871,7 +3462,7 @@
                 <a:ea typeface="Calibri" pitchFamily="34" charset="-122"/>
                 <a:cs typeface="Calibri" pitchFamily="34" charset="-120"/>
               </a:rPr>
-              <a:t>A whole week, caught up on a Friday. Each day is read separately and lands on the day you said it against.</a:t>
+              <a:t>A whole week, caught up on a Friday. Each day is read on its own and lands on the day you said.</a:t>
             </a:r>
             <a:endParaRPr lang="en-US" sz="1250" dirty="0"/>
           </a:p>
@@ -4286,7 +3877,7 @@
                 <a:ea typeface="Calibri" pitchFamily="34" charset="-122"/>
                 <a:cs typeface="Calibri" pitchFamily="34" charset="-120"/>
               </a:rPr>
-              <a:t>The hours you are already up or down. Without it every figure starts from zero — which is almost certainly not where you are.</a:t>
+              <a:t>The hours you’re already up or down. Without it every figure starts from zero, which is almost certainly not where you are.</a:t>
             </a:r>
             <a:endParaRPr lang="en-US" sz="1350" dirty="0"/>
           </a:p>
@@ -4431,7 +4022,7 @@
                 <a:ea typeface="Calibri" pitchFamily="34" charset="-122"/>
                 <a:cs typeface="Calibri" pitchFamily="34" charset="-120"/>
               </a:rPr>
-              <a:t>One tap if you are a normal Mon–Fri.</a:t>
+              <a:t>One tap if you’re a normal Mon–Fri.</a:t>
             </a:r>
             <a:endParaRPr lang="en-US" sz="1350" dirty="0"/>
           </a:p>
@@ -5422,7 +5013,7 @@
               <a:buNone/>
             </a:pPr>
             <a:r>
-              <a:rPr lang="en-US" sz="3000" b="1" dirty="0">
+              <a:rPr lang="en-GB" sz="3000" b="1" dirty="0">
                 <a:solidFill>
                   <a:srgbClr val="0F1522"/>
                 </a:solidFill>
@@ -5430,9 +5021,9 @@
                 <a:ea typeface="Arial" pitchFamily="34" charset="-122"/>
                 <a:cs typeface="Arial" pitchFamily="34" charset="-120"/>
               </a:rPr>
-              <a:t>Every week you have logged,</a:t>
-            </a:r>
-            <a:endParaRPr lang="en-US" sz="3000" dirty="0"/>
+              <a:t>Every week you’ve logged,</a:t>
+            </a:r>
+            <a:endParaRPr lang="en-GB" sz="3000" dirty="0"/>
           </a:p>
           <a:p>
             <a:pPr indent="0" marL="0">
@@ -5442,7 +5033,7 @@
               <a:buNone/>
             </a:pPr>
             <a:r>
-              <a:rPr lang="en-US" sz="3000" b="1" dirty="0">
+              <a:rPr lang="en-GB" sz="3000" b="1" dirty="0">
                 <a:solidFill>
                   <a:srgbClr val="0F1522"/>
                 </a:solidFill>
@@ -5452,7 +5043,7 @@
               </a:rPr>
               <a:t>and the balance that carries.</a:t>
             </a:r>
-            <a:endParaRPr lang="en-US" sz="3000" dirty="0"/>
+            <a:endParaRPr lang="en-GB" sz="3000" dirty="0"/>
           </a:p>
         </p:txBody>
       </p:sp>
@@ -5676,7 +5267,7 @@
               <a:buNone/>
             </a:pPr>
             <a:r>
-              <a:rPr lang="en-US" sz="1400" dirty="0">
+              <a:rPr lang="en-GB" sz="1400" dirty="0">
                 <a:solidFill>
                   <a:srgbClr val="4B5565"/>
                 </a:solidFill>
@@ -5684,9 +5275,9 @@
                 <a:ea typeface="Calibri" pitchFamily="34" charset="-122"/>
                 <a:cs typeface="Calibri" pitchFamily="34" charset="-120"/>
               </a:rPr>
-              <a:t>A week that was not a fair test — full sickness, a phased return, a week you were still working the app out — can be excluded from the running balance without deleting it.</a:t>
-            </a:r>
-            <a:endParaRPr lang="en-US" sz="1400" dirty="0"/>
+              <a:t>Had a week that wasn’t a fair test? Sickness, a phased return, a week you were still getting the hang of the app. Untick it and it stays out of your balance without being deleted.</a:t>
+            </a:r>
+            <a:endParaRPr lang="en-GB" sz="1400" dirty="0"/>
           </a:p>
         </p:txBody>
       </p:sp>
@@ -5718,7 +5309,7 @@
               <a:buNone/>
             </a:pPr>
             <a:r>
-              <a:rPr lang="en-US" sz="1400" b="1" dirty="0">
+              <a:rPr lang="en-GB" sz="1400" b="1" dirty="0">
                 <a:solidFill>
                   <a:srgbClr val="0F1522"/>
                 </a:solidFill>
@@ -5726,26 +5317,20 @@
                 <a:ea typeface="Calibri" pitchFamily="34" charset="-122"/>
                 <a:cs typeface="Calibri" pitchFamily="34" charset="-120"/>
               </a:rPr>
-              <a:t>The balance never resets. </a:t>
-            </a:r>
-            <a:pPr indent="0" marL="0">
-              <a:lnSpc>
-                <a:spcPts val="2100"/>
-              </a:lnSpc>
-              <a:buNone/>
-            </a:pPr>
-            <a:r>
-              <a:rPr lang="en-US" sz="1400" dirty="0">
-                <a:solidFill>
-                  <a:srgbClr val="4B5565"/>
+              <a:t>Your balance never resets.</a:t>
+            </a:r>
+            <a:r>
+              <a:rPr lang="en-GB" sz="1400" dirty="0">
+                <a:solidFill>
+                  <a:srgbClr val="0F1522"/>
                 </a:solidFill>
                 <a:latin typeface="Calibri" pitchFamily="34" charset="0"/>
                 <a:ea typeface="Calibri" pitchFamily="34" charset="-122"/>
                 <a:cs typeface="Calibri" pitchFamily="34" charset="-120"/>
               </a:rPr>
-              <a:t>It is your standing position, carried indefinitely, starting from whatever you were already up or down.</a:t>
-            </a:r>
-            <a:endParaRPr lang="en-US" sz="1400" dirty="0"/>
+              <a:t> It carries on from wherever you were already up or down, week after week.</a:t>
+            </a:r>
+            <a:endParaRPr lang="en-GB" sz="1400" dirty="0"/>
           </a:p>
         </p:txBody>
       </p:sp>
@@ -5857,7 +5442,7 @@
               <a:buNone/>
             </a:pPr>
             <a:r>
-              <a:rPr lang="en-US" sz="1100" b="1" spc="240" kern="0" dirty="0">
+              <a:rPr lang="en-GB" sz="1100" b="1" spc="240" kern="0" dirty="0">
                 <a:solidFill>
                   <a:srgbClr val="2F6BC4"/>
                 </a:solidFill>
@@ -5865,9 +5450,9 @@
                 <a:ea typeface="Arial" pitchFamily="34" charset="-122"/>
                 <a:cs typeface="Arial" pitchFamily="34" charset="-120"/>
               </a:rPr>
-              <a:t>TWO THINGS YOU CAN SWITCH OFF</a:t>
-            </a:r>
-            <a:endParaRPr lang="en-US" sz="1100" dirty="0"/>
+              <a:t>COACH MODE AND THE DAILY CHECK-IN  ·  BOTH OPTIONAL</a:t>
+            </a:r>
+            <a:endParaRPr lang="en-GB" sz="1100" dirty="0"/>
           </a:p>
         </p:txBody>
       </p:sp>
@@ -5899,7 +5484,7 @@
               <a:buNone/>
             </a:pPr>
             <a:r>
-              <a:rPr lang="en-US" sz="3200" b="1" dirty="0">
+              <a:rPr lang="en-GB" sz="3200" b="1" dirty="0">
                 <a:solidFill>
                   <a:srgbClr val="0F1522"/>
                 </a:solidFill>
@@ -5907,9 +5492,9 @@
                 <a:ea typeface="Arial" pitchFamily="34" charset="-122"/>
                 <a:cs typeface="Arial" pitchFamily="34" charset="-120"/>
               </a:rPr>
-              <a:t>One reads your figures back.</a:t>
-            </a:r>
-            <a:endParaRPr lang="en-US" sz="3200" dirty="0"/>
+              <a:t>Coach works out the way back.</a:t>
+            </a:r>
+            <a:endParaRPr lang="en-GB" sz="3200" dirty="0"/>
           </a:p>
           <a:p>
             <a:pPr indent="0" marL="0">
@@ -5919,7 +5504,7 @@
               <a:buNone/>
             </a:pPr>
             <a:r>
-              <a:rPr lang="en-US" sz="3200" b="1" dirty="0">
+              <a:rPr lang="en-GB" sz="3200" b="1" dirty="0">
                 <a:solidFill>
                   <a:srgbClr val="0F1522"/>
                 </a:solidFill>
@@ -5927,9 +5512,9 @@
                 <a:ea typeface="Arial" pitchFamily="34" charset="-122"/>
                 <a:cs typeface="Arial" pitchFamily="34" charset="-120"/>
               </a:rPr>
-              <a:t>The other, nobody else sees.</a:t>
-            </a:r>
-            <a:endParaRPr lang="en-US" sz="3200" dirty="0"/>
+              <a:t>The check-in is your own diary.</a:t>
+            </a:r>
+            <a:endParaRPr lang="en-GB" sz="3200" dirty="0"/>
           </a:p>
         </p:txBody>
       </p:sp>
@@ -5985,7 +5570,7 @@
               <a:buNone/>
             </a:pPr>
             <a:r>
-              <a:rPr lang="en-US" sz="2100" b="1" dirty="0">
+              <a:rPr lang="en-GB" sz="2100" b="1" dirty="0">
                 <a:solidFill>
                   <a:srgbClr val="0F1522"/>
                 </a:solidFill>
@@ -5993,9 +5578,9 @@
                 <a:ea typeface="Arial" pitchFamily="34" charset="-122"/>
                 <a:cs typeface="Arial" pitchFamily="34" charset="-120"/>
               </a:rPr>
-              <a:t>Coach</a:t>
-            </a:r>
-            <a:endParaRPr lang="en-US" sz="2100" dirty="0"/>
+              <a:t>Coach Mode</a:t>
+            </a:r>
+            <a:endParaRPr lang="en-GB" sz="2100" dirty="0"/>
           </a:p>
         </p:txBody>
       </p:sp>
@@ -6015,8 +5600,8 @@
         </p:blipFill>
         <p:spPr>
           <a:xfrm>
-            <a:off x="877824" y="3127248"/>
-            <a:ext cx="4818888" cy="1897942"/>
+            <a:off x="877824" y="3108960"/>
+            <a:ext cx="3931920" cy="1554480"/>
           </a:xfrm>
           <a:prstGeom prst="rect">
             <a:avLst/>
@@ -6031,27 +5616,30 @@
         </p:nvSpPr>
         <p:spPr>
           <a:xfrm>
-            <a:off x="877824" y="5189782"/>
-            <a:ext cx="4818888" cy="868680"/>
-          </a:xfrm>
-          <a:prstGeom prst="rect">
-            <a:avLst/>
-          </a:prstGeom>
-          <a:noFill/>
-          <a:ln/>
-        </p:spPr>
-        <p:txBody>
-          <a:bodyPr wrap="square" lIns="0" tIns="0" rIns="0" bIns="0" rtlCol="0" anchor="ctr"/>
+            <a:off x="877824" y="4773168"/>
+            <a:ext cx="4818888" cy="1371600"/>
+          </a:xfrm>
+          <a:prstGeom prst="rect">
+            <a:avLst/>
+          </a:prstGeom>
+          <a:noFill/>
+          <a:ln/>
+        </p:spPr>
+        <p:txBody>
+          <a:bodyPr wrap="square" lIns="0" tIns="0" rIns="0" bIns="0" rtlCol="0" anchor="t"/>
           <a:lstStyle/>
           <a:p>
             <a:pPr indent="0" marL="0">
               <a:lnSpc>
-                <a:spcPts val="1600"/>
+                <a:spcPts val="1450"/>
               </a:lnSpc>
-              <a:buNone/>
-            </a:pPr>
-            <a:r>
-              <a:rPr lang="en-US" sz="1200" b="1" dirty="0">
+              <a:spcAft>
+                <a:spcPts val="500"/>
+              </a:spcAft>
+              <a:buNone/>
+            </a:pPr>
+            <a:r>
+              <a:rPr lang="en-GB" sz="1150" b="1" dirty="0">
                 <a:solidFill>
                   <a:srgbClr val="0F1522"/>
                 </a:solidFill>
@@ -6059,26 +5647,88 @@
                 <a:ea typeface="Calibri" pitchFamily="34" charset="-122"/>
                 <a:cs typeface="Calibri" pitchFamily="34" charset="-120"/>
               </a:rPr>
-              <a:t>It will not name a job you were not given.</a:t>
-            </a:r>
-            <a:pPr indent="0" marL="0">
-              <a:lnSpc>
-                <a:spcPts val="1600"/>
-              </a:lnSpc>
-              <a:buNone/>
-            </a:pPr>
-            <a:r>
-              <a:rPr lang="en-US" sz="1200" dirty="0">
-                <a:solidFill>
-                  <a:srgbClr val="4B5565"/>
+              <a:t>Your run rate.</a:t>
+            </a:r>
+            <a:r>
+              <a:rPr lang="en-GB" sz="1150" dirty="0">
+                <a:solidFill>
+                  <a:srgbClr val="0F1522"/>
                 </a:solidFill>
                 <a:latin typeface="Calibri" pitchFamily="34" charset="0"/>
                 <a:ea typeface="Calibri" pitchFamily="34" charset="-122"/>
                 <a:cs typeface="Calibri" pitchFamily="34" charset="-120"/>
               </a:rPr>
-              <a:t> Only work you genuinely choose — an inhibitor, a Hive product, a CO alarm. Never a service, repair or Long Duration, because suggesting dispatched work is suggesting you raise work that was not done.</a:t>
-            </a:r>
-            <a:endParaRPr lang="en-US" sz="1200" dirty="0"/>
+              <a:t> How many jobs, or how many hours, get a deficit down, and by when. Keep going as you are today and it tells you where you’ll be in ten days.</a:t>
+            </a:r>
+            <a:endParaRPr lang="en-GB" sz="1150" dirty="0"/>
+          </a:p>
+          <a:p>
+            <a:pPr indent="0" marL="0">
+              <a:lnSpc>
+                <a:spcPts val="1450"/>
+              </a:lnSpc>
+              <a:spcAft>
+                <a:spcPts val="500"/>
+              </a:spcAft>
+              <a:buNone/>
+            </a:pPr>
+            <a:r>
+              <a:rPr lang="en-GB" sz="1150" b="1" dirty="0">
+                <a:solidFill>
+                  <a:srgbClr val="0F1522"/>
+                </a:solidFill>
+                <a:latin typeface="Calibri" pitchFamily="34" charset="0"/>
+                <a:ea typeface="Calibri" pitchFamily="34" charset="-122"/>
+                <a:cs typeface="Calibri" pitchFamily="34" charset="-120"/>
+              </a:rPr>
+              <a:t>What lifts the balance most.</a:t>
+            </a:r>
+            <a:r>
+              <a:rPr lang="en-GB" sz="1150" dirty="0">
+                <a:solidFill>
+                  <a:srgbClr val="0F1522"/>
+                </a:solidFill>
+                <a:latin typeface="Calibri" pitchFamily="34" charset="0"/>
+                <a:ea typeface="Calibri" pitchFamily="34" charset="-122"/>
+                <a:cs typeface="Calibri" pitchFamily="34" charset="-120"/>
+              </a:rPr>
+              <a:t> On the visit you’re already on: a Hive, an inhibitor, a CO alarm, a boiler lead. It shows what each one is worth against today’s gap.</a:t>
+            </a:r>
+            <a:endParaRPr lang="en-GB" sz="1150" dirty="0"/>
+          </a:p>
+          <a:p>
+            <a:pPr indent="0" marL="0">
+              <a:lnSpc>
+                <a:spcPts val="1450"/>
+              </a:lnSpc>
+              <a:spcAft>
+                <a:spcPts val="500"/>
+              </a:spcAft>
+              <a:buNone/>
+            </a:pPr>
+            <a:r>
+              <a:rPr lang="en-GB" sz="1150" b="1" dirty="0">
+                <a:solidFill>
+                  <a:srgbClr val="0F1522"/>
+                </a:solidFill>
+                <a:latin typeface="Calibri" pitchFamily="34" charset="0"/>
+                <a:ea typeface="Calibri" pitchFamily="34" charset="-122"/>
+                <a:cs typeface="Calibri" pitchFamily="34" charset="-120"/>
+              </a:rPr>
+              <a:t>Never dispatched work.</a:t>
+            </a:r>
+            <a:r>
+              <a:rPr lang="en-GB" sz="1150" dirty="0">
+                <a:solidFill>
+                  <a:srgbClr val="0F1522"/>
+                </a:solidFill>
+                <a:latin typeface="Calibri" pitchFamily="34" charset="0"/>
+                <a:ea typeface="Calibri" pitchFamily="34" charset="-122"/>
+                <a:cs typeface="Calibri" pitchFamily="34" charset="-120"/>
+              </a:rPr>
+              <a:t> It won’t suggest a service or a repair you weren’t given, so it can’t nudge anyone into raising work that wasn’t done.</a:t>
+            </a:r>
+            <a:endParaRPr lang="en-GB" sz="1150" dirty="0"/>
           </a:p>
         </p:txBody>
       </p:sp>
@@ -6134,7 +5784,7 @@
               <a:buNone/>
             </a:pPr>
             <a:r>
-              <a:rPr lang="en-US" sz="2100" b="1" dirty="0">
+              <a:rPr lang="en-GB" sz="2100" b="1" dirty="0">
                 <a:solidFill>
                   <a:srgbClr val="0F1522"/>
                 </a:solidFill>
@@ -6144,7 +5794,7 @@
               </a:rPr>
               <a:t>The daily check-in</a:t>
             </a:r>
-            <a:endParaRPr lang="en-US" sz="2100" dirty="0"/>
+            <a:endParaRPr lang="en-GB" sz="2100" dirty="0"/>
           </a:p>
         </p:txBody>
       </p:sp>
@@ -6180,27 +5830,30 @@
         </p:nvSpPr>
         <p:spPr>
           <a:xfrm>
-            <a:off x="6684264" y="4238908"/>
-            <a:ext cx="4818888" cy="731520"/>
-          </a:xfrm>
-          <a:prstGeom prst="rect">
-            <a:avLst/>
-          </a:prstGeom>
-          <a:noFill/>
-          <a:ln/>
-        </p:spPr>
-        <p:txBody>
-          <a:bodyPr wrap="square" lIns="0" tIns="0" rIns="0" bIns="0" rtlCol="0" anchor="ctr"/>
+            <a:off x="6684264" y="4224528"/>
+            <a:ext cx="4818888" cy="1874519"/>
+          </a:xfrm>
+          <a:prstGeom prst="rect">
+            <a:avLst/>
+          </a:prstGeom>
+          <a:noFill/>
+          <a:ln/>
+        </p:spPr>
+        <p:txBody>
+          <a:bodyPr wrap="square" lIns="0" tIns="0" rIns="0" bIns="0" rtlCol="0" anchor="t"/>
           <a:lstStyle/>
           <a:p>
             <a:pPr indent="0" marL="0">
               <a:lnSpc>
-                <a:spcPts val="1600"/>
+                <a:spcPts val="1500"/>
               </a:lnSpc>
-              <a:buNone/>
-            </a:pPr>
-            <a:r>
-              <a:rPr lang="en-US" sz="1200" b="1" dirty="0">
+              <a:spcAft>
+                <a:spcPts val="600"/>
+              </a:spcAft>
+              <a:buNone/>
+            </a:pPr>
+            <a:r>
+              <a:rPr lang="en-GB" sz="1200" b="1" dirty="0">
                 <a:solidFill>
                   <a:srgbClr val="0F1522"/>
                 </a:solidFill>
@@ -6208,85 +5861,88 @@
                 <a:ea typeface="Calibri" pitchFamily="34" charset="-122"/>
                 <a:cs typeface="Calibri" pitchFamily="34" charset="-120"/>
               </a:rPr>
-              <a:t>Your CTAP target is not your goal.</a:t>
-            </a:r>
-            <a:pPr indent="0" marL="0">
-              <a:lnSpc>
-                <a:spcPts val="1600"/>
-              </a:lnSpc>
-              <a:buNone/>
-            </a:pPr>
-            <a:r>
-              <a:rPr lang="en-US" sz="1200" dirty="0">
-                <a:solidFill>
-                  <a:srgbClr val="4B5565"/>
+              <a:t>Built on GROW.</a:t>
+            </a:r>
+            <a:r>
+              <a:rPr lang="en-GB" sz="1200" dirty="0">
+                <a:solidFill>
+                  <a:srgbClr val="0F1522"/>
                 </a:solidFill>
                 <a:latin typeface="Calibri" pitchFamily="34" charset="0"/>
                 <a:ea typeface="Calibri" pitchFamily="34" charset="-122"/>
                 <a:cs typeface="Calibri" pitchFamily="34" charset="-120"/>
               </a:rPr>
-              <a:t> The target is the employer’s number, presented as Reality. The goal is the one thing the engineer picked.</a:t>
-            </a:r>
-            <a:endParaRPr lang="en-US" sz="1200" dirty="0"/>
-          </a:p>
-        </p:txBody>
-      </p:sp>
-      <p:sp>
-        <p:nvSpPr>
-          <p:cNvPr id="12" name="Text 8"/>
-          <p:cNvSpPr txBox="1"/>
-          <p:nvPr/>
-        </p:nvSpPr>
-        <p:spPr>
-          <a:xfrm>
-            <a:off x="6684264" y="5043580"/>
-            <a:ext cx="4818888" cy="777240"/>
-          </a:xfrm>
-          <a:prstGeom prst="rect">
-            <a:avLst/>
-          </a:prstGeom>
-          <a:noFill/>
-          <a:ln/>
-        </p:spPr>
-        <p:txBody>
-          <a:bodyPr wrap="square" lIns="0" tIns="0" rIns="0" bIns="0" rtlCol="0" anchor="ctr"/>
-          <a:lstStyle/>
+              <a:t> Goal, Reality, Options, Will. One question a day, and it takes under a minute.</a:t>
+            </a:r>
+            <a:endParaRPr lang="en-GB" sz="1200" dirty="0"/>
+          </a:p>
           <a:p>
             <a:pPr indent="0" marL="0">
               <a:lnSpc>
-                <a:spcPts val="1600"/>
+                <a:spcPts val="1500"/>
               </a:lnSpc>
-              <a:buNone/>
-            </a:pPr>
-            <a:r>
-              <a:rPr lang="en-US" sz="1200" b="1" dirty="0">
-                <a:solidFill>
-                  <a:srgbClr val="1F8A4C"/>
+              <a:spcAft>
+                <a:spcPts val="600"/>
+              </a:spcAft>
+              <a:buNone/>
+            </a:pPr>
+            <a:r>
+              <a:rPr lang="en-GB" sz="1200" b="1" dirty="0">
+                <a:solidFill>
+                  <a:srgbClr val="0F1522"/>
                 </a:solidFill>
                 <a:latin typeface="Calibri" pitchFamily="34" charset="0"/>
                 <a:ea typeface="Calibri" pitchFamily="34" charset="-122"/>
                 <a:cs typeface="Calibri" pitchFamily="34" charset="-120"/>
               </a:rPr>
-              <a:t>Nobody else ever sees it.</a:t>
-            </a:r>
-            <a:pPr indent="0" marL="0">
-              <a:lnSpc>
-                <a:spcPts val="1600"/>
-              </a:lnSpc>
-              <a:buNone/>
-            </a:pPr>
-            <a:r>
-              <a:rPr lang="en-US" sz="1200" dirty="0">
-                <a:solidFill>
-                  <a:srgbClr val="4B5565"/>
+              <a:t>An honest diary.</a:t>
+            </a:r>
+            <a:r>
+              <a:rPr lang="en-GB" sz="1200" dirty="0">
+                <a:solidFill>
+                  <a:srgbClr val="0F1522"/>
                 </a:solidFill>
                 <a:latin typeface="Calibri" pitchFamily="34" charset="0"/>
                 <a:ea typeface="Calibri" pitchFamily="34" charset="-122"/>
                 <a:cs typeface="Calibri" pitchFamily="34" charset="-120"/>
               </a:rPr>
-              <a:t> No team view, no aggregate, no export, no comparison between engineers. That is how it is built, not a setting someone could change.</a:t>
-            </a:r>
-            <a:endParaRPr lang="en-US" sz="1200" dirty="0"/>
+              <a:t> Where the gaps in the day were, what you’re struggling with, what you’d do differently. It’s there for the engineers who genuinely want to use it.</a:t>
+            </a:r>
+            <a:endParaRPr lang="en-GB" sz="1200" dirty="0"/>
+          </a:p>
+          <a:p>
+            <a:pPr indent="0" marL="0">
+              <a:lnSpc>
+                <a:spcPts val="1500"/>
+              </a:lnSpc>
+              <a:spcAft>
+                <a:spcPts val="600"/>
+              </a:spcAft>
+              <a:buNone/>
+            </a:pPr>
+            <a:r>
+              <a:rPr lang="en-GB" sz="1200" b="1" dirty="0">
+                <a:solidFill>
+                  <a:srgbClr val="0F1522"/>
+                </a:solidFill>
+                <a:latin typeface="Calibri" pitchFamily="34" charset="0"/>
+                <a:ea typeface="Calibri" pitchFamily="34" charset="-122"/>
+                <a:cs typeface="Calibri" pitchFamily="34" charset="-120"/>
+              </a:rPr>
+              <a:t>Only you can read it.</a:t>
+            </a:r>
+            <a:r>
+              <a:rPr lang="en-GB" sz="1200" dirty="0">
+                <a:solidFill>
+                  <a:srgbClr val="0F1522"/>
+                </a:solidFill>
+                <a:latin typeface="Calibri" pitchFamily="34" charset="0"/>
+                <a:ea typeface="Calibri" pitchFamily="34" charset="-122"/>
+                <a:cs typeface="Calibri" pitchFamily="34" charset="-120"/>
+              </a:rPr>
+              <a:t> No team view, no export, no comparing engineers. That’s how it’s built, not a setting.</a:t>
+            </a:r>
+            <a:endParaRPr lang="en-GB" sz="1200" dirty="0"/>
           </a:p>
         </p:txBody>
       </p:sp>
@@ -6347,7 +6003,7 @@
               <a:buNone/>
             </a:pPr>
             <a:r>
-              <a:rPr lang="en-US" sz="1100" b="1" spc="240" kern="0" dirty="0">
+              <a:rPr lang="en-GB" sz="1100" b="1" spc="240" kern="0" dirty="0">
                 <a:solidFill>
                   <a:srgbClr val="2F6BC4"/>
                 </a:solidFill>
@@ -6355,9 +6011,9 @@
                 <a:ea typeface="Arial" pitchFamily="34" charset="-122"/>
                 <a:cs typeface="Arial" pitchFamily="34" charset="-120"/>
               </a:rPr>
-              <a:t>WHERE THE FIGURES LIVE</a:t>
-            </a:r>
-            <a:endParaRPr lang="en-US" sz="1100" dirty="0"/>
+              <a:t>YOUR DATA</a:t>
+            </a:r>
+            <a:endParaRPr lang="en-GB" sz="1100" dirty="0"/>
           </a:p>
         </p:txBody>
       </p:sp>
@@ -6389,7 +6045,7 @@
               <a:buNone/>
             </a:pPr>
             <a:r>
-              <a:rPr lang="en-US" sz="3400" b="1" dirty="0">
+              <a:rPr lang="en-GB" sz="3400" b="1" dirty="0">
                 <a:solidFill>
                   <a:srgbClr val="0F1522"/>
                 </a:solidFill>
@@ -6397,9 +6053,9 @@
                 <a:ea typeface="Arial" pitchFamily="34" charset="-122"/>
                 <a:cs typeface="Arial" pitchFamily="34" charset="-120"/>
               </a:rPr>
-              <a:t>On the engineer’s phone.</a:t>
-            </a:r>
-            <a:endParaRPr lang="en-US" sz="3400" dirty="0"/>
+              <a:t>Everything stays</a:t>
+            </a:r>
+            <a:endParaRPr lang="en-GB" sz="3400" dirty="0"/>
           </a:p>
           <a:p>
             <a:pPr indent="0" marL="0">
@@ -6409,7 +6065,7 @@
               <a:buNone/>
             </a:pPr>
             <a:r>
-              <a:rPr lang="en-US" sz="3400" b="1" dirty="0">
+              <a:rPr lang="en-GB" sz="3400" b="1" dirty="0">
                 <a:solidFill>
                   <a:srgbClr val="0F1522"/>
                 </a:solidFill>
@@ -6417,9 +6073,9 @@
                 <a:ea typeface="Arial" pitchFamily="34" charset="-122"/>
                 <a:cs typeface="Arial" pitchFamily="34" charset="-120"/>
               </a:rPr>
-              <a:t>That is the whole answer.</a:t>
-            </a:r>
-            <a:endParaRPr lang="en-US" sz="3400" dirty="0"/>
+              <a:t>on your phone.</a:t>
+            </a:r>
+            <a:endParaRPr lang="en-GB" sz="3400" dirty="0"/>
           </a:p>
         </p:txBody>
       </p:sp>
@@ -6451,7 +6107,7 @@
               <a:buNone/>
             </a:pPr>
             <a:r>
-              <a:rPr lang="en-US" sz="1500" dirty="0">
+              <a:rPr lang="en-GB" sz="1500" dirty="0">
                 <a:solidFill>
                   <a:srgbClr val="4B5565"/>
                 </a:solidFill>
@@ -6459,9 +6115,9 @@
                 <a:ea typeface="Calibri" pitchFamily="34" charset="-122"/>
                 <a:cs typeface="Calibri" pitchFamily="34" charset="-120"/>
               </a:rPr>
-              <a:t>The question was never whether someone could read an engineer’s CTAP figures. It was whether they leave the device at all — and that cannot be answered with better encryption, only with no transmission.</a:t>
-            </a:r>
-            <a:endParaRPr lang="en-US" sz="1500" dirty="0"/>
+              <a:t>It’s completely secure, because there’s nothing to secure: every figure you log lives on your own phone and nowhere else. No account, no upload, no server. Nobody can see your CTAP figures but you.</a:t>
+            </a:r>
+            <a:endParaRPr lang="en-GB" sz="1500" dirty="0"/>
           </a:p>
         </p:txBody>
       </p:sp>
@@ -6532,7 +6188,7 @@
               <a:buNone/>
             </a:pPr>
             <a:r>
-              <a:rPr lang="en-US" sz="1300" dirty="0">
+              <a:rPr lang="en-GB" sz="1300" dirty="0">
                 <a:solidFill>
                   <a:srgbClr val="4B5565"/>
                 </a:solidFill>
@@ -6542,7 +6198,7 @@
               </a:rPr>
               <a:t>None. Nothing to sign into, nothing to sign out of.</a:t>
             </a:r>
-            <a:endParaRPr lang="en-US" sz="1300" dirty="0"/>
+            <a:endParaRPr lang="en-GB" sz="1300" dirty="0"/>
           </a:p>
         </p:txBody>
       </p:sp>
@@ -6638,7 +6294,7 @@
               <a:buNone/>
             </a:pPr>
             <a:r>
-              <a:rPr lang="en-US" sz="1300" dirty="0">
+              <a:rPr lang="en-GB" sz="1300" dirty="0">
                 <a:solidFill>
                   <a:srgbClr val="4B5565"/>
                 </a:solidFill>
@@ -6646,9 +6302,9 @@
                 <a:ea typeface="Calibri" pitchFamily="34" charset="-122"/>
                 <a:cs typeface="Calibri" pitchFamily="34" charset="-120"/>
               </a:rPr>
-              <a:t>None. Once installed it makes no network requests at all — it does not even fetch its own fonts.</a:t>
-            </a:r>
-            <a:endParaRPr lang="en-US" sz="1300" dirty="0"/>
+              <a:t>None. Once it’s installed it makes no network requests at all.</a:t>
+            </a:r>
+            <a:endParaRPr lang="en-GB" sz="1300" dirty="0"/>
           </a:p>
         </p:txBody>
       </p:sp>
@@ -6744,7 +6400,7 @@
               <a:buNone/>
             </a:pPr>
             <a:r>
-              <a:rPr lang="en-US" sz="1300" dirty="0">
+              <a:rPr lang="en-GB" sz="1300" dirty="0">
                 <a:solidFill>
                   <a:srgbClr val="4B5565"/>
                 </a:solidFill>
@@ -6752,9 +6408,9 @@
                 <a:ea typeface="Calibri" pitchFamily="34" charset="-122"/>
                 <a:cs typeface="Calibri" pitchFamily="34" charset="-120"/>
               </a:rPr>
-              <a:t>Nobody. Not the employer, not analytics, not me.</a:t>
-            </a:r>
-            <a:endParaRPr lang="en-US" sz="1300" dirty="0"/>
+              <a:t>Nobody. Not your manager, not me, no analytics.</a:t>
+            </a:r>
+            <a:endParaRPr lang="en-GB" sz="1300" dirty="0"/>
           </a:p>
         </p:txBody>
       </p:sp>
@@ -6850,7 +6506,7 @@
               <a:buNone/>
             </a:pPr>
             <a:r>
-              <a:rPr lang="en-US" sz="1300" dirty="0">
+              <a:rPr lang="en-GB" sz="1300" dirty="0">
                 <a:solidFill>
                   <a:srgbClr val="4B5565"/>
                 </a:solidFill>
@@ -6858,9 +6514,9 @@
                 <a:ea typeface="Calibri" pitchFamily="34" charset="-122"/>
                 <a:cs typeface="Calibri" pitchFamily="34" charset="-120"/>
               </a:rPr>
-              <a:t>Works fully — which matters, because plant rooms and cellars are where signal is worst.</a:t>
-            </a:r>
-            <a:endParaRPr lang="en-US" sz="1300" dirty="0"/>
+              <a:t>Works fully, which matters in plant rooms and cellars.</a:t>
+            </a:r>
+            <a:endParaRPr lang="en-GB" sz="1300" dirty="0"/>
           </a:p>
         </p:txBody>
       </p:sp>
@@ -6956,7 +6612,7 @@
               <a:buNone/>
             </a:pPr>
             <a:r>
-              <a:rPr lang="en-US" sz="1300" dirty="0">
+              <a:rPr lang="en-GB" sz="1300" dirty="0">
                 <a:solidFill>
                   <a:srgbClr val="4B5565"/>
                 </a:solidFill>
@@ -6964,9 +6620,9 @@
                 <a:ea typeface="Calibri" pitchFamily="34" charset="-122"/>
                 <a:cs typeface="Calibri" pitchFamily="34" charset="-120"/>
               </a:rPr>
-              <a:t>Settings → Erase all data. Immediate and total.</a:t>
-            </a:r>
-            <a:endParaRPr lang="en-US" sz="1300" dirty="0"/>
+              <a:t>Settings → Erase all data, and it’s gone straight away.</a:t>
+            </a:r>
+            <a:endParaRPr lang="en-GB" sz="1300" dirty="0"/>
           </a:p>
         </p:txBody>
       </p:sp>
@@ -7061,7 +6717,7 @@
               <a:buNone/>
             </a:pPr>
             <a:r>
-              <a:rPr lang="en-US" sz="1700" b="1" dirty="0">
+              <a:rPr lang="en-GB" sz="1700" b="1" dirty="0">
                 <a:solidFill>
                   <a:srgbClr val="0F1522"/>
                 </a:solidFill>
@@ -7069,9 +6725,9 @@
                 <a:ea typeface="Arial" pitchFamily="34" charset="-122"/>
                 <a:cs typeface="Arial" pitchFamily="34" charset="-120"/>
               </a:rPr>
-              <a:t>The flip side</a:t>
-            </a:r>
-            <a:endParaRPr lang="en-US" sz="1700" dirty="0"/>
+              <a:t>The one catch</a:t>
+            </a:r>
+            <a:endParaRPr lang="en-GB" sz="1700" dirty="0"/>
           </a:p>
         </p:txBody>
       </p:sp>
@@ -7100,10 +6756,13 @@
               <a:lnSpc>
                 <a:spcPts val="1900"/>
               </a:lnSpc>
-              <a:buNone/>
-            </a:pPr>
-            <a:r>
-              <a:rPr lang="en-US" sz="1300" dirty="0">
+              <a:spcAft>
+                <a:spcPts val="600"/>
+              </a:spcAft>
+              <a:buNone/>
+            </a:pPr>
+            <a:r>
+              <a:rPr lang="en-GB" sz="1300" dirty="0">
                 <a:solidFill>
                   <a:srgbClr val="4B5565"/>
                 </a:solidFill>
@@ -7111,28 +6770,22 @@
                 <a:ea typeface="Calibri" pitchFamily="34" charset="-122"/>
                 <a:cs typeface="Calibri" pitchFamily="34" charset="-120"/>
               </a:rPr>
-              <a:t>There is no backup. Delete the app, erase the data or lose the phone and it is gone. Nobody can recover it, because nobody else ever had it.</a:t>
-            </a:r>
-            <a:endParaRPr lang="en-US" sz="1300" dirty="0"/>
+              <a:t>There’s no backup. Delete the app, erase the data or lose the phone and it’s gone. Nobody can get it back, because nobody else ever had it.</a:t>
+            </a:r>
+            <a:endParaRPr lang="en-GB" sz="1300" dirty="0"/>
           </a:p>
           <a:p>
             <a:pPr indent="0" marL="0">
               <a:lnSpc>
                 <a:spcPts val="1900"/>
               </a:lnSpc>
-              <a:buNone/>
-            </a:pPr>
-            <a:endParaRPr lang="en-US" sz="1300" dirty="0"/>
-          </a:p>
-          <a:p>
-            <a:pPr indent="0" marL="0">
-              <a:lnSpc>
-                <a:spcPts val="1900"/>
-              </a:lnSpc>
-              <a:buNone/>
-            </a:pPr>
-            <a:r>
-              <a:rPr lang="en-US" sz="1300" dirty="0">
+              <a:spcAft>
+                <a:spcPts val="600"/>
+              </a:spcAft>
+              <a:buNone/>
+            </a:pPr>
+            <a:r>
+              <a:rPr lang="en-GB" sz="1300" dirty="0">
                 <a:solidFill>
                   <a:srgbClr val="4B5565"/>
                 </a:solidFill>
@@ -7142,7 +6795,7 @@
               </a:rPr>
               <a:t>Engineers are told this before they start.</a:t>
             </a:r>
-            <a:endParaRPr lang="en-US" sz="1300" dirty="0"/>
+            <a:endParaRPr lang="en-GB" sz="1300" dirty="0"/>
           </a:p>
         </p:txBody>
       </p:sp>
@@ -7245,7 +6898,7 @@
               <a:buNone/>
             </a:pPr>
             <a:r>
-              <a:rPr lang="en-US" sz="3400" b="1" dirty="0">
+              <a:rPr lang="en-GB" sz="3400" b="1" dirty="0">
                 <a:solidFill>
                   <a:srgbClr val="0F1522"/>
                 </a:solidFill>
@@ -7253,9 +6906,9 @@
                 <a:ea typeface="Arial" pitchFamily="34" charset="-122"/>
                 <a:cs typeface="Arial" pitchFamily="34" charset="-120"/>
               </a:rPr>
-              <a:t>Where this build is up to.</a:t>
-            </a:r>
-            <a:endParaRPr lang="en-US" sz="3400" dirty="0"/>
+              <a:t>Where it’s up to, and who I’m after.</a:t>
+            </a:r>
+            <a:endParaRPr lang="en-GB" sz="3400" dirty="0"/>
           </a:p>
         </p:txBody>
       </p:sp>
@@ -7643,7 +7296,7 @@
                 <a:ea typeface="Arial" pitchFamily="34" charset="-122"/>
                 <a:cs typeface="Arial" pitchFamily="34" charset="-120"/>
               </a:rPr>
-              <a:t>384</a:t>
+              <a:t>429</a:t>
             </a:r>
             <a:endParaRPr lang="en-US" sz="3800" dirty="0"/>
           </a:p>
@@ -7716,7 +7369,7 @@
               <a:buNone/>
             </a:pPr>
             <a:r>
-              <a:rPr lang="en-US" sz="1900" b="1" dirty="0">
+              <a:rPr lang="en-GB" sz="1900" b="1" dirty="0">
                 <a:solidFill>
                   <a:srgbClr val="0F1522"/>
                 </a:solidFill>
@@ -7724,9 +7377,9 @@
                 <a:ea typeface="Arial" pitchFamily="34" charset="-122"/>
                 <a:cs typeface="Arial" pitchFamily="34" charset="-120"/>
               </a:rPr>
-              <a:t>Still open</a:t>
-            </a:r>
-            <a:endParaRPr lang="en-US" sz="1900" dirty="0"/>
+              <a:t>Who I’m looking for</a:t>
+            </a:r>
+            <a:endParaRPr lang="en-GB" sz="1900" dirty="0"/>
           </a:p>
         </p:txBody>
       </p:sp>
@@ -7738,31 +7391,31 @@
         </p:nvSpPr>
         <p:spPr>
           <a:xfrm>
-            <a:off x="566928" y="4892040"/>
-            <a:ext cx="10881360" cy="1371600"/>
-          </a:xfrm>
-          <a:prstGeom prst="rect">
-            <a:avLst/>
-          </a:prstGeom>
-          <a:noFill/>
-          <a:ln/>
-        </p:spPr>
-        <p:txBody>
-          <a:bodyPr wrap="square" lIns="0" tIns="0" rIns="0" bIns="0" rtlCol="0" anchor="ctr"/>
+            <a:off x="566928" y="4846320"/>
+            <a:ext cx="10881360" cy="1051560"/>
+          </a:xfrm>
+          <a:prstGeom prst="rect">
+            <a:avLst/>
+          </a:prstGeom>
+          <a:noFill/>
+          <a:ln/>
+        </p:spPr>
+        <p:txBody>
+          <a:bodyPr wrap="square" lIns="0" tIns="0" rIns="0" bIns="0" rtlCol="0" anchor="t"/>
           <a:lstStyle/>
           <a:p>
             <a:pPr marL="342900" indent="-342900">
               <a:lnSpc>
-                <a:spcPts val="1900"/>
+                <a:spcPts val="1800"/>
               </a:lnSpc>
               <a:spcAft>
-                <a:spcPts val="800"/>
+                <a:spcPts val="500"/>
               </a:spcAft>
               <a:buSzPct val="100000"/>
               <a:buChar char="•"/>
             </a:pPr>
             <a:r>
-              <a:rPr lang="en-US" sz="1400" dirty="0">
+              <a:rPr lang="en-GB" sz="1400" dirty="0">
                 <a:solidFill>
                   <a:srgbClr val="4B5565"/>
                 </a:solidFill>
@@ -7770,23 +7423,23 @@
                 <a:ea typeface="Calibri" pitchFamily="34" charset="-122"/>
                 <a:cs typeface="Calibri" pitchFamily="34" charset="-120"/>
               </a:rPr>
-              <a:t>Nine catalogue credit times carried over from an older sheet still need checking against ID1923.</a:t>
-            </a:r>
-            <a:endParaRPr lang="en-US" sz="1400" dirty="0"/>
+              <a:t>Engineers in a slight deficit who want to get it back.</a:t>
+            </a:r>
+            <a:endParaRPr lang="en-GB" sz="1400" dirty="0"/>
           </a:p>
           <a:p>
             <a:pPr marL="342900" indent="-342900">
               <a:lnSpc>
-                <a:spcPts val="1900"/>
+                <a:spcPts val="1800"/>
               </a:lnSpc>
               <a:spcAft>
-                <a:spcPts val="800"/>
+                <a:spcPts val="500"/>
               </a:spcAft>
               <a:buSzPct val="100000"/>
               <a:buChar char="•"/>
             </a:pPr>
             <a:r>
-              <a:rPr lang="en-US" sz="1400" dirty="0">
+              <a:rPr lang="en-GB" sz="1400" dirty="0">
                 <a:solidFill>
                   <a:srgbClr val="4B5565"/>
                 </a:solidFill>
@@ -7794,23 +7447,23 @@
                 <a:ea typeface="Calibri" pitchFamily="34" charset="-122"/>
                 <a:cs typeface="Calibri" pitchFamily="34" charset="-120"/>
               </a:rPr>
-              <a:t>Offline needs one pass on a real handset — the logic is covered by tests, but nobody has watched it work in a cellar.</a:t>
-            </a:r>
-            <a:endParaRPr lang="en-US" sz="1400" dirty="0"/>
+              <a:t>New recruits who aren’t on CTAP yet, or are just starting.</a:t>
+            </a:r>
+            <a:endParaRPr lang="en-GB" sz="1400" dirty="0"/>
           </a:p>
           <a:p>
             <a:pPr marL="342900" indent="-342900">
               <a:lnSpc>
-                <a:spcPts val="1900"/>
+                <a:spcPts val="1800"/>
               </a:lnSpc>
               <a:spcAft>
-                <a:spcPts val="800"/>
+                <a:spcPts val="500"/>
               </a:spcAft>
               <a:buSzPct val="100000"/>
               <a:buChar char="•"/>
             </a:pPr>
             <a:r>
-              <a:rPr lang="en-US" sz="1400" dirty="0">
+              <a:rPr lang="en-GB" sz="1400" dirty="0">
                 <a:solidFill>
                   <a:srgbClr val="4B5565"/>
                 </a:solidFill>
@@ -7818,9 +7471,90 @@
                 <a:ea typeface="Calibri" pitchFamily="34" charset="-122"/>
                 <a:cs typeface="Calibri" pitchFamily="34" charset="-120"/>
               </a:rPr>
-              <a:t>No export yet. It is the obvious next feature, deliberately left out to keep the trial build small.</a:t>
-            </a:r>
-            <a:endParaRPr lang="en-US" sz="1400" dirty="0"/>
+              <a:t>Anyone a manager thinks would get something out of seeing their figures day to day.</a:t>
+            </a:r>
+            <a:endParaRPr lang="en-GB" sz="1400" dirty="0"/>
+          </a:p>
+        </p:txBody>
+      </p:sp>
+      <p:sp>
+        <p:nvSpPr>
+          <p:cNvPr id="18" name="Text 16"/>
+          <p:cNvSpPr txBox="1"/>
+          <p:nvPr/>
+        </p:nvSpPr>
+        <p:spPr>
+          <a:xfrm>
+            <a:off x="566928" y="5961888"/>
+            <a:ext cx="10881360" cy="274320"/>
+          </a:xfrm>
+          <a:prstGeom prst="rect">
+            <a:avLst/>
+          </a:prstGeom>
+          <a:noFill/>
+          <a:ln/>
+        </p:spPr>
+        <p:txBody>
+          <a:bodyPr wrap="square" lIns="0" tIns="0" rIns="0" bIns="0" rtlCol="0" anchor="ctr"/>
+          <a:lstStyle/>
+          <a:p>
+            <a:pPr indent="0" marL="0">
+              <a:buNone/>
+            </a:pPr>
+            <a:r>
+              <a:rPr lang="en-GB" sz="1300" dirty="0">
+                <a:solidFill>
+                  <a:srgbClr val="6B7485"/>
+                </a:solidFill>
+                <a:latin typeface="Calibri" pitchFamily="34" charset="0"/>
+                <a:ea typeface="Calibri" pitchFamily="34" charset="-122"/>
+                <a:cs typeface="Calibri" pitchFamily="34" charset="-120"/>
+              </a:rPr>
+              <a:t>Jake Rainford  ·  Service &amp; Repair Engineer  ·  any questions, get me on email or Teams</a:t>
+            </a:r>
+            <a:endParaRPr lang="en-GB" sz="1300" dirty="0"/>
+          </a:p>
+        </p:txBody>
+      </p:sp>
+      <p:sp>
+        <p:nvSpPr>
+          <p:cNvPr id="19" name="Text 17"/>
+          <p:cNvSpPr txBox="1"/>
+          <p:nvPr/>
+        </p:nvSpPr>
+        <p:spPr>
+          <a:xfrm>
+            <a:off x="566928" y="6291072"/>
+            <a:ext cx="10881360" cy="457200"/>
+          </a:xfrm>
+          <a:prstGeom prst="rect">
+            <a:avLst/>
+          </a:prstGeom>
+          <a:noFill/>
+          <a:ln/>
+        </p:spPr>
+        <p:txBody>
+          <a:bodyPr wrap="square" lIns="0" tIns="0" rIns="0" bIns="0" rtlCol="0" anchor="ctr"/>
+          <a:lstStyle/>
+          <a:p>
+            <a:pPr indent="0" marL="0">
+              <a:lnSpc>
+                <a:spcPts val="1400"/>
+              </a:lnSpc>
+              <a:buNone/>
+            </a:pPr>
+            <a:r>
+              <a:rPr lang="en-US" sz="1050" dirty="0">
+                <a:solidFill>
+                  <a:srgbClr val="6B7485"/>
+                </a:solidFill>
+                <a:latin typeface="Calibri" pitchFamily="34" charset="0"/>
+                <a:ea typeface="Calibri" pitchFamily="34" charset="-122"/>
+                <a:cs typeface="Calibri" pitchFamily="34" charset="-120"/>
+              </a:rPr>
+              <a:t>Personal estimates only — verify against your payslip and company tools. Not affiliated with, endorsed by, or representative of Centrica plc, British Gas or any employer.</a:t>
+            </a:r>
+            <a:endParaRPr lang="en-US" sz="1050" dirty="0"/>
           </a:p>
         </p:txBody>
       </p:sp>

</xml_diff>

<commit_message>
Keep the last slide to the tiles and the contact line
Co-Authored-By: Claude Fable 5.1 <noreply@anthropic.com>
</commit_message>
<xml_diff>
--- a/docs/presentation/CTAP-Tracker.pptx
+++ b/docs/presentation/CTAP-Tracker.pptx
@@ -6906,7 +6906,7 @@
                 <a:ea typeface="Arial" pitchFamily="34" charset="-122"/>
                 <a:cs typeface="Arial" pitchFamily="34" charset="-120"/>
               </a:rPr>
-              <a:t>Where it’s up to, and who I’m after.</a:t>
+              <a:t>Where it’s up to.</a:t>
             </a:r>
             <a:endParaRPr lang="en-GB" sz="3400" dirty="0"/>
           </a:p>
@@ -7346,146 +7346,13 @@
       </p:sp>
       <p:sp>
         <p:nvSpPr>
-          <p:cNvPr id="16" name="Text 14"/>
-          <p:cNvSpPr txBox="1"/>
-          <p:nvPr/>
-        </p:nvSpPr>
-        <p:spPr>
-          <a:xfrm>
-            <a:off x="566928" y="4434840"/>
-            <a:ext cx="5486400" cy="365760"/>
-          </a:xfrm>
-          <a:prstGeom prst="rect">
-            <a:avLst/>
-          </a:prstGeom>
-          <a:noFill/>
-          <a:ln/>
-        </p:spPr>
-        <p:txBody>
-          <a:bodyPr wrap="square" lIns="0" tIns="0" rIns="0" bIns="0" rtlCol="0" anchor="ctr"/>
-          <a:lstStyle/>
-          <a:p>
-            <a:pPr indent="0" marL="0">
-              <a:buNone/>
-            </a:pPr>
-            <a:r>
-              <a:rPr lang="en-GB" sz="1900" b="1" dirty="0">
-                <a:solidFill>
-                  <a:srgbClr val="0F1522"/>
-                </a:solidFill>
-                <a:latin typeface="Arial" pitchFamily="34" charset="0"/>
-                <a:ea typeface="Arial" pitchFamily="34" charset="-122"/>
-                <a:cs typeface="Arial" pitchFamily="34" charset="-120"/>
-              </a:rPr>
-              <a:t>Who I’m looking for</a:t>
-            </a:r>
-            <a:endParaRPr lang="en-GB" sz="1900" dirty="0"/>
-          </a:p>
-        </p:txBody>
-      </p:sp>
-      <p:sp>
-        <p:nvSpPr>
-          <p:cNvPr id="17" name="Text 15"/>
-          <p:cNvSpPr txBox="1"/>
-          <p:nvPr/>
-        </p:nvSpPr>
-        <p:spPr>
-          <a:xfrm>
-            <a:off x="566928" y="4846320"/>
-            <a:ext cx="10881360" cy="1051560"/>
-          </a:xfrm>
-          <a:prstGeom prst="rect">
-            <a:avLst/>
-          </a:prstGeom>
-          <a:noFill/>
-          <a:ln/>
-        </p:spPr>
-        <p:txBody>
-          <a:bodyPr wrap="square" lIns="0" tIns="0" rIns="0" bIns="0" rtlCol="0" anchor="t"/>
-          <a:lstStyle/>
-          <a:p>
-            <a:pPr marL="342900" indent="-342900">
-              <a:lnSpc>
-                <a:spcPts val="1800"/>
-              </a:lnSpc>
-              <a:spcAft>
-                <a:spcPts val="500"/>
-              </a:spcAft>
-              <a:buSzPct val="100000"/>
-              <a:buChar char="•"/>
-            </a:pPr>
-            <a:r>
-              <a:rPr lang="en-GB" sz="1400" dirty="0">
-                <a:solidFill>
-                  <a:srgbClr val="4B5565"/>
-                </a:solidFill>
-                <a:latin typeface="Calibri" pitchFamily="34" charset="0"/>
-                <a:ea typeface="Calibri" pitchFamily="34" charset="-122"/>
-                <a:cs typeface="Calibri" pitchFamily="34" charset="-120"/>
-              </a:rPr>
-              <a:t>Engineers in a slight deficit who want to get it back.</a:t>
-            </a:r>
-            <a:endParaRPr lang="en-GB" sz="1400" dirty="0"/>
-          </a:p>
-          <a:p>
-            <a:pPr marL="342900" indent="-342900">
-              <a:lnSpc>
-                <a:spcPts val="1800"/>
-              </a:lnSpc>
-              <a:spcAft>
-                <a:spcPts val="500"/>
-              </a:spcAft>
-              <a:buSzPct val="100000"/>
-              <a:buChar char="•"/>
-            </a:pPr>
-            <a:r>
-              <a:rPr lang="en-GB" sz="1400" dirty="0">
-                <a:solidFill>
-                  <a:srgbClr val="4B5565"/>
-                </a:solidFill>
-                <a:latin typeface="Calibri" pitchFamily="34" charset="0"/>
-                <a:ea typeface="Calibri" pitchFamily="34" charset="-122"/>
-                <a:cs typeface="Calibri" pitchFamily="34" charset="-120"/>
-              </a:rPr>
-              <a:t>New recruits who aren’t on CTAP yet, or are just starting.</a:t>
-            </a:r>
-            <a:endParaRPr lang="en-GB" sz="1400" dirty="0"/>
-          </a:p>
-          <a:p>
-            <a:pPr marL="342900" indent="-342900">
-              <a:lnSpc>
-                <a:spcPts val="1800"/>
-              </a:lnSpc>
-              <a:spcAft>
-                <a:spcPts val="500"/>
-              </a:spcAft>
-              <a:buSzPct val="100000"/>
-              <a:buChar char="•"/>
-            </a:pPr>
-            <a:r>
-              <a:rPr lang="en-GB" sz="1400" dirty="0">
-                <a:solidFill>
-                  <a:srgbClr val="4B5565"/>
-                </a:solidFill>
-                <a:latin typeface="Calibri" pitchFamily="34" charset="0"/>
-                <a:ea typeface="Calibri" pitchFamily="34" charset="-122"/>
-                <a:cs typeface="Calibri" pitchFamily="34" charset="-120"/>
-              </a:rPr>
-              <a:t>Anyone a manager thinks would get something out of seeing their figures day to day.</a:t>
-            </a:r>
-            <a:endParaRPr lang="en-GB" sz="1400" dirty="0"/>
-          </a:p>
-        </p:txBody>
-      </p:sp>
-      <p:sp>
-        <p:nvSpPr>
           <p:cNvPr id="18" name="Text 16"/>
           <p:cNvSpPr txBox="1"/>
           <p:nvPr/>
         </p:nvSpPr>
         <p:spPr>
           <a:xfrm>
-            <a:off x="566928" y="5961888"/>
+            <a:off x="566928" y="4526280"/>
             <a:ext cx="10881360" cy="274320"/>
           </a:xfrm>
           <a:prstGeom prst="rect">

</xml_diff>

<commit_message>
Drop the third-party-requests tile; the data slide already says it
Co-Authored-By: Claude Fable 5.1 <noreply@anthropic.com>
</commit_message>
<xml_diff>
--- a/docs/presentation/CTAP-Tracker.pptx
+++ b/docs/presentation/CTAP-Tracker.pptx
@@ -6921,7 +6921,7 @@
         <p:spPr>
           <a:xfrm>
             <a:off x="566928" y="2286000"/>
-            <a:ext cx="2578608" cy="1691640"/>
+            <a:ext cx="3447288" cy="1691640"/>
           </a:xfrm>
           <a:prstGeom prst="roundRect">
             <a:avLst>
@@ -6948,7 +6948,7 @@
         <p:spPr>
           <a:xfrm>
             <a:off x="804672" y="2542032"/>
-            <a:ext cx="2103120" cy="731520"/>
+            <a:ext cx="2971800" cy="731520"/>
           </a:xfrm>
           <a:prstGeom prst="rect">
             <a:avLst/>
@@ -6987,7 +6987,7 @@
         <p:spPr>
           <a:xfrm>
             <a:off x="804672" y="3346704"/>
-            <a:ext cx="2103120" cy="457200"/>
+            <a:ext cx="2971800" cy="457200"/>
           </a:xfrm>
           <a:prstGeom prst="rect">
             <a:avLst/>
@@ -7028,8 +7028,8 @@
         </p:nvSpPr>
         <p:spPr>
           <a:xfrm>
-            <a:off x="3364992" y="2286000"/>
-            <a:ext cx="2578608" cy="1691640"/>
+            <a:off x="4283964" y="2286000"/>
+            <a:ext cx="3447288" cy="1691640"/>
           </a:xfrm>
           <a:prstGeom prst="roundRect">
             <a:avLst>
@@ -7055,8 +7055,8 @@
         </p:nvSpPr>
         <p:spPr>
           <a:xfrm>
-            <a:off x="3602736" y="2542032"/>
-            <a:ext cx="2103120" cy="731520"/>
+            <a:off x="4521708" y="2542032"/>
+            <a:ext cx="2971800" cy="731520"/>
           </a:xfrm>
           <a:prstGeom prst="rect">
             <a:avLst/>
@@ -7094,8 +7094,8 @@
         </p:nvSpPr>
         <p:spPr>
           <a:xfrm>
-            <a:off x="3602736" y="3346704"/>
-            <a:ext cx="2103120" cy="457200"/>
+            <a:off x="4521708" y="3346704"/>
+            <a:ext cx="2971800" cy="457200"/>
           </a:xfrm>
           <a:prstGeom prst="rect">
             <a:avLst/>
@@ -7130,14 +7130,14 @@
       </p:sp>
       <p:sp>
         <p:nvSpPr>
-          <p:cNvPr id="10" name="Shape 8"/>
+          <p:cNvPr id="13" name="Shape 11"/>
           <p:cNvSpPr/>
           <p:nvPr/>
         </p:nvSpPr>
         <p:spPr>
           <a:xfrm>
-            <a:off x="6163056" y="2286000"/>
-            <a:ext cx="2578608" cy="1691640"/>
+            <a:off x="8001000" y="2286000"/>
+            <a:ext cx="3447288" cy="1691640"/>
           </a:xfrm>
           <a:prstGeom prst="roundRect">
             <a:avLst>
@@ -7157,14 +7157,14 @@
       </p:sp>
       <p:sp>
         <p:nvSpPr>
-          <p:cNvPr id="11" name="Text 9"/>
-          <p:cNvSpPr txBox="1"/>
-          <p:nvPr/>
-        </p:nvSpPr>
-        <p:spPr>
-          <a:xfrm>
-            <a:off x="6400800" y="2542032"/>
-            <a:ext cx="2103120" cy="731520"/>
+          <p:cNvPr id="14" name="Text 12"/>
+          <p:cNvSpPr txBox="1"/>
+          <p:nvPr/>
+        </p:nvSpPr>
+        <p:spPr>
+          <a:xfrm>
+            <a:off x="8238744" y="2542032"/>
+            <a:ext cx="2971800" cy="731520"/>
           </a:xfrm>
           <a:prstGeom prst="rect">
             <a:avLst/>
@@ -7188,7 +7188,7 @@
                 <a:ea typeface="Arial" pitchFamily="34" charset="-122"/>
                 <a:cs typeface="Arial" pitchFamily="34" charset="-120"/>
               </a:rPr>
-              <a:t>0</a:t>
+              <a:t>429</a:t>
             </a:r>
             <a:endParaRPr lang="en-US" sz="3800" dirty="0"/>
           </a:p>
@@ -7196,122 +7196,14 @@
       </p:sp>
       <p:sp>
         <p:nvSpPr>
-          <p:cNvPr id="12" name="Text 10"/>
-          <p:cNvSpPr txBox="1"/>
-          <p:nvPr/>
-        </p:nvSpPr>
-        <p:spPr>
-          <a:xfrm>
-            <a:off x="6400800" y="3346704"/>
-            <a:ext cx="2103120" cy="457200"/>
-          </a:xfrm>
-          <a:prstGeom prst="rect">
-            <a:avLst/>
-          </a:prstGeom>
-          <a:noFill/>
-          <a:ln/>
-        </p:spPr>
-        <p:txBody>
-          <a:bodyPr wrap="square" lIns="0" tIns="0" rIns="0" bIns="0" rtlCol="0" anchor="ctr"/>
-          <a:lstStyle/>
-          <a:p>
-            <a:pPr indent="0" marL="0">
-              <a:lnSpc>
-                <a:spcPts val="1300"/>
-              </a:lnSpc>
-              <a:buNone/>
-            </a:pPr>
-            <a:r>
-              <a:rPr lang="en-US" sz="900" spc="110" kern="0" dirty="0">
-                <a:solidFill>
-                  <a:srgbClr val="6B7485"/>
-                </a:solidFill>
-                <a:latin typeface="Arial" pitchFamily="34" charset="0"/>
-                <a:ea typeface="Arial" pitchFamily="34" charset="-122"/>
-                <a:cs typeface="Arial" pitchFamily="34" charset="-120"/>
-              </a:rPr>
-              <a:t>THIRD-PARTY REQUESTS</a:t>
-            </a:r>
-            <a:endParaRPr lang="en-US" sz="900" dirty="0"/>
-          </a:p>
-        </p:txBody>
-      </p:sp>
-      <p:sp>
-        <p:nvSpPr>
-          <p:cNvPr id="13" name="Shape 11"/>
-          <p:cNvSpPr/>
-          <p:nvPr/>
-        </p:nvSpPr>
-        <p:spPr>
-          <a:xfrm>
-            <a:off x="8961120" y="2286000"/>
-            <a:ext cx="2578608" cy="1691640"/>
-          </a:xfrm>
-          <a:prstGeom prst="roundRect">
-            <a:avLst>
-              <a:gd name="adj" fmla="val 6486"/>
-            </a:avLst>
-          </a:prstGeom>
-          <a:solidFill>
-            <a:srgbClr val="F2F2F7"/>
-          </a:solidFill>
-          <a:ln w="12700">
-            <a:solidFill>
-              <a:srgbClr val="DDE3EC"/>
-            </a:solidFill>
-            <a:prstDash val="solid"/>
-          </a:ln>
-        </p:spPr>
-      </p:sp>
-      <p:sp>
-        <p:nvSpPr>
-          <p:cNvPr id="14" name="Text 12"/>
-          <p:cNvSpPr txBox="1"/>
-          <p:nvPr/>
-        </p:nvSpPr>
-        <p:spPr>
-          <a:xfrm>
-            <a:off x="9198864" y="2542032"/>
-            <a:ext cx="2103120" cy="731520"/>
-          </a:xfrm>
-          <a:prstGeom prst="rect">
-            <a:avLst/>
-          </a:prstGeom>
-          <a:noFill/>
-          <a:ln/>
-        </p:spPr>
-        <p:txBody>
-          <a:bodyPr wrap="square" lIns="0" tIns="0" rIns="0" bIns="0" rtlCol="0" anchor="ctr"/>
-          <a:lstStyle/>
-          <a:p>
-            <a:pPr indent="0" marL="0">
-              <a:buNone/>
-            </a:pPr>
-            <a:r>
-              <a:rPr lang="en-US" sz="3800" b="1" dirty="0">
-                <a:solidFill>
-                  <a:srgbClr val="1F8A4C"/>
-                </a:solidFill>
-                <a:latin typeface="Arial" pitchFamily="34" charset="0"/>
-                <a:ea typeface="Arial" pitchFamily="34" charset="-122"/>
-                <a:cs typeface="Arial" pitchFamily="34" charset="-120"/>
-              </a:rPr>
-              <a:t>429</a:t>
-            </a:r>
-            <a:endParaRPr lang="en-US" sz="3800" dirty="0"/>
-          </a:p>
-        </p:txBody>
-      </p:sp>
-      <p:sp>
-        <p:nvSpPr>
           <p:cNvPr id="15" name="Text 13"/>
           <p:cNvSpPr txBox="1"/>
           <p:nvPr/>
         </p:nvSpPr>
         <p:spPr>
           <a:xfrm>
-            <a:off x="9198864" y="3346704"/>
-            <a:ext cx="2103120" cy="457200"/>
+            <a:off x="8238744" y="3346704"/>
+            <a:ext cx="2971800" cy="457200"/>
           </a:xfrm>
           <a:prstGeom prst="rect">
             <a:avLst/>

</xml_diff>

<commit_message>
Sign every slide in the footer, say calculation not arithmetic, and keep a PDF for forwarding
Co-Authored-By: Claude Fable 5.1 <noreply@anthropic.com>
</commit_message>
<xml_diff>
--- a/docs/presentation/CTAP-Tracker.pptx
+++ b/docs/presentation/CTAP-Tracker.pptx
@@ -1883,6 +1883,47 @@
           </a:prstGeom>
         </p:spPr>
       </p:pic>
+      <p:sp>
+        <p:nvSpPr>
+          <p:cNvPr id="900" name="Footer"/>
+          <p:cNvSpPr txBox="1"/>
+          <p:nvPr/>
+        </p:nvSpPr>
+        <p:spPr>
+          <a:xfrm>
+            <a:off x="566928" y="6537960"/>
+            <a:ext cx="10881360" cy="228600"/>
+          </a:xfrm>
+          <a:prstGeom prst="rect">
+            <a:avLst/>
+          </a:prstGeom>
+          <a:noFill/>
+          <a:ln>
+            <a:noFill/>
+          </a:ln>
+        </p:spPr>
+        <p:txBody>
+          <a:bodyPr wrap="square" lIns="0" tIns="0" rIns="0" bIns="0" rtlCol="0" anchor="ctr"/>
+          <a:lstStyle/>
+          <a:p>
+            <a:pPr indent="0" marL="0">
+              <a:buNone/>
+            </a:pPr>
+            <a:r>
+              <a:rPr lang="en-GB" sz="900" spc="40" kern="0" dirty="0">
+                <a:solidFill>
+                  <a:srgbClr val="6B7485"/>
+                </a:solidFill>
+                <a:latin typeface="Arial" pitchFamily="34" charset="0"/>
+                <a:ea typeface="Arial" pitchFamily="34" charset="-122"/>
+                <a:cs typeface="Arial" pitchFamily="34" charset="-120"/>
+              </a:rPr>
+              <a:t>Designed and created by Jake Rainford  ·  any questions, reach out on Teams</a:t>
+            </a:r>
+            <a:endParaRPr lang="en-GB" sz="900" dirty="0"/>
+          </a:p>
+        </p:txBody>
+      </p:sp>
     </p:spTree>
   </p:cSld>
   <p:clrMapOvr>
@@ -2406,6 +2447,47 @@
           </a:prstGeom>
         </p:spPr>
       </p:pic>
+      <p:sp>
+        <p:nvSpPr>
+          <p:cNvPr id="900" name="Footer"/>
+          <p:cNvSpPr txBox="1"/>
+          <p:nvPr/>
+        </p:nvSpPr>
+        <p:spPr>
+          <a:xfrm>
+            <a:off x="566928" y="6537960"/>
+            <a:ext cx="10881360" cy="228600"/>
+          </a:xfrm>
+          <a:prstGeom prst="rect">
+            <a:avLst/>
+          </a:prstGeom>
+          <a:noFill/>
+          <a:ln>
+            <a:noFill/>
+          </a:ln>
+        </p:spPr>
+        <p:txBody>
+          <a:bodyPr wrap="square" lIns="0" tIns="0" rIns="0" bIns="0" rtlCol="0" anchor="ctr"/>
+          <a:lstStyle/>
+          <a:p>
+            <a:pPr indent="0" marL="0">
+              <a:buNone/>
+            </a:pPr>
+            <a:r>
+              <a:rPr lang="en-GB" sz="900" spc="40" kern="0" dirty="0">
+                <a:solidFill>
+                  <a:srgbClr val="6B7485"/>
+                </a:solidFill>
+                <a:latin typeface="Arial" pitchFamily="34" charset="0"/>
+                <a:ea typeface="Arial" pitchFamily="34" charset="-122"/>
+                <a:cs typeface="Arial" pitchFamily="34" charset="-120"/>
+              </a:rPr>
+              <a:t>Designed and created by Jake Rainford  ·  any questions, reach out on Teams</a:t>
+            </a:r>
+            <a:endParaRPr lang="en-GB" sz="900" dirty="0"/>
+          </a:p>
+        </p:txBody>
+      </p:sp>
     </p:spTree>
   </p:cSld>
   <p:clrMapOvr>
@@ -3097,6 +3179,47 @@
           </a:p>
         </p:txBody>
       </p:sp>
+      <p:sp>
+        <p:nvSpPr>
+          <p:cNvPr id="900" name="Footer"/>
+          <p:cNvSpPr txBox="1"/>
+          <p:nvPr/>
+        </p:nvSpPr>
+        <p:spPr>
+          <a:xfrm>
+            <a:off x="566928" y="6537960"/>
+            <a:ext cx="10881360" cy="228600"/>
+          </a:xfrm>
+          <a:prstGeom prst="rect">
+            <a:avLst/>
+          </a:prstGeom>
+          <a:noFill/>
+          <a:ln>
+            <a:noFill/>
+          </a:ln>
+        </p:spPr>
+        <p:txBody>
+          <a:bodyPr wrap="square" lIns="0" tIns="0" rIns="0" bIns="0" rtlCol="0" anchor="ctr"/>
+          <a:lstStyle/>
+          <a:p>
+            <a:pPr indent="0" marL="0">
+              <a:buNone/>
+            </a:pPr>
+            <a:r>
+              <a:rPr lang="en-GB" sz="900" spc="40" kern="0" dirty="0">
+                <a:solidFill>
+                  <a:srgbClr val="6B7485"/>
+                </a:solidFill>
+                <a:latin typeface="Arial" pitchFamily="34" charset="0"/>
+                <a:ea typeface="Arial" pitchFamily="34" charset="-122"/>
+                <a:cs typeface="Arial" pitchFamily="34" charset="-120"/>
+              </a:rPr>
+              <a:t>Designed and created by Jake Rainford  ·  any questions, reach out on Teams</a:t>
+            </a:r>
+            <a:endParaRPr lang="en-GB" sz="900" dirty="0"/>
+          </a:p>
+        </p:txBody>
+      </p:sp>
     </p:spTree>
   </p:cSld>
   <p:clrMapOvr>
@@ -3605,6 +3728,47 @@
           </a:prstGeom>
         </p:spPr>
       </p:pic>
+      <p:sp>
+        <p:nvSpPr>
+          <p:cNvPr id="900" name="Footer"/>
+          <p:cNvSpPr txBox="1"/>
+          <p:nvPr/>
+        </p:nvSpPr>
+        <p:spPr>
+          <a:xfrm>
+            <a:off x="566928" y="6537960"/>
+            <a:ext cx="10881360" cy="228600"/>
+          </a:xfrm>
+          <a:prstGeom prst="rect">
+            <a:avLst/>
+          </a:prstGeom>
+          <a:noFill/>
+          <a:ln>
+            <a:noFill/>
+          </a:ln>
+        </p:spPr>
+        <p:txBody>
+          <a:bodyPr wrap="square" lIns="0" tIns="0" rIns="0" bIns="0" rtlCol="0" anchor="ctr"/>
+          <a:lstStyle/>
+          <a:p>
+            <a:pPr indent="0" marL="0">
+              <a:buNone/>
+            </a:pPr>
+            <a:r>
+              <a:rPr lang="en-GB" sz="900" spc="40" kern="0" dirty="0">
+                <a:solidFill>
+                  <a:srgbClr val="6B7485"/>
+                </a:solidFill>
+                <a:latin typeface="Arial" pitchFamily="34" charset="0"/>
+                <a:ea typeface="Arial" pitchFamily="34" charset="-122"/>
+                <a:cs typeface="Arial" pitchFamily="34" charset="-120"/>
+              </a:rPr>
+              <a:t>Designed and created by Jake Rainford  ·  any questions, reach out on Teams</a:t>
+            </a:r>
+            <a:endParaRPr lang="en-GB" sz="900" dirty="0"/>
+          </a:p>
+        </p:txBody>
+      </p:sp>
     </p:spTree>
   </p:cSld>
   <p:clrMapOvr>
@@ -4263,6 +4427,47 @@
           </a:prstGeom>
         </p:spPr>
       </p:pic>
+      <p:sp>
+        <p:nvSpPr>
+          <p:cNvPr id="900" name="Footer"/>
+          <p:cNvSpPr txBox="1"/>
+          <p:nvPr/>
+        </p:nvSpPr>
+        <p:spPr>
+          <a:xfrm>
+            <a:off x="566928" y="6537960"/>
+            <a:ext cx="10881360" cy="228600"/>
+          </a:xfrm>
+          <a:prstGeom prst="rect">
+            <a:avLst/>
+          </a:prstGeom>
+          <a:noFill/>
+          <a:ln>
+            <a:noFill/>
+          </a:ln>
+        </p:spPr>
+        <p:txBody>
+          <a:bodyPr wrap="square" lIns="0" tIns="0" rIns="0" bIns="0" rtlCol="0" anchor="ctr"/>
+          <a:lstStyle/>
+          <a:p>
+            <a:pPr indent="0" marL="0">
+              <a:buNone/>
+            </a:pPr>
+            <a:r>
+              <a:rPr lang="en-GB" sz="900" spc="40" kern="0" dirty="0">
+                <a:solidFill>
+                  <a:srgbClr val="6B7485"/>
+                </a:solidFill>
+                <a:latin typeface="Arial" pitchFamily="34" charset="0"/>
+                <a:ea typeface="Arial" pitchFamily="34" charset="-122"/>
+                <a:cs typeface="Arial" pitchFamily="34" charset="-120"/>
+              </a:rPr>
+              <a:t>Designed and created by Jake Rainford  ·  any questions, reach out on Teams</a:t>
+            </a:r>
+            <a:endParaRPr lang="en-GB" sz="900" dirty="0"/>
+          </a:p>
+        </p:txBody>
+      </p:sp>
     </p:spTree>
   </p:cSld>
   <p:clrMapOvr>
@@ -4857,7 +5062,7 @@
                 <a:ea typeface="Calibri" pitchFamily="34" charset="-122"/>
                 <a:cs typeface="Calibri" pitchFamily="34" charset="-120"/>
               </a:rPr>
-              <a:t>The arithmetic is printed under the figure in the app, so it can be checked rather than trusted.</a:t>
+              <a:t>The calculation is shown under the figure in the app, so you can check it rather than take it on trust.</a:t>
             </a:r>
             <a:endParaRPr lang="en-US" sz="1300" dirty="0"/>
           </a:p>
@@ -4914,6 +5119,47 @@
           </a:prstGeom>
         </p:spPr>
       </p:pic>
+      <p:sp>
+        <p:nvSpPr>
+          <p:cNvPr id="900" name="Footer"/>
+          <p:cNvSpPr txBox="1"/>
+          <p:nvPr/>
+        </p:nvSpPr>
+        <p:spPr>
+          <a:xfrm>
+            <a:off x="566928" y="6537960"/>
+            <a:ext cx="10881360" cy="228600"/>
+          </a:xfrm>
+          <a:prstGeom prst="rect">
+            <a:avLst/>
+          </a:prstGeom>
+          <a:noFill/>
+          <a:ln>
+            <a:noFill/>
+          </a:ln>
+        </p:spPr>
+        <p:txBody>
+          <a:bodyPr wrap="square" lIns="0" tIns="0" rIns="0" bIns="0" rtlCol="0" anchor="ctr"/>
+          <a:lstStyle/>
+          <a:p>
+            <a:pPr indent="0" marL="0">
+              <a:buNone/>
+            </a:pPr>
+            <a:r>
+              <a:rPr lang="en-GB" sz="900" spc="40" kern="0" dirty="0">
+                <a:solidFill>
+                  <a:srgbClr val="6B7485"/>
+                </a:solidFill>
+                <a:latin typeface="Arial" pitchFamily="34" charset="0"/>
+                <a:ea typeface="Arial" pitchFamily="34" charset="-122"/>
+                <a:cs typeface="Arial" pitchFamily="34" charset="-120"/>
+              </a:rPr>
+              <a:t>Designed and created by Jake Rainford  ·  any questions, reach out on Teams</a:t>
+            </a:r>
+            <a:endParaRPr lang="en-GB" sz="900" dirty="0"/>
+          </a:p>
+        </p:txBody>
+      </p:sp>
     </p:spTree>
   </p:cSld>
   <p:clrMapOvr>
@@ -5385,6 +5631,47 @@
           </a:prstGeom>
         </p:spPr>
       </p:pic>
+      <p:sp>
+        <p:nvSpPr>
+          <p:cNvPr id="900" name="Footer"/>
+          <p:cNvSpPr txBox="1"/>
+          <p:nvPr/>
+        </p:nvSpPr>
+        <p:spPr>
+          <a:xfrm>
+            <a:off x="566928" y="6537960"/>
+            <a:ext cx="10881360" cy="228600"/>
+          </a:xfrm>
+          <a:prstGeom prst="rect">
+            <a:avLst/>
+          </a:prstGeom>
+          <a:noFill/>
+          <a:ln>
+            <a:noFill/>
+          </a:ln>
+        </p:spPr>
+        <p:txBody>
+          <a:bodyPr wrap="square" lIns="0" tIns="0" rIns="0" bIns="0" rtlCol="0" anchor="ctr"/>
+          <a:lstStyle/>
+          <a:p>
+            <a:pPr indent="0" marL="0">
+              <a:buNone/>
+            </a:pPr>
+            <a:r>
+              <a:rPr lang="en-GB" sz="900" spc="40" kern="0" dirty="0">
+                <a:solidFill>
+                  <a:srgbClr val="6B7485"/>
+                </a:solidFill>
+                <a:latin typeface="Arial" pitchFamily="34" charset="0"/>
+                <a:ea typeface="Arial" pitchFamily="34" charset="-122"/>
+                <a:cs typeface="Arial" pitchFamily="34" charset="-120"/>
+              </a:rPr>
+              <a:t>Designed and created by Jake Rainford  ·  any questions, reach out on Teams</a:t>
+            </a:r>
+            <a:endParaRPr lang="en-GB" sz="900" dirty="0"/>
+          </a:p>
+        </p:txBody>
+      </p:sp>
     </p:spTree>
   </p:cSld>
   <p:clrMapOvr>
@@ -5946,6 +6233,47 @@
           </a:p>
         </p:txBody>
       </p:sp>
+      <p:sp>
+        <p:nvSpPr>
+          <p:cNvPr id="900" name="Footer"/>
+          <p:cNvSpPr txBox="1"/>
+          <p:nvPr/>
+        </p:nvSpPr>
+        <p:spPr>
+          <a:xfrm>
+            <a:off x="566928" y="6537960"/>
+            <a:ext cx="10881360" cy="228600"/>
+          </a:xfrm>
+          <a:prstGeom prst="rect">
+            <a:avLst/>
+          </a:prstGeom>
+          <a:noFill/>
+          <a:ln>
+            <a:noFill/>
+          </a:ln>
+        </p:spPr>
+        <p:txBody>
+          <a:bodyPr wrap="square" lIns="0" tIns="0" rIns="0" bIns="0" rtlCol="0" anchor="ctr"/>
+          <a:lstStyle/>
+          <a:p>
+            <a:pPr indent="0" marL="0">
+              <a:buNone/>
+            </a:pPr>
+            <a:r>
+              <a:rPr lang="en-GB" sz="900" spc="40" kern="0" dirty="0">
+                <a:solidFill>
+                  <a:srgbClr val="6B7485"/>
+                </a:solidFill>
+                <a:latin typeface="Arial" pitchFamily="34" charset="0"/>
+                <a:ea typeface="Arial" pitchFamily="34" charset="-122"/>
+                <a:cs typeface="Arial" pitchFamily="34" charset="-120"/>
+              </a:rPr>
+              <a:t>Designed and created by Jake Rainford  ·  any questions, reach out on Teams</a:t>
+            </a:r>
+            <a:endParaRPr lang="en-GB" sz="900" dirty="0"/>
+          </a:p>
+        </p:txBody>
+      </p:sp>
     </p:spTree>
   </p:cSld>
   <p:clrMapOvr>
@@ -6612,7 +6940,7 @@
               <a:buNone/>
             </a:pPr>
             <a:r>
-              <a:rPr lang="en-GB" sz="1300" dirty="0">
+              <a:rPr lang="en-US" sz="1300" dirty="0">
                 <a:solidFill>
                   <a:srgbClr val="4B5565"/>
                 </a:solidFill>
@@ -6620,9 +6948,9 @@
                 <a:ea typeface="Calibri" pitchFamily="34" charset="-122"/>
                 <a:cs typeface="Calibri" pitchFamily="34" charset="-120"/>
               </a:rPr>
-              <a:t>Settings → Erase all data, and it’s gone straight away.</a:t>
-            </a:r>
-            <a:endParaRPr lang="en-GB" sz="1300" dirty="0"/>
+              <a:t>Settings → Erase all data. Immediate and total.</a:t>
+            </a:r>
+            <a:endParaRPr lang="en-US" sz="1300" dirty="0"/>
           </a:p>
         </p:txBody>
       </p:sp>
@@ -6796,6 +7124,47 @@
               <a:t>Engineers are told this before they start.</a:t>
             </a:r>
             <a:endParaRPr lang="en-GB" sz="1300" dirty="0"/>
+          </a:p>
+        </p:txBody>
+      </p:sp>
+      <p:sp>
+        <p:nvSpPr>
+          <p:cNvPr id="900" name="Footer"/>
+          <p:cNvSpPr txBox="1"/>
+          <p:nvPr/>
+        </p:nvSpPr>
+        <p:spPr>
+          <a:xfrm>
+            <a:off x="566928" y="6537960"/>
+            <a:ext cx="10881360" cy="228600"/>
+          </a:xfrm>
+          <a:prstGeom prst="rect">
+            <a:avLst/>
+          </a:prstGeom>
+          <a:noFill/>
+          <a:ln>
+            <a:noFill/>
+          </a:ln>
+        </p:spPr>
+        <p:txBody>
+          <a:bodyPr wrap="square" lIns="0" tIns="0" rIns="0" bIns="0" rtlCol="0" anchor="ctr"/>
+          <a:lstStyle/>
+          <a:p>
+            <a:pPr indent="0" marL="0">
+              <a:buNone/>
+            </a:pPr>
+            <a:r>
+              <a:rPr lang="en-GB" sz="900" spc="40" kern="0" dirty="0">
+                <a:solidFill>
+                  <a:srgbClr val="6B7485"/>
+                </a:solidFill>
+                <a:latin typeface="Arial" pitchFamily="34" charset="0"/>
+                <a:ea typeface="Arial" pitchFamily="34" charset="-122"/>
+                <a:cs typeface="Arial" pitchFamily="34" charset="-120"/>
+              </a:rPr>
+              <a:t>Designed and created by Jake Rainford  ·  any questions, reach out on Teams</a:t>
+            </a:r>
+            <a:endParaRPr lang="en-GB" sz="900" dirty="0"/>
           </a:p>
         </p:txBody>
       </p:sp>
@@ -7238,30 +7607,33 @@
       </p:sp>
       <p:sp>
         <p:nvSpPr>
-          <p:cNvPr id="18" name="Text 16"/>
+          <p:cNvPr id="19" name="Text 17"/>
           <p:cNvSpPr txBox="1"/>
           <p:nvPr/>
         </p:nvSpPr>
         <p:spPr>
           <a:xfrm>
             <a:off x="566928" y="4526280"/>
-            <a:ext cx="10881360" cy="274320"/>
-          </a:xfrm>
-          <a:prstGeom prst="rect">
-            <a:avLst/>
-          </a:prstGeom>
-          <a:noFill/>
-          <a:ln/>
-        </p:spPr>
-        <p:txBody>
-          <a:bodyPr wrap="square" lIns="0" tIns="0" rIns="0" bIns="0" rtlCol="0" anchor="ctr"/>
-          <a:lstStyle/>
-          <a:p>
-            <a:pPr indent="0" marL="0">
-              <a:buNone/>
-            </a:pPr>
-            <a:r>
-              <a:rPr lang="en-GB" sz="1300" dirty="0">
+            <a:ext cx="10881360" cy="457200"/>
+          </a:xfrm>
+          <a:prstGeom prst="rect">
+            <a:avLst/>
+          </a:prstGeom>
+          <a:noFill/>
+          <a:ln/>
+        </p:spPr>
+        <p:txBody>
+          <a:bodyPr wrap="square" lIns="0" tIns="0" rIns="0" bIns="0" rtlCol="0" anchor="ctr"/>
+          <a:lstStyle/>
+          <a:p>
+            <a:pPr indent="0" marL="0">
+              <a:lnSpc>
+                <a:spcPts val="1400"/>
+              </a:lnSpc>
+              <a:buNone/>
+            </a:pPr>
+            <a:r>
+              <a:rPr lang="en-US" sz="1050" dirty="0">
                 <a:solidFill>
                   <a:srgbClr val="6B7485"/>
                 </a:solidFill>
@@ -7269,51 +7641,50 @@
                 <a:ea typeface="Calibri" pitchFamily="34" charset="-122"/>
                 <a:cs typeface="Calibri" pitchFamily="34" charset="-120"/>
               </a:rPr>
-              <a:t>Jake Rainford  ·  Service &amp; Repair Engineer  ·  any questions, get me on email or Teams</a:t>
-            </a:r>
-            <a:endParaRPr lang="en-GB" sz="1300" dirty="0"/>
-          </a:p>
-        </p:txBody>
-      </p:sp>
-      <p:sp>
-        <p:nvSpPr>
-          <p:cNvPr id="19" name="Text 17"/>
-          <p:cNvSpPr txBox="1"/>
-          <p:nvPr/>
-        </p:nvSpPr>
-        <p:spPr>
-          <a:xfrm>
-            <a:off x="566928" y="6291072"/>
-            <a:ext cx="10881360" cy="457200"/>
-          </a:xfrm>
-          <a:prstGeom prst="rect">
-            <a:avLst/>
-          </a:prstGeom>
-          <a:noFill/>
-          <a:ln/>
-        </p:spPr>
-        <p:txBody>
-          <a:bodyPr wrap="square" lIns="0" tIns="0" rIns="0" bIns="0" rtlCol="0" anchor="ctr"/>
-          <a:lstStyle/>
-          <a:p>
-            <a:pPr indent="0" marL="0">
-              <a:lnSpc>
-                <a:spcPts val="1400"/>
-              </a:lnSpc>
-              <a:buNone/>
-            </a:pPr>
-            <a:r>
-              <a:rPr lang="en-US" sz="1050" dirty="0">
+              <a:t>Personal estimates only — verify against your payslip and company tools. Not affiliated with, endorsed by, or representative of Centrica plc, British Gas or any employer.</a:t>
+            </a:r>
+            <a:endParaRPr lang="en-US" sz="1050" dirty="0"/>
+          </a:p>
+        </p:txBody>
+      </p:sp>
+      <p:sp>
+        <p:nvSpPr>
+          <p:cNvPr id="900" name="Footer"/>
+          <p:cNvSpPr txBox="1"/>
+          <p:nvPr/>
+        </p:nvSpPr>
+        <p:spPr>
+          <a:xfrm>
+            <a:off x="566928" y="6537960"/>
+            <a:ext cx="10881360" cy="228600"/>
+          </a:xfrm>
+          <a:prstGeom prst="rect">
+            <a:avLst/>
+          </a:prstGeom>
+          <a:noFill/>
+          <a:ln>
+            <a:noFill/>
+          </a:ln>
+        </p:spPr>
+        <p:txBody>
+          <a:bodyPr wrap="square" lIns="0" tIns="0" rIns="0" bIns="0" rtlCol="0" anchor="ctr"/>
+          <a:lstStyle/>
+          <a:p>
+            <a:pPr indent="0" marL="0">
+              <a:buNone/>
+            </a:pPr>
+            <a:r>
+              <a:rPr lang="en-GB" sz="900" spc="40" kern="0" dirty="0">
                 <a:solidFill>
                   <a:srgbClr val="6B7485"/>
                 </a:solidFill>
-                <a:latin typeface="Calibri" pitchFamily="34" charset="0"/>
-                <a:ea typeface="Calibri" pitchFamily="34" charset="-122"/>
-                <a:cs typeface="Calibri" pitchFamily="34" charset="-120"/>
-              </a:rPr>
-              <a:t>Personal estimates only — verify against your payslip and company tools. Not affiliated with, endorsed by, or representative of Centrica plc, British Gas or any employer.</a:t>
-            </a:r>
-            <a:endParaRPr lang="en-US" sz="1050" dirty="0"/>
+                <a:latin typeface="Arial" pitchFamily="34" charset="0"/>
+                <a:ea typeface="Arial" pitchFamily="34" charset="-122"/>
+                <a:cs typeface="Arial" pitchFamily="34" charset="-120"/>
+              </a:rPr>
+              <a:t>Designed and created by Jake Rainford  ·  any questions, reach out on Teams</a:t>
+            </a:r>
+            <a:endParaRPr lang="en-GB" sz="900" dirty="0"/>
           </a:p>
         </p:txBody>
       </p:sp>

</xml_diff>

<commit_message>
Refresh the deck and the email image for launch day
Every screen in the deck predated the last week of changes: the Actual
toggle, a 32.5h target, the pre-redesign Log Job and a Cash-Out with no
Hours to price. All seven screens are replaced in place from the Thursday
10:05 guide set, so the deck and the guides show the same figures.

Slide 7 loses the daily check-in, which is paused: it is now Coach alone,
with the Best advice strip where the check-in card was, and its notes say
so. Slide 5 no longer claims the target switches to your own rolling
average after four weeks (ADR-0022 removed that). Test count 429 → 518.

The email overview image (Dashboard, Log Job, History, one line each,
low-key contact footer) is rebuilt from the same screens and kept here,
since its only copy had lived in a session scratchpad.

Co-Authored-By: Claude Opus 5 <noreply@anthropic.com>
</commit_message>
<xml_diff>
--- a/docs/presentation/CTAP-Tracker.pptx
+++ b/docs/presentation/CTAP-Tracker.pptx
@@ -1127,7 +1127,7 @@
           <a:p>
             <a:r>
               <a:rPr lang="en-US" dirty="0"/>
-              <a:t>Both optional, both off in one tap in Settings. Coach is the bit I would show a new engineer first: it turns the figures into a run rate and tells you what the extras on a visit are worth. The check-in is a private diary built on GROW. There is no management view of it, and that is a property of the build rather than a promise.</a:t>
+              <a:t>Optional, and off in one tap in Settings. Coach is the bit I would show a new engineer first: it turns the figures into a run rate and tells you what the extras on a visit are worth. It only ever suggests advice on a visit you were already given, never extra work.</a:t>
             </a:r>
             <a:endParaRPr lang="en-US" dirty="0"/>
           </a:p>
@@ -4795,7 +4795,7 @@
                 <a:ea typeface="Calibri" pitchFamily="34" charset="-122"/>
                 <a:cs typeface="Calibri" pitchFamily="34" charset="-120"/>
               </a:rPr>
-              <a:t>The 80% is a buffer for travel and performance factor. After four logged weeks it uses your own rolling average instead.</a:t>
+              <a:t>The 80% is a buffer for travel and performance factor. It’s the employer’s bar, so it never drifts towards your own average.</a:t>
             </a:r>
             <a:endParaRPr lang="en-US" sz="1200" dirty="0"/>
           </a:p>
@@ -5737,7 +5737,7 @@
                 <a:ea typeface="Arial" pitchFamily="34" charset="-122"/>
                 <a:cs typeface="Arial" pitchFamily="34" charset="-120"/>
               </a:rPr>
-              <a:t>COACH MODE AND THE DAILY CHECK-IN  ·  BOTH OPTIONAL</a:t>
+              <a:t>COACH MODE  ·  OPTIONAL</a:t>
             </a:r>
             <a:endParaRPr lang="en-GB" sz="1100" dirty="0"/>
           </a:p>
@@ -5799,7 +5799,7 @@
                 <a:ea typeface="Arial" pitchFamily="34" charset="-122"/>
                 <a:cs typeface="Arial" pitchFamily="34" charset="-120"/>
               </a:rPr>
-              <a:t>The check-in is your own diary.</a:t>
+              <a:t>And shows what lifts the balance most.</a:t>
             </a:r>
             <a:endParaRPr lang="en-GB" sz="3200" dirty="0"/>
           </a:p>
@@ -5888,7 +5888,7 @@
         <p:spPr>
           <a:xfrm>
             <a:off x="877824" y="3108960"/>
-            <a:ext cx="3931920" cy="1554480"/>
+            <a:ext cx="3478149" cy="1554480"/>
           </a:xfrm>
           <a:prstGeom prst="rect">
             <a:avLst/>
@@ -6079,7 +6079,7 @@
                 <a:ea typeface="Arial" pitchFamily="34" charset="-122"/>
                 <a:cs typeface="Arial" pitchFamily="34" charset="-120"/>
               </a:rPr>
-              <a:t>The daily check-in</a:t>
+              <a:t>Best advice</a:t>
             </a:r>
             <a:endParaRPr lang="en-GB" sz="2100" dirty="0"/>
           </a:p>
@@ -6087,7 +6087,7 @@
       </p:sp>
       <p:pic>
         <p:nvPicPr>
-          <p:cNvPr id="10" name="Image 1" descr="shots/checkin-card.png">    </p:cNvPr>
+          <p:cNvPr id="10" name="Image 1" descr="shots/coach-best-advice.png">    </p:cNvPr>
           <p:cNvPicPr>
             <a:picLocks noChangeAspect="1"/>
           </p:cNvPicPr>
@@ -6101,138 +6101,14 @@
         </p:blipFill>
         <p:spPr>
           <a:xfrm>
-            <a:off x="6684264" y="3127248"/>
-            <a:ext cx="4818888" cy="928780"/>
+            <a:off x="6684264" y="3108960"/>
+            <a:ext cx="3388231" cy="2971800"/>
           </a:xfrm>
           <a:prstGeom prst="rect">
             <a:avLst/>
           </a:prstGeom>
         </p:spPr>
       </p:pic>
-      <p:sp>
-        <p:nvSpPr>
-          <p:cNvPr id="11" name="Text 7"/>
-          <p:cNvSpPr txBox="1"/>
-          <p:nvPr/>
-        </p:nvSpPr>
-        <p:spPr>
-          <a:xfrm>
-            <a:off x="6684264" y="4224528"/>
-            <a:ext cx="4818888" cy="1874519"/>
-          </a:xfrm>
-          <a:prstGeom prst="rect">
-            <a:avLst/>
-          </a:prstGeom>
-          <a:noFill/>
-          <a:ln/>
-        </p:spPr>
-        <p:txBody>
-          <a:bodyPr wrap="square" lIns="0" tIns="0" rIns="0" bIns="0" rtlCol="0" anchor="t"/>
-          <a:lstStyle/>
-          <a:p>
-            <a:pPr indent="0" marL="0">
-              <a:lnSpc>
-                <a:spcPts val="1500"/>
-              </a:lnSpc>
-              <a:spcAft>
-                <a:spcPts val="600"/>
-              </a:spcAft>
-              <a:buNone/>
-            </a:pPr>
-            <a:r>
-              <a:rPr lang="en-GB" sz="1200" b="1" dirty="0">
-                <a:solidFill>
-                  <a:srgbClr val="0F1522"/>
-                </a:solidFill>
-                <a:latin typeface="Calibri" pitchFamily="34" charset="0"/>
-                <a:ea typeface="Calibri" pitchFamily="34" charset="-122"/>
-                <a:cs typeface="Calibri" pitchFamily="34" charset="-120"/>
-              </a:rPr>
-              <a:t>Built on GROW.</a:t>
-            </a:r>
-            <a:r>
-              <a:rPr lang="en-GB" sz="1200" dirty="0">
-                <a:solidFill>
-                  <a:srgbClr val="0F1522"/>
-                </a:solidFill>
-                <a:latin typeface="Calibri" pitchFamily="34" charset="0"/>
-                <a:ea typeface="Calibri" pitchFamily="34" charset="-122"/>
-                <a:cs typeface="Calibri" pitchFamily="34" charset="-120"/>
-              </a:rPr>
-              <a:t> Goal, Reality, Options, Will. One question a day, and it takes under a minute.</a:t>
-            </a:r>
-            <a:endParaRPr lang="en-GB" sz="1200" dirty="0"/>
-          </a:p>
-          <a:p>
-            <a:pPr indent="0" marL="0">
-              <a:lnSpc>
-                <a:spcPts val="1500"/>
-              </a:lnSpc>
-              <a:spcAft>
-                <a:spcPts val="600"/>
-              </a:spcAft>
-              <a:buNone/>
-            </a:pPr>
-            <a:r>
-              <a:rPr lang="en-GB" sz="1200" b="1" dirty="0">
-                <a:solidFill>
-                  <a:srgbClr val="0F1522"/>
-                </a:solidFill>
-                <a:latin typeface="Calibri" pitchFamily="34" charset="0"/>
-                <a:ea typeface="Calibri" pitchFamily="34" charset="-122"/>
-                <a:cs typeface="Calibri" pitchFamily="34" charset="-120"/>
-              </a:rPr>
-              <a:t>An honest diary.</a:t>
-            </a:r>
-            <a:r>
-              <a:rPr lang="en-GB" sz="1200" dirty="0">
-                <a:solidFill>
-                  <a:srgbClr val="0F1522"/>
-                </a:solidFill>
-                <a:latin typeface="Calibri" pitchFamily="34" charset="0"/>
-                <a:ea typeface="Calibri" pitchFamily="34" charset="-122"/>
-                <a:cs typeface="Calibri" pitchFamily="34" charset="-120"/>
-              </a:rPr>
-              <a:t> Where the gaps in the day were, what you’re struggling with, what you’d do differently. It’s there for the engineers who genuinely want to use it.</a:t>
-            </a:r>
-            <a:endParaRPr lang="en-GB" sz="1200" dirty="0"/>
-          </a:p>
-          <a:p>
-            <a:pPr indent="0" marL="0">
-              <a:lnSpc>
-                <a:spcPts val="1500"/>
-              </a:lnSpc>
-              <a:spcAft>
-                <a:spcPts val="600"/>
-              </a:spcAft>
-              <a:buNone/>
-            </a:pPr>
-            <a:r>
-              <a:rPr lang="en-GB" sz="1200" b="1" dirty="0">
-                <a:solidFill>
-                  <a:srgbClr val="0F1522"/>
-                </a:solidFill>
-                <a:latin typeface="Calibri" pitchFamily="34" charset="0"/>
-                <a:ea typeface="Calibri" pitchFamily="34" charset="-122"/>
-                <a:cs typeface="Calibri" pitchFamily="34" charset="-120"/>
-              </a:rPr>
-              <a:t>Only you can read it.</a:t>
-            </a:r>
-            <a:r>
-              <a:rPr lang="en-GB" sz="1200" dirty="0">
-                <a:solidFill>
-                  <a:srgbClr val="0F1522"/>
-                </a:solidFill>
-                <a:latin typeface="Calibri" pitchFamily="34" charset="0"/>
-                <a:ea typeface="Calibri" pitchFamily="34" charset="-122"/>
-                <a:cs typeface="Calibri" pitchFamily="34" charset="-120"/>
-              </a:rPr>
-              <a:t> No team view, no export, no comparing engineers. That’s how it’s built, not a setting.</a:t>
-            </a:r>
-            <a:endParaRPr lang="en-GB" sz="1200" dirty="0"/>
-          </a:p>
-        </p:txBody>
-      </p:sp>
       <p:sp>
         <p:nvSpPr>
           <p:cNvPr id="900" name="Footer"/>
@@ -7557,7 +7433,7 @@
                 <a:ea typeface="Arial" pitchFamily="34" charset="-122"/>
                 <a:cs typeface="Arial" pitchFamily="34" charset="-120"/>
               </a:rPr>
-              <a:t>429</a:t>
+              <a:t>518</a:t>
             </a:r>
             <a:endParaRPr lang="en-US" sz="3800" dirty="0"/>
           </a:p>

</xml_diff>

<commit_message>
Drop the engineers-wanted tile from the deck, which now goes to the engineers
Co-Authored-By: Claude Opus 5 <noreply@anthropic.com>
</commit_message>
<xml_diff>
--- a/docs/presentation/CTAP-Tracker.pptx
+++ b/docs/presentation/CTAP-Tracker.pptx
@@ -1303,7 +1303,7 @@
           <a:p>
             <a:r>
               <a:rPr lang="en-US" dirty="0"/>
-              <a:t>What is shipped, and the ask: a handful of engineers, five to ten, who a manager thinks would get something out of it. Engineers a little behind on CTAP and new starters get the most from seeing the figures day to day. Nobody can install it without the link, so it goes out to whoever comes forward.</a:t>
+              <a:t>What is shipped. The version is in Settings under About if I ask which build you are on, and every change runs the full set of tests before it reaches your phone.</a:t>
             </a:r>
             <a:endParaRPr lang="en-US" dirty="0"/>
           </a:p>
@@ -7267,7 +7267,7 @@
       </p:sp>
       <p:sp>
         <p:nvSpPr>
-          <p:cNvPr id="7" name="Shape 5"/>
+          <p:cNvPr id="13" name="Shape 11"/>
           <p:cNvSpPr/>
           <p:nvPr/>
         </p:nvSpPr>
@@ -7294,7 +7294,7 @@
       </p:sp>
       <p:sp>
         <p:nvSpPr>
-          <p:cNvPr id="8" name="Text 6"/>
+          <p:cNvPr id="14" name="Text 12"/>
           <p:cNvSpPr txBox="1"/>
           <p:nvPr/>
         </p:nvSpPr>
@@ -7319,13 +7319,13 @@
             <a:r>
               <a:rPr lang="en-US" sz="3800" b="1" dirty="0">
                 <a:solidFill>
-                  <a:srgbClr val="0F1522"/>
-                </a:solidFill>
-                <a:latin typeface="Arial" pitchFamily="34" charset="0"/>
-                <a:ea typeface="Arial" pitchFamily="34" charset="-122"/>
-                <a:cs typeface="Arial" pitchFamily="34" charset="-120"/>
-              </a:rPr>
-              <a:t>5–10</a:t>
+                  <a:srgbClr val="1F8A4C"/>
+                </a:solidFill>
+                <a:latin typeface="Arial" pitchFamily="34" charset="0"/>
+                <a:ea typeface="Arial" pitchFamily="34" charset="-122"/>
+                <a:cs typeface="Arial" pitchFamily="34" charset="-120"/>
+              </a:rPr>
+              <a:t>518</a:t>
             </a:r>
             <a:endParaRPr lang="en-US" sz="3800" dirty="0"/>
           </a:p>
@@ -7333,121 +7333,13 @@
       </p:sp>
       <p:sp>
         <p:nvSpPr>
-          <p:cNvPr id="9" name="Text 7"/>
+          <p:cNvPr id="15" name="Text 13"/>
           <p:cNvSpPr txBox="1"/>
           <p:nvPr/>
         </p:nvSpPr>
         <p:spPr>
           <a:xfrm>
             <a:off x="4521708" y="3346704"/>
-            <a:ext cx="2971800" cy="457200"/>
-          </a:xfrm>
-          <a:prstGeom prst="rect">
-            <a:avLst/>
-          </a:prstGeom>
-          <a:noFill/>
-          <a:ln/>
-        </p:spPr>
-        <p:txBody>
-          <a:bodyPr wrap="square" lIns="0" tIns="0" rIns="0" bIns="0" rtlCol="0" anchor="ctr"/>
-          <a:lstStyle/>
-          <a:p>
-            <a:pPr indent="0" marL="0">
-              <a:lnSpc>
-                <a:spcPts val="1300"/>
-              </a:lnSpc>
-              <a:buNone/>
-            </a:pPr>
-            <a:r>
-              <a:rPr lang="en-US" sz="900" spc="110" kern="0" dirty="0">
-                <a:solidFill>
-                  <a:srgbClr val="6B7485"/>
-                </a:solidFill>
-                <a:latin typeface="Arial" pitchFamily="34" charset="0"/>
-                <a:ea typeface="Arial" pitchFamily="34" charset="-122"/>
-                <a:cs typeface="Arial" pitchFamily="34" charset="-120"/>
-              </a:rPr>
-              <a:t>ENGINEERS WANTED</a:t>
-            </a:r>
-            <a:endParaRPr lang="en-US" sz="900" dirty="0"/>
-          </a:p>
-        </p:txBody>
-      </p:sp>
-      <p:sp>
-        <p:nvSpPr>
-          <p:cNvPr id="13" name="Shape 11"/>
-          <p:cNvSpPr/>
-          <p:nvPr/>
-        </p:nvSpPr>
-        <p:spPr>
-          <a:xfrm>
-            <a:off x="8001000" y="2286000"/>
-            <a:ext cx="3447288" cy="1691640"/>
-          </a:xfrm>
-          <a:prstGeom prst="roundRect">
-            <a:avLst>
-              <a:gd name="adj" fmla="val 6486"/>
-            </a:avLst>
-          </a:prstGeom>
-          <a:solidFill>
-            <a:srgbClr val="F2F2F7"/>
-          </a:solidFill>
-          <a:ln w="12700">
-            <a:solidFill>
-              <a:srgbClr val="DDE3EC"/>
-            </a:solidFill>
-            <a:prstDash val="solid"/>
-          </a:ln>
-        </p:spPr>
-      </p:sp>
-      <p:sp>
-        <p:nvSpPr>
-          <p:cNvPr id="14" name="Text 12"/>
-          <p:cNvSpPr txBox="1"/>
-          <p:nvPr/>
-        </p:nvSpPr>
-        <p:spPr>
-          <a:xfrm>
-            <a:off x="8238744" y="2542032"/>
-            <a:ext cx="2971800" cy="731520"/>
-          </a:xfrm>
-          <a:prstGeom prst="rect">
-            <a:avLst/>
-          </a:prstGeom>
-          <a:noFill/>
-          <a:ln/>
-        </p:spPr>
-        <p:txBody>
-          <a:bodyPr wrap="square" lIns="0" tIns="0" rIns="0" bIns="0" rtlCol="0" anchor="ctr"/>
-          <a:lstStyle/>
-          <a:p>
-            <a:pPr indent="0" marL="0">
-              <a:buNone/>
-            </a:pPr>
-            <a:r>
-              <a:rPr lang="en-US" sz="3800" b="1" dirty="0">
-                <a:solidFill>
-                  <a:srgbClr val="1F8A4C"/>
-                </a:solidFill>
-                <a:latin typeface="Arial" pitchFamily="34" charset="0"/>
-                <a:ea typeface="Arial" pitchFamily="34" charset="-122"/>
-                <a:cs typeface="Arial" pitchFamily="34" charset="-120"/>
-              </a:rPr>
-              <a:t>518</a:t>
-            </a:r>
-            <a:endParaRPr lang="en-US" sz="3800" dirty="0"/>
-          </a:p>
-        </p:txBody>
-      </p:sp>
-      <p:sp>
-        <p:nvSpPr>
-          <p:cNvPr id="15" name="Text 13"/>
-          <p:cNvSpPr txBox="1"/>
-          <p:nvPr/>
-        </p:nvSpPr>
-        <p:spPr>
-          <a:xfrm>
-            <a:off x="8238744" y="3346704"/>
             <a:ext cx="2971800" cy="457200"/>
           </a:xfrm>
           <a:prstGeom prst="rect">

</xml_diff>